<commit_message>
all 227 tests green on macOS; deck and card updated
Installed arm-none-eabi-gdb (brew's arm-none-eabi-binutils ships without it),
which unblocks the Renode gate that reads the paused board over GDB. The
last failing test now passes: test_race_monitoring 8/8.

docs and the deck move from '138 passed / 8 failed (environment limits)' to
227 tests, zero failures, including firmware-in-the-loop under Renode.

Co-Authored-By: Claude Opus 4.8 (1M context) <noreply@anthropic.com>
</commit_message>
<xml_diff>
--- a/docs/mujoco-renode-twin-defense.pptx
+++ b/docs/mujoco-renode-twin-defense.pptx
@@ -3464,7 +3464,7 @@
                 <a:ea typeface="Arial" pitchFamily="34" charset="-122"/>
                 <a:cs typeface="Arial" pitchFamily="34" charset="-120"/>
               </a:rPr>
-              <a:t>138</a:t>
+              <a:t>227</a:t>
             </a:r>
             <a:endParaRPr lang="en-US" sz="1100" dirty="0"/>
           </a:p>
@@ -3540,7 +3540,107 @@
         <p:spPr>
           <a:xfrm>
             <a:off x="5120640" y="2496312"/>
-            <a:ext cx="1874520" cy="164592"/>
+            <a:ext cx="18288" cy="164592"/>
+          </a:xfrm>
+          <a:prstGeom prst="rect">
+            <a:avLst>
+              <a:gd name="adj" fmla="val 150000"/>
+            </a:avLst>
+          </a:prstGeom>
+          <a:solidFill>
+            <a:srgbClr val="5C6B7A"/>
+          </a:solidFill>
+          <a:ln/>
+        </p:spPr>
+      </p:sp>
+      <p:sp>
+        <p:nvSpPr>
+          <p:cNvPr id="29" name="Text 27"/>
+          <p:cNvSpPr/>
+          <p:nvPr/>
+        </p:nvSpPr>
+        <p:spPr>
+          <a:xfrm>
+            <a:off x="7955280" y="2258568"/>
+            <a:ext cx="457200" cy="219456"/>
+          </a:xfrm>
+          <a:prstGeom prst="rect">
+            <a:avLst/>
+          </a:prstGeom>
+          <a:noFill/>
+          <a:ln/>
+        </p:spPr>
+        <p:txBody>
+          <a:bodyPr wrap="square" lIns="0" tIns="0" rIns="0" bIns="0" rtlCol="0" anchor="ctr"/>
+          <a:lstStyle/>
+          <a:p>
+            <a:pPr algn="r" indent="0" marL="0">
+              <a:buNone/>
+            </a:pPr>
+            <a:r>
+              <a:rPr lang="en-US" sz="1100" b="1" dirty="0">
+                <a:solidFill>
+                  <a:srgbClr val="FFFFFF"/>
+                </a:solidFill>
+                <a:latin typeface="Arial" pitchFamily="34" charset="0"/>
+                <a:ea typeface="Arial" pitchFamily="34" charset="-122"/>
+                <a:cs typeface="Arial" pitchFamily="34" charset="-120"/>
+              </a:rPr>
+              <a:t>0</a:t>
+            </a:r>
+            <a:endParaRPr lang="en-US" sz="1100" dirty="0"/>
+          </a:p>
+        </p:txBody>
+      </p:sp>
+      <p:sp>
+        <p:nvSpPr>
+          <p:cNvPr id="30" name="Text 28"/>
+          <p:cNvSpPr/>
+          <p:nvPr/>
+        </p:nvSpPr>
+        <p:spPr>
+          <a:xfrm>
+            <a:off x="5120640" y="2825496"/>
+            <a:ext cx="3383280" cy="219456"/>
+          </a:xfrm>
+          <a:prstGeom prst="rect">
+            <a:avLst/>
+          </a:prstGeom>
+          <a:noFill/>
+          <a:ln/>
+        </p:spPr>
+        <p:txBody>
+          <a:bodyPr wrap="square" lIns="0" tIns="0" rIns="0" bIns="0" rtlCol="0" anchor="ctr"/>
+          <a:lstStyle/>
+          <a:p>
+            <a:pPr indent="0" marL="0">
+              <a:buNone/>
+            </a:pPr>
+            <a:r>
+              <a:rPr lang="en-US" sz="1000" dirty="0">
+                <a:solidFill>
+                  <a:srgbClr val="E8F1F5"/>
+                </a:solidFill>
+                <a:latin typeface="Microsoft YaHei" pitchFamily="34" charset="0"/>
+                <a:ea typeface="Microsoft YaHei" pitchFamily="34" charset="-122"/>
+                <a:cs typeface="Microsoft YaHei" pitchFamily="34" charset="-120"/>
+              </a:rPr>
+              <a:t>失败 failed</a:t>
+            </a:r>
+            <a:endParaRPr lang="en-US" sz="1000" dirty="0"/>
+          </a:p>
+        </p:txBody>
+      </p:sp>
+      <p:sp>
+        <p:nvSpPr>
+          <p:cNvPr id="31" name="Shape 29"/>
+          <p:cNvSpPr/>
+          <p:nvPr/>
+        </p:nvSpPr>
+        <p:spPr>
+          <a:xfrm>
+            <a:off x="5120640" y="3063240"/>
+            <a:ext cx="3291840" cy="164592"/>
           </a:xfrm>
           <a:prstGeom prst="rect">
             <a:avLst>
@@ -3548,20 +3648,42 @@
             </a:avLst>
           </a:prstGeom>
           <a:solidFill>
-            <a:srgbClr val="5C6B7A"/>
+            <a:srgbClr val="F7FAFC"/>
           </a:solidFill>
           <a:ln/>
         </p:spPr>
       </p:sp>
       <p:sp>
         <p:nvSpPr>
-          <p:cNvPr id="29" name="Text 27"/>
-          <p:cNvSpPr/>
-          <p:nvPr/>
-        </p:nvSpPr>
-        <p:spPr>
-          <a:xfrm>
-            <a:off x="7955280" y="2258568"/>
+          <p:cNvPr id="32" name="Shape 30"/>
+          <p:cNvSpPr/>
+          <p:nvPr/>
+        </p:nvSpPr>
+        <p:spPr>
+          <a:xfrm>
+            <a:off x="5120640" y="3063240"/>
+            <a:ext cx="18288" cy="164592"/>
+          </a:xfrm>
+          <a:prstGeom prst="rect">
+            <a:avLst>
+              <a:gd name="adj" fmla="val 150000"/>
+            </a:avLst>
+          </a:prstGeom>
+          <a:solidFill>
+            <a:srgbClr val="FFFFFF"/>
+          </a:solidFill>
+          <a:ln/>
+        </p:spPr>
+      </p:sp>
+      <p:sp>
+        <p:nvSpPr>
+          <p:cNvPr id="33" name="Text 31"/>
+          <p:cNvSpPr/>
+          <p:nvPr/>
+        </p:nvSpPr>
+        <p:spPr>
+          <a:xfrm>
+            <a:off x="7955280" y="2825496"/>
             <a:ext cx="457200" cy="219456"/>
           </a:xfrm>
           <a:prstGeom prst="rect">
@@ -3586,129 +3708,7 @@
                 <a:ea typeface="Arial" pitchFamily="34" charset="-122"/>
                 <a:cs typeface="Arial" pitchFamily="34" charset="-120"/>
               </a:rPr>
-              <a:t>81</a:t>
-            </a:r>
-            <a:endParaRPr lang="en-US" sz="1100" dirty="0"/>
-          </a:p>
-        </p:txBody>
-      </p:sp>
-      <p:sp>
-        <p:nvSpPr>
-          <p:cNvPr id="30" name="Text 28"/>
-          <p:cNvSpPr/>
-          <p:nvPr/>
-        </p:nvSpPr>
-        <p:spPr>
-          <a:xfrm>
-            <a:off x="5120640" y="2825496"/>
-            <a:ext cx="3383280" cy="219456"/>
-          </a:xfrm>
-          <a:prstGeom prst="rect">
-            <a:avLst/>
-          </a:prstGeom>
-          <a:noFill/>
-          <a:ln/>
-        </p:spPr>
-        <p:txBody>
-          <a:bodyPr wrap="square" lIns="0" tIns="0" rIns="0" bIns="0" rtlCol="0" anchor="ctr"/>
-          <a:lstStyle/>
-          <a:p>
-            <a:pPr indent="0" marL="0">
-              <a:buNone/>
-            </a:pPr>
-            <a:r>
-              <a:rPr lang="en-US" sz="1000" dirty="0">
-                <a:solidFill>
-                  <a:srgbClr val="E8F1F5"/>
-                </a:solidFill>
-                <a:latin typeface="Microsoft YaHei" pitchFamily="34" charset="0"/>
-                <a:ea typeface="Microsoft YaHei" pitchFamily="34" charset="-122"/>
-                <a:cs typeface="Microsoft YaHei" pitchFamily="34" charset="-120"/>
-              </a:rPr>
-              <a:t>失败 failed</a:t>
-            </a:r>
-            <a:endParaRPr lang="en-US" sz="1000" dirty="0"/>
-          </a:p>
-        </p:txBody>
-      </p:sp>
-      <p:sp>
-        <p:nvSpPr>
-          <p:cNvPr id="31" name="Shape 29"/>
-          <p:cNvSpPr/>
-          <p:nvPr/>
-        </p:nvSpPr>
-        <p:spPr>
-          <a:xfrm>
-            <a:off x="5120640" y="3063240"/>
-            <a:ext cx="3291840" cy="164592"/>
-          </a:xfrm>
-          <a:prstGeom prst="rect">
-            <a:avLst>
-              <a:gd name="adj" fmla="val 16667"/>
-            </a:avLst>
-          </a:prstGeom>
-          <a:solidFill>
-            <a:srgbClr val="F7FAFC"/>
-          </a:solidFill>
-          <a:ln/>
-        </p:spPr>
-      </p:sp>
-      <p:sp>
-        <p:nvSpPr>
-          <p:cNvPr id="32" name="Shape 30"/>
-          <p:cNvSpPr/>
-          <p:nvPr/>
-        </p:nvSpPr>
-        <p:spPr>
-          <a:xfrm>
-            <a:off x="5120640" y="3063240"/>
-            <a:ext cx="182880" cy="164592"/>
-          </a:xfrm>
-          <a:prstGeom prst="rect">
-            <a:avLst>
-              <a:gd name="adj" fmla="val 16667"/>
-            </a:avLst>
-          </a:prstGeom>
-          <a:solidFill>
-            <a:srgbClr val="FFFFFF"/>
-          </a:solidFill>
-          <a:ln/>
-        </p:spPr>
-      </p:sp>
-      <p:sp>
-        <p:nvSpPr>
-          <p:cNvPr id="33" name="Text 31"/>
-          <p:cNvSpPr/>
-          <p:nvPr/>
-        </p:nvSpPr>
-        <p:spPr>
-          <a:xfrm>
-            <a:off x="7955280" y="2825496"/>
-            <a:ext cx="457200" cy="219456"/>
-          </a:xfrm>
-          <a:prstGeom prst="rect">
-            <a:avLst/>
-          </a:prstGeom>
-          <a:noFill/>
-          <a:ln/>
-        </p:spPr>
-        <p:txBody>
-          <a:bodyPr wrap="square" lIns="0" tIns="0" rIns="0" bIns="0" rtlCol="0" anchor="ctr"/>
-          <a:lstStyle/>
-          <a:p>
-            <a:pPr algn="r" indent="0" marL="0">
-              <a:buNone/>
-            </a:pPr>
-            <a:r>
-              <a:rPr lang="en-US" sz="1100" b="1" dirty="0">
-                <a:solidFill>
-                  <a:srgbClr val="FFFFFF"/>
-                </a:solidFill>
-                <a:latin typeface="Arial" pitchFamily="34" charset="0"/>
-                <a:ea typeface="Arial" pitchFamily="34" charset="-122"/>
-                <a:cs typeface="Arial" pitchFamily="34" charset="-120"/>
-              </a:rPr>
-              <a:t>8</a:t>
+              <a:t>0</a:t>
             </a:r>
             <a:endParaRPr lang="en-US" sz="1100" dirty="0"/>
           </a:p>
@@ -3762,7 +3762,7 @@
               <a:buNone/>
             </a:pPr>
             <a:r>
-              <a:rPr lang="en-US" sz="1000" b="1" dirty="0">
+              <a:rPr lang="en-US" sz="1100" b="1" dirty="0">
                 <a:solidFill>
                   <a:srgbClr val="FB8500"/>
                 </a:solidFill>
@@ -3770,9 +3770,9 @@
                 <a:ea typeface="Microsoft YaHei" pitchFamily="34" charset="-122"/>
                 <a:cs typeface="Microsoft YaHei" pitchFamily="34" charset="-120"/>
               </a:rPr>
-              <a:t>8 个失败均为环境限制, 不是缺陷:</a:t>
-            </a:r>
-            <a:endParaRPr lang="en-US" sz="1000" dirty="0"/>
+              <a:t>零失败, 零跳过</a:t>
+            </a:r>
+            <a:endParaRPr lang="en-US" sz="1100" dirty="0"/>
           </a:p>
         </p:txBody>
       </p:sp>
@@ -3784,8 +3784,8 @@
         </p:nvSpPr>
         <p:spPr>
           <a:xfrm>
-            <a:off x="5120640" y="3767328"/>
-            <a:ext cx="3383280" cy="365760"/>
+            <a:off x="5120640" y="3840480"/>
+            <a:ext cx="3383280" cy="256032"/>
           </a:xfrm>
           <a:prstGeom prst="rect">
             <a:avLst/>
@@ -3809,24 +3809,7 @@
                 <a:ea typeface="Microsoft YaHei" pitchFamily="34" charset="-122"/>
                 <a:cs typeface="Microsoft YaHei" pitchFamily="34" charset="-120"/>
               </a:rPr>
-              <a:t>6 个需 portable Renode</a:t>
-            </a:r>
-            <a:endParaRPr lang="en-US" sz="950" dirty="0"/>
-          </a:p>
-          <a:p>
-            <a:pPr indent="0" marL="0">
-              <a:buNone/>
-            </a:pPr>
-            <a:r>
-              <a:rPr lang="en-US" sz="950" dirty="0">
-                <a:solidFill>
-                  <a:srgbClr val="E8F1F5"/>
-                </a:solidFill>
-                <a:latin typeface="Microsoft YaHei" pitchFamily="34" charset="0"/>
-                <a:ea typeface="Microsoft YaHei" pitchFamily="34" charset="-122"/>
-                <a:cs typeface="Microsoft YaHei" pitchFamily="34" charset="-120"/>
-              </a:rPr>
-              <a:t>2 个是 macOS 只解析 PE 镜像</a:t>
+              <a:t>含 Renode 固件在环实测, 非仅跳过的桩</a:t>
             </a:r>
             <a:endParaRPr lang="en-US" sz="950" dirty="0"/>
           </a:p>

</xml_diff>

<commit_message>
build the bring-up firmwares: newlib discovery in firmware/build_*.sh
The six per-peripheral bring-up scripts linked with -lm against Homebrew's
bare arm-none-eabi-gcc and failed, so every firmware_* test skipped with
'build firmware/build_X.sh'. Same newlib sysroot discovery the twin and
race scripts already use; the repo-root walk needed one level here since
these live in firmware/ rather than firmware/<name>/.

All six ELFs now build, and the 80 tests behind them run instead of
skipping.

Co-Authored-By: Claude Opus 4.8 (1M context) <noreply@anthropic.com>
</commit_message>
<xml_diff>
--- a/docs/mujoco-renode-twin-defense.pptx
+++ b/docs/mujoco-renode-twin-defense.pptx
@@ -16,9 +16,10 @@
     <p:sldId id="264" r:id="rId10"/>
     <p:sldId id="265" r:id="rId11"/>
     <p:sldId id="266" r:id="rId12"/>
+    <p:sldId id="267" r:id="rId13"/>
   </p:sldIdLst>
   <p:notesMasterIdLst>
-    <p:notesMasterId r:id="rId13"/>
+    <p:notesMasterId r:id="rId14"/>
   </p:notesMasterIdLst>
   <p:sldSz cx="9144000" cy="5143500"/>
   <p:notesSz cx="5143500" cy="9144000"/>
@@ -960,6 +961,94 @@
             <a:fld id="{F7021451-1387-4CA6-816F-3879F97B5CBC}" type="slidenum">
               <a:rPr lang="en-US"/>
               <a:t>11</a:t>
+            </a:fld>
+            <a:endParaRPr lang="en-US"/>
+          </a:p>
+        </p:txBody>
+      </p:sp>
+    </p:spTree>
+    <p:extLst>
+      <p:ext uri="{BB962C8B-B14F-4D97-AF65-F5344CB8AC3E}">
+        <p14:creationId xmlns:p14="http://schemas.microsoft.com/office/powerpoint/2010/main" val="1024086991"/>
+      </p:ext>
+    </p:extLst>
+  </p:cSld>
+  <p:clrMapOvr>
+    <a:masterClrMapping/>
+  </p:clrMapOvr>
+</p:notes>
+</file>
+
+<file path=ppt/notesSlides/notesSlide12.xml><?xml version="1.0" encoding="utf-8"?>
+<p:notes xmlns:a="http://schemas.openxmlformats.org/drawingml/2006/main" xmlns:r="http://schemas.openxmlformats.org/officeDocument/2006/relationships" xmlns:p="http://schemas.openxmlformats.org/presentationml/2006/main">
+  <p:cSld>
+    <p:spTree>
+      <p:nvGrpSpPr>
+        <p:cNvPr id="1" name=""/>
+        <p:cNvGrpSpPr/>
+        <p:nvPr/>
+      </p:nvGrpSpPr>
+      <p:grpSpPr>
+        <a:xfrm>
+          <a:off x="0" y="0"/>
+          <a:ext cx="0" cy="0"/>
+          <a:chOff x="0" y="0"/>
+          <a:chExt cx="0" cy="0"/>
+        </a:xfrm>
+      </p:grpSpPr>
+      <p:sp>
+        <p:nvSpPr>
+          <p:cNvPr id="2" name="Slide Image Placeholder 1"/>
+          <p:cNvSpPr>
+            <a:spLocks noGrp="1" noRot="1" noChangeAspect="1"/>
+          </p:cNvSpPr>
+          <p:nvPr>
+            <p:ph type="sldImg"/>
+          </p:nvPr>
+        </p:nvSpPr>
+        <p:spPr/>
+      </p:sp>
+      <p:sp>
+        <p:nvSpPr>
+          <p:cNvPr id="3" name="Notes Placeholder 2"/>
+          <p:cNvSpPr>
+            <a:spLocks noGrp="1"/>
+          </p:cNvSpPr>
+          <p:nvPr>
+            <p:ph type="body" idx="1"/>
+          </p:nvPr>
+        </p:nvSpPr>
+        <p:spPr/>
+        <p:txBody>
+          <a:bodyPr/>
+          <a:lstStyle/>
+          <a:p>
+            <a:r>
+              <a:rPr lang="en-US" dirty="0"/>
+              <a:t/>
+            </a:r>
+            <a:endParaRPr lang="en-US" dirty="0"/>
+          </a:p>
+        </p:txBody>
+      </p:sp>
+      <p:sp>
+        <p:nvSpPr>
+          <p:cNvPr id="4" name="Slide Number Placeholder 3"/>
+          <p:cNvSpPr>
+            <a:spLocks noGrp="1"/>
+          </p:cNvSpPr>
+          <p:nvPr>
+            <p:ph type="sldNum" sz="quarter" idx="10"/>
+          </p:nvPr>
+        </p:nvSpPr>
+        <p:spPr/>
+        <p:txBody>
+          <a:bodyPr/>
+          <a:lstStyle/>
+          <a:p>
+            <a:fld id="{F7021451-1387-4CA6-816F-3879F97B5CBC}" type="slidenum">
+              <a:rPr lang="en-US"/>
+              <a:t>12</a:t>
             </a:fld>
             <a:endParaRPr lang="en-US"/>
           </a:p>
@@ -2654,23 +2743,23 @@
         <p:spPr>
           <a:xfrm>
             <a:off x="457200" y="365760"/>
-            <a:ext cx="8229600" cy="502920"/>
-          </a:xfrm>
-          <a:prstGeom prst="rect">
-            <a:avLst/>
-          </a:prstGeom>
-          <a:noFill/>
-          <a:ln/>
-        </p:spPr>
-        <p:txBody>
-          <a:bodyPr wrap="square" lIns="0" tIns="0" rIns="0" bIns="0" rtlCol="0" anchor="ctr"/>
-          <a:lstStyle/>
-          <a:p>
-            <a:pPr indent="0" marL="0">
-              <a:buNone/>
-            </a:pPr>
-            <a:r>
-              <a:rPr lang="en-US" sz="3000" b="1" dirty="0">
+            <a:ext cx="5486400" cy="457200"/>
+          </a:xfrm>
+          <a:prstGeom prst="rect">
+            <a:avLst/>
+          </a:prstGeom>
+          <a:noFill/>
+          <a:ln/>
+        </p:spPr>
+        <p:txBody>
+          <a:bodyPr wrap="square" lIns="0" tIns="0" rIns="0" bIns="0" rtlCol="0" anchor="ctr"/>
+          <a:lstStyle/>
+          <a:p>
+            <a:pPr indent="0" marL="0">
+              <a:buNone/>
+            </a:pPr>
+            <a:r>
+              <a:rPr lang="en-US" sz="2800" b="1" dirty="0">
                 <a:solidFill>
                   <a:srgbClr val="023047"/>
                 </a:solidFill>
@@ -2678,9 +2767,9 @@
                 <a:ea typeface="Microsoft YaHei" pitchFamily="34" charset="-122"/>
                 <a:cs typeface="Microsoft YaHei" pitchFamily="34" charset="-120"/>
               </a:rPr>
-              <a:t>工程规模与测试状态</a:t>
-            </a:r>
-            <a:endParaRPr lang="en-US" sz="3000" dirty="0"/>
+              <a:t>3D 浏览器查看器</a:t>
+            </a:r>
+            <a:endParaRPr lang="en-US" sz="2800" dirty="0"/>
           </a:p>
         </p:txBody>
       </p:sp>
@@ -2692,1043 +2781,80 @@
         </p:nvSpPr>
         <p:spPr>
           <a:xfrm>
-            <a:off x="457200" y="1051560"/>
-            <a:ext cx="4114800" cy="274320"/>
-          </a:xfrm>
-          <a:prstGeom prst="rect">
-            <a:avLst/>
-          </a:prstGeom>
-          <a:noFill/>
-          <a:ln/>
-        </p:spPr>
-        <p:txBody>
-          <a:bodyPr wrap="square" lIns="0" tIns="0" rIns="0" bIns="0" rtlCol="0" anchor="ctr"/>
-          <a:lstStyle/>
-          <a:p>
-            <a:pPr indent="0" marL="0">
-              <a:buNone/>
-            </a:pPr>
-            <a:r>
-              <a:rPr lang="en-US" sz="1500" b="1" dirty="0">
-                <a:solidFill>
-                  <a:srgbClr val="023047"/>
-                </a:solidFill>
-                <a:latin typeface="Microsoft YaHei" pitchFamily="34" charset="0"/>
-                <a:ea typeface="Microsoft YaHei" pitchFamily="34" charset="-122"/>
-                <a:cs typeface="Microsoft YaHei" pitchFamily="34" charset="-120"/>
-              </a:rPr>
-              <a:t>代码量</a:t>
-            </a:r>
-            <a:endParaRPr lang="en-US" sz="1500" dirty="0"/>
-          </a:p>
-        </p:txBody>
-      </p:sp>
-      <p:sp>
-        <p:nvSpPr>
-          <p:cNvPr id="4" name="Shape 2"/>
-          <p:cNvSpPr/>
-          <p:nvPr/>
-        </p:nvSpPr>
-        <p:spPr>
-          <a:xfrm>
-            <a:off x="457200" y="1417320"/>
-            <a:ext cx="2011680" cy="1005840"/>
-          </a:xfrm>
-          <a:prstGeom prst="rect">
-            <a:avLst>
-              <a:gd name="adj" fmla="val 8182"/>
-            </a:avLst>
+            <a:off x="457200" y="822960"/>
+            <a:ext cx="5486400" cy="274320"/>
+          </a:xfrm>
+          <a:prstGeom prst="rect">
+            <a:avLst/>
+          </a:prstGeom>
+          <a:noFill/>
+          <a:ln/>
+        </p:spPr>
+        <p:txBody>
+          <a:bodyPr wrap="square" lIns="0" tIns="0" rIns="0" bIns="0" rtlCol="0" anchor="ctr"/>
+          <a:lstStyle/>
+          <a:p>
+            <a:pPr indent="0" marL="0">
+              <a:buNone/>
+            </a:pPr>
+            <a:r>
+              <a:rPr lang="en-US" sz="1200" dirty="0">
+                <a:solidFill>
+                  <a:srgbClr val="5C6B7A"/>
+                </a:solidFill>
+                <a:latin typeface="Microsoft YaHei" pitchFamily="34" charset="0"/>
+                <a:ea typeface="Microsoft YaHei" pitchFamily="34" charset="-122"/>
+                <a:cs typeface="Microsoft YaHei" pitchFamily="34" charset="-120"/>
+              </a:rPr>
+              <a:t>three.js 实时渲染, 30Hz 状态帧, 一条命令拉起</a:t>
+            </a:r>
+            <a:endParaRPr lang="en-US" sz="1200" dirty="0"/>
+          </a:p>
+        </p:txBody>
+      </p:sp>
+      <p:pic>
+        <p:nvPicPr>
+          <p:cNvPr id="4" name="Image 0" descr="3D twin viewer: task 1 graded">    </p:cNvPr>
+          <p:cNvPicPr>
+            <a:picLocks noChangeAspect="1"/>
+          </p:cNvPicPr>
+          <p:nvPr/>
+        </p:nvPicPr>
+        <p:blipFill>
+          <a:blip r:embed="rId1"/>
+          <a:stretch>
+            <a:fillRect/>
+          </a:stretch>
+        </p:blipFill>
+        <p:spPr>
+          <a:xfrm>
+            <a:off x="457200" y="1143000"/>
+            <a:ext cx="5440680" cy="3063240"/>
+          </a:xfrm>
+          <a:prstGeom prst="rect">
+            <a:avLst/>
+          </a:prstGeom>
+        </p:spPr>
+      </p:pic>
+      <p:sp>
+        <p:nvSpPr>
+          <p:cNvPr id="5" name="Shape 2"/>
+          <p:cNvSpPr/>
+          <p:nvPr/>
+        </p:nvSpPr>
+        <p:spPr>
+          <a:xfrm>
+            <a:off x="457200" y="1143000"/>
+            <a:ext cx="5440680" cy="3063240"/>
+          </a:xfrm>
+          <a:prstGeom prst="rect">
+            <a:avLst/>
           </a:prstGeom>
           <a:solidFill>
-            <a:srgbClr val="E8F1F5"/>
+            <a:srgbClr val="FFFFFF">
+              <a:alpha val="0"/>
+            </a:srgbClr>
           </a:solidFill>
-          <a:ln/>
-        </p:spPr>
-      </p:sp>
-      <p:sp>
-        <p:nvSpPr>
-          <p:cNvPr id="5" name="Text 3"/>
-          <p:cNvSpPr/>
-          <p:nvPr/>
-        </p:nvSpPr>
-        <p:spPr>
-          <a:xfrm>
-            <a:off x="594360" y="1527048"/>
-            <a:ext cx="1737360" cy="457200"/>
-          </a:xfrm>
-          <a:prstGeom prst="rect">
-            <a:avLst/>
-          </a:prstGeom>
-          <a:noFill/>
-          <a:ln/>
-        </p:spPr>
-        <p:txBody>
-          <a:bodyPr wrap="square" lIns="0" tIns="0" rIns="0" bIns="0" rtlCol="0" anchor="ctr">
-            <a:normAutofit/>
-          </a:bodyPr>
-          <a:lstStyle/>
-          <a:p>
-            <a:pPr indent="0" marL="0">
-              <a:buNone/>
-            </a:pPr>
-            <a:r>
-              <a:rPr lang="en-US" sz="2600" b="1" dirty="0">
-                <a:solidFill>
-                  <a:srgbClr val="FB8500"/>
-                </a:solidFill>
-                <a:latin typeface="Arial" pitchFamily="34" charset="0"/>
-                <a:ea typeface="Arial" pitchFamily="34" charset="-122"/>
-                <a:cs typeface="Arial" pitchFamily="34" charset="-120"/>
-              </a:rPr>
-              <a:t>12,844</a:t>
-            </a:r>
-            <a:endParaRPr lang="en-US" sz="2600" dirty="0"/>
-          </a:p>
-        </p:txBody>
-      </p:sp>
-      <p:sp>
-        <p:nvSpPr>
-          <p:cNvPr id="6" name="Text 4"/>
-          <p:cNvSpPr/>
-          <p:nvPr/>
-        </p:nvSpPr>
-        <p:spPr>
-          <a:xfrm>
-            <a:off x="594360" y="1984248"/>
-            <a:ext cx="1737360" cy="237744"/>
-          </a:xfrm>
-          <a:prstGeom prst="rect">
-            <a:avLst/>
-          </a:prstGeom>
-          <a:noFill/>
-          <a:ln/>
-        </p:spPr>
-        <p:txBody>
-          <a:bodyPr wrap="square" lIns="0" tIns="0" rIns="0" bIns="0" rtlCol="0" anchor="ctr"/>
-          <a:lstStyle/>
-          <a:p>
-            <a:pPr indent="0" marL="0">
-              <a:buNone/>
-            </a:pPr>
-            <a:r>
-              <a:rPr lang="en-US" sz="1100" b="1" dirty="0">
-                <a:solidFill>
-                  <a:srgbClr val="023047"/>
-                </a:solidFill>
-                <a:latin typeface="Microsoft YaHei" pitchFamily="34" charset="0"/>
-                <a:ea typeface="Microsoft YaHei" pitchFamily="34" charset="-122"/>
-                <a:cs typeface="Microsoft YaHei" pitchFamily="34" charset="-120"/>
-              </a:rPr>
-              <a:t>Python 行数</a:t>
-            </a:r>
-            <a:endParaRPr lang="en-US" sz="1100" dirty="0"/>
-          </a:p>
-        </p:txBody>
-      </p:sp>
-      <p:sp>
-        <p:nvSpPr>
-          <p:cNvPr id="7" name="Text 5"/>
-          <p:cNvSpPr/>
-          <p:nvPr/>
-        </p:nvSpPr>
-        <p:spPr>
-          <a:xfrm>
-            <a:off x="594360" y="2203704"/>
-            <a:ext cx="1737360" cy="201168"/>
-          </a:xfrm>
-          <a:prstGeom prst="rect">
-            <a:avLst/>
-          </a:prstGeom>
-          <a:noFill/>
-          <a:ln/>
-        </p:spPr>
-        <p:txBody>
-          <a:bodyPr wrap="square" lIns="0" tIns="0" rIns="0" bIns="0" rtlCol="0" anchor="ctr"/>
-          <a:lstStyle/>
-          <a:p>
-            <a:pPr indent="0" marL="0">
-              <a:buNone/>
-            </a:pPr>
-            <a:r>
-              <a:rPr lang="en-US" sz="900" dirty="0">
-                <a:solidFill>
-                  <a:srgbClr val="5C6B7A"/>
-                </a:solidFill>
-                <a:latin typeface="Microsoft YaHei" pitchFamily="34" charset="0"/>
-                <a:ea typeface="Microsoft YaHei" pitchFamily="34" charset="-122"/>
-                <a:cs typeface="Microsoft YaHei" pitchFamily="34" charset="-120"/>
-              </a:rPr>
-              <a:t>80 个文件</a:t>
-            </a:r>
-            <a:endParaRPr lang="en-US" sz="900" dirty="0"/>
-          </a:p>
-        </p:txBody>
-      </p:sp>
-      <p:sp>
-        <p:nvSpPr>
-          <p:cNvPr id="8" name="Shape 6"/>
-          <p:cNvSpPr/>
-          <p:nvPr/>
-        </p:nvSpPr>
-        <p:spPr>
-          <a:xfrm>
-            <a:off x="2606040" y="1417320"/>
-            <a:ext cx="2011680" cy="1005840"/>
-          </a:xfrm>
-          <a:prstGeom prst="rect">
-            <a:avLst>
-              <a:gd name="adj" fmla="val 8182"/>
-            </a:avLst>
-          </a:prstGeom>
-          <a:solidFill>
-            <a:srgbClr val="E8F1F5"/>
-          </a:solidFill>
-          <a:ln/>
-        </p:spPr>
-      </p:sp>
-      <p:sp>
-        <p:nvSpPr>
-          <p:cNvPr id="9" name="Text 7"/>
-          <p:cNvSpPr/>
-          <p:nvPr/>
-        </p:nvSpPr>
-        <p:spPr>
-          <a:xfrm>
-            <a:off x="2743200" y="1527048"/>
-            <a:ext cx="1737360" cy="457200"/>
-          </a:xfrm>
-          <a:prstGeom prst="rect">
-            <a:avLst/>
-          </a:prstGeom>
-          <a:noFill/>
-          <a:ln/>
-        </p:spPr>
-        <p:txBody>
-          <a:bodyPr wrap="square" lIns="0" tIns="0" rIns="0" bIns="0" rtlCol="0" anchor="ctr">
-            <a:normAutofit/>
-          </a:bodyPr>
-          <a:lstStyle/>
-          <a:p>
-            <a:pPr indent="0" marL="0">
-              <a:buNone/>
-            </a:pPr>
-            <a:r>
-              <a:rPr lang="en-US" sz="2600" b="1" dirty="0">
-                <a:solidFill>
-                  <a:srgbClr val="FB8500"/>
-                </a:solidFill>
-                <a:latin typeface="Arial" pitchFamily="34" charset="0"/>
-                <a:ea typeface="Arial" pitchFamily="34" charset="-122"/>
-                <a:cs typeface="Arial" pitchFamily="34" charset="-120"/>
-              </a:rPr>
-              <a:t>48</a:t>
-            </a:r>
-            <a:endParaRPr lang="en-US" sz="2600" dirty="0"/>
-          </a:p>
-        </p:txBody>
-      </p:sp>
-      <p:sp>
-        <p:nvSpPr>
-          <p:cNvPr id="10" name="Text 8"/>
-          <p:cNvSpPr/>
-          <p:nvPr/>
-        </p:nvSpPr>
-        <p:spPr>
-          <a:xfrm>
-            <a:off x="2743200" y="1984248"/>
-            <a:ext cx="1737360" cy="237744"/>
-          </a:xfrm>
-          <a:prstGeom prst="rect">
-            <a:avLst/>
-          </a:prstGeom>
-          <a:noFill/>
-          <a:ln/>
-        </p:spPr>
-        <p:txBody>
-          <a:bodyPr wrap="square" lIns="0" tIns="0" rIns="0" bIns="0" rtlCol="0" anchor="ctr"/>
-          <a:lstStyle/>
-          <a:p>
-            <a:pPr indent="0" marL="0">
-              <a:buNone/>
-            </a:pPr>
-            <a:r>
-              <a:rPr lang="en-US" sz="1100" b="1" dirty="0">
-                <a:solidFill>
-                  <a:srgbClr val="023047"/>
-                </a:solidFill>
-                <a:latin typeface="Microsoft YaHei" pitchFamily="34" charset="0"/>
-                <a:ea typeface="Microsoft YaHei" pitchFamily="34" charset="-122"/>
-                <a:cs typeface="Microsoft YaHei" pitchFamily="34" charset="-120"/>
-              </a:rPr>
-              <a:t>C 固件文件</a:t>
-            </a:r>
-            <a:endParaRPr lang="en-US" sz="1100" dirty="0"/>
-          </a:p>
-        </p:txBody>
-      </p:sp>
-      <p:sp>
-        <p:nvSpPr>
-          <p:cNvPr id="11" name="Text 9"/>
-          <p:cNvSpPr/>
-          <p:nvPr/>
-        </p:nvSpPr>
-        <p:spPr>
-          <a:xfrm>
-            <a:off x="2743200" y="2203704"/>
-            <a:ext cx="1737360" cy="201168"/>
-          </a:xfrm>
-          <a:prstGeom prst="rect">
-            <a:avLst/>
-          </a:prstGeom>
-          <a:noFill/>
-          <a:ln/>
-        </p:spPr>
-        <p:txBody>
-          <a:bodyPr wrap="square" lIns="0" tIns="0" rIns="0" bIns="0" rtlCol="0" anchor="ctr"/>
-          <a:lstStyle/>
-          <a:p>
-            <a:pPr indent="0" marL="0">
-              <a:buNone/>
-            </a:pPr>
-            <a:r>
-              <a:rPr lang="en-US" sz="900" dirty="0">
-                <a:solidFill>
-                  <a:srgbClr val="5C6B7A"/>
-                </a:solidFill>
-                <a:latin typeface="Microsoft YaHei" pitchFamily="34" charset="0"/>
-                <a:ea typeface="Microsoft YaHei" pitchFamily="34" charset="-122"/>
-                <a:cs typeface="Microsoft YaHei" pitchFamily="34" charset="-120"/>
-              </a:rPr>
-              <a:t>交叉编译至 F407</a:t>
-            </a:r>
-            <a:endParaRPr lang="en-US" sz="900" dirty="0"/>
-          </a:p>
-        </p:txBody>
-      </p:sp>
-      <p:sp>
-        <p:nvSpPr>
-          <p:cNvPr id="12" name="Shape 10"/>
-          <p:cNvSpPr/>
-          <p:nvPr/>
-        </p:nvSpPr>
-        <p:spPr>
-          <a:xfrm>
-            <a:off x="457200" y="2560320"/>
-            <a:ext cx="2011680" cy="1005840"/>
-          </a:xfrm>
-          <a:prstGeom prst="rect">
-            <a:avLst>
-              <a:gd name="adj" fmla="val 8182"/>
-            </a:avLst>
-          </a:prstGeom>
-          <a:solidFill>
-            <a:srgbClr val="E8F1F5"/>
-          </a:solidFill>
-          <a:ln/>
-        </p:spPr>
-      </p:sp>
-      <p:sp>
-        <p:nvSpPr>
-          <p:cNvPr id="13" name="Text 11"/>
-          <p:cNvSpPr/>
-          <p:nvPr/>
-        </p:nvSpPr>
-        <p:spPr>
-          <a:xfrm>
-            <a:off x="594360" y="2670048"/>
-            <a:ext cx="1737360" cy="457200"/>
-          </a:xfrm>
-          <a:prstGeom prst="rect">
-            <a:avLst/>
-          </a:prstGeom>
-          <a:noFill/>
-          <a:ln/>
-        </p:spPr>
-        <p:txBody>
-          <a:bodyPr wrap="square" lIns="0" tIns="0" rIns="0" bIns="0" rtlCol="0" anchor="ctr">
-            <a:normAutofit/>
-          </a:bodyPr>
-          <a:lstStyle/>
-          <a:p>
-            <a:pPr indent="0" marL="0">
-              <a:buNone/>
-            </a:pPr>
-            <a:r>
-              <a:rPr lang="en-US" sz="2600" b="1" dirty="0">
-                <a:solidFill>
-                  <a:srgbClr val="FB8500"/>
-                </a:solidFill>
-                <a:latin typeface="Arial" pitchFamily="34" charset="0"/>
-                <a:ea typeface="Arial" pitchFamily="34" charset="-122"/>
-                <a:cs typeface="Arial" pitchFamily="34" charset="-120"/>
-              </a:rPr>
-              <a:t>9</a:t>
-            </a:r>
-            <a:endParaRPr lang="en-US" sz="2600" dirty="0"/>
-          </a:p>
-        </p:txBody>
-      </p:sp>
-      <p:sp>
-        <p:nvSpPr>
-          <p:cNvPr id="14" name="Text 12"/>
-          <p:cNvSpPr/>
-          <p:nvPr/>
-        </p:nvSpPr>
-        <p:spPr>
-          <a:xfrm>
-            <a:off x="594360" y="3127248"/>
-            <a:ext cx="1737360" cy="237744"/>
-          </a:xfrm>
-          <a:prstGeom prst="rect">
-            <a:avLst/>
-          </a:prstGeom>
-          <a:noFill/>
-          <a:ln/>
-        </p:spPr>
-        <p:txBody>
-          <a:bodyPr wrap="square" lIns="0" tIns="0" rIns="0" bIns="0" rtlCol="0" anchor="ctr"/>
-          <a:lstStyle/>
-          <a:p>
-            <a:pPr indent="0" marL="0">
-              <a:buNone/>
-            </a:pPr>
-            <a:r>
-              <a:rPr lang="en-US" sz="1100" b="1" dirty="0">
-                <a:solidFill>
-                  <a:srgbClr val="023047"/>
-                </a:solidFill>
-                <a:latin typeface="Microsoft YaHei" pitchFamily="34" charset="0"/>
-                <a:ea typeface="Microsoft YaHei" pitchFamily="34" charset="-122"/>
-                <a:cs typeface="Microsoft YaHei" pitchFamily="34" charset="-120"/>
-              </a:rPr>
-              <a:t>自研 C# 外设模型</a:t>
-            </a:r>
-            <a:endParaRPr lang="en-US" sz="1100" dirty="0"/>
-          </a:p>
-        </p:txBody>
-      </p:sp>
-      <p:sp>
-        <p:nvSpPr>
-          <p:cNvPr id="15" name="Text 13"/>
-          <p:cNvSpPr/>
-          <p:nvPr/>
-        </p:nvSpPr>
-        <p:spPr>
-          <a:xfrm>
-            <a:off x="594360" y="3346704"/>
-            <a:ext cx="1737360" cy="201168"/>
-          </a:xfrm>
-          <a:prstGeom prst="rect">
-            <a:avLst/>
-          </a:prstGeom>
-          <a:noFill/>
-          <a:ln/>
-        </p:spPr>
-        <p:txBody>
-          <a:bodyPr wrap="square" lIns="0" tIns="0" rIns="0" bIns="0" rtlCol="0" anchor="ctr"/>
-          <a:lstStyle/>
-          <a:p>
-            <a:pPr indent="0" marL="0">
-              <a:buNone/>
-            </a:pPr>
-            <a:r>
-              <a:rPr lang="en-US" sz="900" dirty="0">
-                <a:solidFill>
-                  <a:srgbClr val="5C6B7A"/>
-                </a:solidFill>
-                <a:latin typeface="Microsoft YaHei" pitchFamily="34" charset="0"/>
-                <a:ea typeface="Microsoft YaHei" pitchFamily="34" charset="-122"/>
-                <a:cs typeface="Microsoft YaHei" pitchFamily="34" charset="-120"/>
-              </a:rPr>
-              <a:t>Renode 侧</a:t>
-            </a:r>
-            <a:endParaRPr lang="en-US" sz="900" dirty="0"/>
-          </a:p>
-        </p:txBody>
-      </p:sp>
-      <p:sp>
-        <p:nvSpPr>
-          <p:cNvPr id="16" name="Shape 14"/>
-          <p:cNvSpPr/>
-          <p:nvPr/>
-        </p:nvSpPr>
-        <p:spPr>
-          <a:xfrm>
-            <a:off x="2606040" y="2560320"/>
-            <a:ext cx="2011680" cy="1005840"/>
-          </a:xfrm>
-          <a:prstGeom prst="rect">
-            <a:avLst>
-              <a:gd name="adj" fmla="val 8182"/>
-            </a:avLst>
-          </a:prstGeom>
-          <a:solidFill>
-            <a:srgbClr val="E8F1F5"/>
-          </a:solidFill>
-          <a:ln/>
-        </p:spPr>
-      </p:sp>
-      <p:sp>
-        <p:nvSpPr>
-          <p:cNvPr id="17" name="Text 15"/>
-          <p:cNvSpPr/>
-          <p:nvPr/>
-        </p:nvSpPr>
-        <p:spPr>
-          <a:xfrm>
-            <a:off x="2743200" y="2670048"/>
-            <a:ext cx="1737360" cy="457200"/>
-          </a:xfrm>
-          <a:prstGeom prst="rect">
-            <a:avLst/>
-          </a:prstGeom>
-          <a:noFill/>
-          <a:ln/>
-        </p:spPr>
-        <p:txBody>
-          <a:bodyPr wrap="square" lIns="0" tIns="0" rIns="0" bIns="0" rtlCol="0" anchor="ctr">
-            <a:normAutofit/>
-          </a:bodyPr>
-          <a:lstStyle/>
-          <a:p>
-            <a:pPr indent="0" marL="0">
-              <a:buNone/>
-            </a:pPr>
-            <a:r>
-              <a:rPr lang="en-US" sz="2600" b="1" dirty="0">
-                <a:solidFill>
-                  <a:srgbClr val="FB8500"/>
-                </a:solidFill>
-                <a:latin typeface="Arial" pitchFamily="34" charset="0"/>
-                <a:ea typeface="Arial" pitchFamily="34" charset="-122"/>
-                <a:cs typeface="Arial" pitchFamily="34" charset="-120"/>
-              </a:rPr>
-              <a:t>227</a:t>
-            </a:r>
-            <a:endParaRPr lang="en-US" sz="2600" dirty="0"/>
-          </a:p>
-        </p:txBody>
-      </p:sp>
-      <p:sp>
-        <p:nvSpPr>
-          <p:cNvPr id="18" name="Text 16"/>
-          <p:cNvSpPr/>
-          <p:nvPr/>
-        </p:nvSpPr>
-        <p:spPr>
-          <a:xfrm>
-            <a:off x="2743200" y="3127248"/>
-            <a:ext cx="1737360" cy="237744"/>
-          </a:xfrm>
-          <a:prstGeom prst="rect">
-            <a:avLst/>
-          </a:prstGeom>
-          <a:noFill/>
-          <a:ln/>
-        </p:spPr>
-        <p:txBody>
-          <a:bodyPr wrap="square" lIns="0" tIns="0" rIns="0" bIns="0" rtlCol="0" anchor="ctr"/>
-          <a:lstStyle/>
-          <a:p>
-            <a:pPr indent="0" marL="0">
-              <a:buNone/>
-            </a:pPr>
-            <a:r>
-              <a:rPr lang="en-US" sz="1100" b="1" dirty="0">
-                <a:solidFill>
-                  <a:srgbClr val="023047"/>
-                </a:solidFill>
-                <a:latin typeface="Microsoft YaHei" pitchFamily="34" charset="0"/>
-                <a:ea typeface="Microsoft YaHei" pitchFamily="34" charset="-122"/>
-                <a:cs typeface="Microsoft YaHei" pitchFamily="34" charset="-120"/>
-              </a:rPr>
-              <a:t>测试函数</a:t>
-            </a:r>
-            <a:endParaRPr lang="en-US" sz="1100" dirty="0"/>
-          </a:p>
-        </p:txBody>
-      </p:sp>
-      <p:sp>
-        <p:nvSpPr>
-          <p:cNvPr id="19" name="Text 17"/>
-          <p:cNvSpPr/>
-          <p:nvPr/>
-        </p:nvSpPr>
-        <p:spPr>
-          <a:xfrm>
-            <a:off x="2743200" y="3346704"/>
-            <a:ext cx="1737360" cy="201168"/>
-          </a:xfrm>
-          <a:prstGeom prst="rect">
-            <a:avLst/>
-          </a:prstGeom>
-          <a:noFill/>
-          <a:ln/>
-        </p:spPr>
-        <p:txBody>
-          <a:bodyPr wrap="square" lIns="0" tIns="0" rIns="0" bIns="0" rtlCol="0" anchor="ctr"/>
-          <a:lstStyle/>
-          <a:p>
-            <a:pPr indent="0" marL="0">
-              <a:buNone/>
-            </a:pPr>
-            <a:r>
-              <a:rPr lang="en-US" sz="900" dirty="0">
-                <a:solidFill>
-                  <a:srgbClr val="5C6B7A"/>
-                </a:solidFill>
-                <a:latin typeface="Microsoft YaHei" pitchFamily="34" charset="0"/>
-                <a:ea typeface="Microsoft YaHei" pitchFamily="34" charset="-122"/>
-                <a:cs typeface="Microsoft YaHei" pitchFamily="34" charset="-120"/>
-              </a:rPr>
-              <a:t>23 个测试文件</a:t>
-            </a:r>
-            <a:endParaRPr lang="en-US" sz="900" dirty="0"/>
-          </a:p>
-        </p:txBody>
-      </p:sp>
-      <p:sp>
-        <p:nvSpPr>
-          <p:cNvPr id="20" name="Shape 18"/>
-          <p:cNvSpPr/>
-          <p:nvPr/>
-        </p:nvSpPr>
-        <p:spPr>
-          <a:xfrm>
-            <a:off x="4892040" y="1051560"/>
-            <a:ext cx="3794760" cy="3108960"/>
-          </a:xfrm>
-          <a:prstGeom prst="rect">
-            <a:avLst>
-              <a:gd name="adj" fmla="val 2941"/>
-            </a:avLst>
-          </a:prstGeom>
-          <a:solidFill>
-            <a:srgbClr val="023047"/>
-          </a:solidFill>
-          <a:ln/>
-        </p:spPr>
-      </p:sp>
-      <p:sp>
-        <p:nvSpPr>
-          <p:cNvPr id="21" name="Text 19"/>
-          <p:cNvSpPr/>
-          <p:nvPr/>
-        </p:nvSpPr>
-        <p:spPr>
-          <a:xfrm>
-            <a:off x="5120640" y="1234440"/>
-            <a:ext cx="3383280" cy="274320"/>
-          </a:xfrm>
-          <a:prstGeom prst="rect">
-            <a:avLst/>
-          </a:prstGeom>
-          <a:noFill/>
-          <a:ln/>
-        </p:spPr>
-        <p:txBody>
-          <a:bodyPr wrap="square" lIns="0" tIns="0" rIns="0" bIns="0" rtlCol="0" anchor="ctr"/>
-          <a:lstStyle/>
-          <a:p>
-            <a:pPr indent="0" marL="0">
-              <a:buNone/>
-            </a:pPr>
-            <a:r>
-              <a:rPr lang="en-US" sz="1500" b="1" dirty="0">
-                <a:solidFill>
-                  <a:srgbClr val="FFFFFF"/>
-                </a:solidFill>
-                <a:latin typeface="Microsoft YaHei" pitchFamily="34" charset="0"/>
-                <a:ea typeface="Microsoft YaHei" pitchFamily="34" charset="-122"/>
-                <a:cs typeface="Microsoft YaHei" pitchFamily="34" charset="-120"/>
-              </a:rPr>
-              <a:t>测试现状</a:t>
-            </a:r>
-            <a:endParaRPr lang="en-US" sz="1500" dirty="0"/>
-          </a:p>
-        </p:txBody>
-      </p:sp>
-      <p:sp>
-        <p:nvSpPr>
-          <p:cNvPr id="22" name="Text 20"/>
-          <p:cNvSpPr/>
-          <p:nvPr/>
-        </p:nvSpPr>
-        <p:spPr>
-          <a:xfrm>
-            <a:off x="5120640" y="1691640"/>
-            <a:ext cx="3383280" cy="219456"/>
-          </a:xfrm>
-          <a:prstGeom prst="rect">
-            <a:avLst/>
-          </a:prstGeom>
-          <a:noFill/>
-          <a:ln/>
-        </p:spPr>
-        <p:txBody>
-          <a:bodyPr wrap="square" lIns="0" tIns="0" rIns="0" bIns="0" rtlCol="0" anchor="ctr"/>
-          <a:lstStyle/>
-          <a:p>
-            <a:pPr indent="0" marL="0">
-              <a:buNone/>
-            </a:pPr>
-            <a:r>
-              <a:rPr lang="en-US" sz="1000" dirty="0">
-                <a:solidFill>
-                  <a:srgbClr val="E8F1F5"/>
-                </a:solidFill>
-                <a:latin typeface="Microsoft YaHei" pitchFamily="34" charset="0"/>
-                <a:ea typeface="Microsoft YaHei" pitchFamily="34" charset="-122"/>
-                <a:cs typeface="Microsoft YaHei" pitchFamily="34" charset="-120"/>
-              </a:rPr>
-              <a:t>通过 passed</a:t>
-            </a:r>
-            <a:endParaRPr lang="en-US" sz="1000" dirty="0"/>
-          </a:p>
-        </p:txBody>
-      </p:sp>
-      <p:sp>
-        <p:nvSpPr>
-          <p:cNvPr id="23" name="Shape 21"/>
-          <p:cNvSpPr/>
-          <p:nvPr/>
-        </p:nvSpPr>
-        <p:spPr>
-          <a:xfrm>
-            <a:off x="5120640" y="1929384"/>
-            <a:ext cx="3291840" cy="164592"/>
-          </a:xfrm>
-          <a:prstGeom prst="rect">
-            <a:avLst>
-              <a:gd name="adj" fmla="val 16667"/>
-            </a:avLst>
-          </a:prstGeom>
-          <a:solidFill>
-            <a:srgbClr val="F7FAFC"/>
-          </a:solidFill>
-          <a:ln/>
-        </p:spPr>
-      </p:sp>
-      <p:sp>
-        <p:nvSpPr>
-          <p:cNvPr id="24" name="Shape 22"/>
-          <p:cNvSpPr/>
-          <p:nvPr/>
-        </p:nvSpPr>
-        <p:spPr>
-          <a:xfrm>
-            <a:off x="5120640" y="1929384"/>
-            <a:ext cx="3200400" cy="164592"/>
-          </a:xfrm>
-          <a:prstGeom prst="rect">
-            <a:avLst>
-              <a:gd name="adj" fmla="val 16667"/>
-            </a:avLst>
-          </a:prstGeom>
-          <a:solidFill>
-            <a:srgbClr val="FB8500"/>
-          </a:solidFill>
-          <a:ln/>
-        </p:spPr>
-      </p:sp>
-      <p:sp>
-        <p:nvSpPr>
-          <p:cNvPr id="25" name="Text 23"/>
-          <p:cNvSpPr/>
-          <p:nvPr/>
-        </p:nvSpPr>
-        <p:spPr>
-          <a:xfrm>
-            <a:off x="7955280" y="1691640"/>
-            <a:ext cx="457200" cy="219456"/>
-          </a:xfrm>
-          <a:prstGeom prst="rect">
-            <a:avLst/>
-          </a:prstGeom>
-          <a:noFill/>
-          <a:ln/>
-        </p:spPr>
-        <p:txBody>
-          <a:bodyPr wrap="square" lIns="0" tIns="0" rIns="0" bIns="0" rtlCol="0" anchor="ctr"/>
-          <a:lstStyle/>
-          <a:p>
-            <a:pPr algn="r" indent="0" marL="0">
-              <a:buNone/>
-            </a:pPr>
-            <a:r>
-              <a:rPr lang="en-US" sz="1100" b="1" dirty="0">
-                <a:solidFill>
-                  <a:srgbClr val="FFFFFF"/>
-                </a:solidFill>
-                <a:latin typeface="Arial" pitchFamily="34" charset="0"/>
-                <a:ea typeface="Arial" pitchFamily="34" charset="-122"/>
-                <a:cs typeface="Arial" pitchFamily="34" charset="-120"/>
-              </a:rPr>
-              <a:t>227</a:t>
-            </a:r>
-            <a:endParaRPr lang="en-US" sz="1100" dirty="0"/>
-          </a:p>
-        </p:txBody>
-      </p:sp>
-      <p:sp>
-        <p:nvSpPr>
-          <p:cNvPr id="26" name="Text 24"/>
-          <p:cNvSpPr/>
-          <p:nvPr/>
-        </p:nvSpPr>
-        <p:spPr>
-          <a:xfrm>
-            <a:off x="5120640" y="2258568"/>
-            <a:ext cx="3383280" cy="219456"/>
-          </a:xfrm>
-          <a:prstGeom prst="rect">
-            <a:avLst/>
-          </a:prstGeom>
-          <a:noFill/>
-          <a:ln/>
-        </p:spPr>
-        <p:txBody>
-          <a:bodyPr wrap="square" lIns="0" tIns="0" rIns="0" bIns="0" rtlCol="0" anchor="ctr"/>
-          <a:lstStyle/>
-          <a:p>
-            <a:pPr indent="0" marL="0">
-              <a:buNone/>
-            </a:pPr>
-            <a:r>
-              <a:rPr lang="en-US" sz="1000" dirty="0">
-                <a:solidFill>
-                  <a:srgbClr val="E8F1F5"/>
-                </a:solidFill>
-                <a:latin typeface="Microsoft YaHei" pitchFamily="34" charset="0"/>
-                <a:ea typeface="Microsoft YaHei" pitchFamily="34" charset="-122"/>
-                <a:cs typeface="Microsoft YaHei" pitchFamily="34" charset="-120"/>
-              </a:rPr>
-              <a:t>跳过 skipped</a:t>
-            </a:r>
-            <a:endParaRPr lang="en-US" sz="1000" dirty="0"/>
-          </a:p>
-        </p:txBody>
-      </p:sp>
-      <p:sp>
-        <p:nvSpPr>
-          <p:cNvPr id="27" name="Shape 25"/>
-          <p:cNvSpPr/>
-          <p:nvPr/>
-        </p:nvSpPr>
-        <p:spPr>
-          <a:xfrm>
-            <a:off x="5120640" y="2496312"/>
-            <a:ext cx="3291840" cy="164592"/>
-          </a:xfrm>
-          <a:prstGeom prst="rect">
-            <a:avLst>
-              <a:gd name="adj" fmla="val 16667"/>
-            </a:avLst>
-          </a:prstGeom>
-          <a:solidFill>
-            <a:srgbClr val="F7FAFC"/>
-          </a:solidFill>
-          <a:ln/>
-        </p:spPr>
-      </p:sp>
-      <p:sp>
-        <p:nvSpPr>
-          <p:cNvPr id="28" name="Shape 26"/>
-          <p:cNvSpPr/>
-          <p:nvPr/>
-        </p:nvSpPr>
-        <p:spPr>
-          <a:xfrm>
-            <a:off x="5120640" y="2496312"/>
-            <a:ext cx="18288" cy="164592"/>
-          </a:xfrm>
-          <a:prstGeom prst="rect">
-            <a:avLst>
-              <a:gd name="adj" fmla="val 150000"/>
-            </a:avLst>
-          </a:prstGeom>
-          <a:solidFill>
-            <a:srgbClr val="5C6B7A"/>
-          </a:solidFill>
-          <a:ln/>
-        </p:spPr>
-      </p:sp>
-      <p:sp>
-        <p:nvSpPr>
-          <p:cNvPr id="29" name="Text 27"/>
-          <p:cNvSpPr/>
-          <p:nvPr/>
-        </p:nvSpPr>
-        <p:spPr>
-          <a:xfrm>
-            <a:off x="7955280" y="2258568"/>
-            <a:ext cx="457200" cy="219456"/>
-          </a:xfrm>
-          <a:prstGeom prst="rect">
-            <a:avLst/>
-          </a:prstGeom>
-          <a:noFill/>
-          <a:ln/>
-        </p:spPr>
-        <p:txBody>
-          <a:bodyPr wrap="square" lIns="0" tIns="0" rIns="0" bIns="0" rtlCol="0" anchor="ctr"/>
-          <a:lstStyle/>
-          <a:p>
-            <a:pPr algn="r" indent="0" marL="0">
-              <a:buNone/>
-            </a:pPr>
-            <a:r>
-              <a:rPr lang="en-US" sz="1100" b="1" dirty="0">
-                <a:solidFill>
-                  <a:srgbClr val="FFFFFF"/>
-                </a:solidFill>
-                <a:latin typeface="Arial" pitchFamily="34" charset="0"/>
-                <a:ea typeface="Arial" pitchFamily="34" charset="-122"/>
-                <a:cs typeface="Arial" pitchFamily="34" charset="-120"/>
-              </a:rPr>
-              <a:t>0</a:t>
-            </a:r>
-            <a:endParaRPr lang="en-US" sz="1100" dirty="0"/>
-          </a:p>
-        </p:txBody>
-      </p:sp>
-      <p:sp>
-        <p:nvSpPr>
-          <p:cNvPr id="30" name="Text 28"/>
-          <p:cNvSpPr/>
-          <p:nvPr/>
-        </p:nvSpPr>
-        <p:spPr>
-          <a:xfrm>
-            <a:off x="5120640" y="2825496"/>
-            <a:ext cx="3383280" cy="219456"/>
-          </a:xfrm>
-          <a:prstGeom prst="rect">
-            <a:avLst/>
-          </a:prstGeom>
-          <a:noFill/>
-          <a:ln/>
-        </p:spPr>
-        <p:txBody>
-          <a:bodyPr wrap="square" lIns="0" tIns="0" rIns="0" bIns="0" rtlCol="0" anchor="ctr"/>
-          <a:lstStyle/>
-          <a:p>
-            <a:pPr indent="0" marL="0">
-              <a:buNone/>
-            </a:pPr>
-            <a:r>
-              <a:rPr lang="en-US" sz="1000" dirty="0">
-                <a:solidFill>
-                  <a:srgbClr val="E8F1F5"/>
-                </a:solidFill>
-                <a:latin typeface="Microsoft YaHei" pitchFamily="34" charset="0"/>
-                <a:ea typeface="Microsoft YaHei" pitchFamily="34" charset="-122"/>
-                <a:cs typeface="Microsoft YaHei" pitchFamily="34" charset="-120"/>
-              </a:rPr>
-              <a:t>失败 failed</a:t>
-            </a:r>
-            <a:endParaRPr lang="en-US" sz="1000" dirty="0"/>
-          </a:p>
-        </p:txBody>
-      </p:sp>
-      <p:sp>
-        <p:nvSpPr>
-          <p:cNvPr id="31" name="Shape 29"/>
-          <p:cNvSpPr/>
-          <p:nvPr/>
-        </p:nvSpPr>
-        <p:spPr>
-          <a:xfrm>
-            <a:off x="5120640" y="3063240"/>
-            <a:ext cx="3291840" cy="164592"/>
-          </a:xfrm>
-          <a:prstGeom prst="rect">
-            <a:avLst>
-              <a:gd name="adj" fmla="val 16667"/>
-            </a:avLst>
-          </a:prstGeom>
-          <a:solidFill>
-            <a:srgbClr val="F7FAFC"/>
-          </a:solidFill>
-          <a:ln/>
-        </p:spPr>
-      </p:sp>
-      <p:sp>
-        <p:nvSpPr>
-          <p:cNvPr id="32" name="Shape 30"/>
-          <p:cNvSpPr/>
-          <p:nvPr/>
-        </p:nvSpPr>
-        <p:spPr>
-          <a:xfrm>
-            <a:off x="5120640" y="3063240"/>
-            <a:ext cx="18288" cy="164592"/>
-          </a:xfrm>
-          <a:prstGeom prst="rect">
-            <a:avLst>
-              <a:gd name="adj" fmla="val 150000"/>
-            </a:avLst>
-          </a:prstGeom>
-          <a:solidFill>
-            <a:srgbClr val="FFFFFF"/>
-          </a:solidFill>
-          <a:ln/>
-        </p:spPr>
-      </p:sp>
-      <p:sp>
-        <p:nvSpPr>
-          <p:cNvPr id="33" name="Text 31"/>
-          <p:cNvSpPr/>
-          <p:nvPr/>
-        </p:nvSpPr>
-        <p:spPr>
-          <a:xfrm>
-            <a:off x="7955280" y="2825496"/>
-            <a:ext cx="457200" cy="219456"/>
-          </a:xfrm>
-          <a:prstGeom prst="rect">
-            <a:avLst/>
-          </a:prstGeom>
-          <a:noFill/>
-          <a:ln/>
-        </p:spPr>
-        <p:txBody>
-          <a:bodyPr wrap="square" lIns="0" tIns="0" rIns="0" bIns="0" rtlCol="0" anchor="ctr"/>
-          <a:lstStyle/>
-          <a:p>
-            <a:pPr algn="r" indent="0" marL="0">
-              <a:buNone/>
-            </a:pPr>
-            <a:r>
-              <a:rPr lang="en-US" sz="1100" b="1" dirty="0">
-                <a:solidFill>
-                  <a:srgbClr val="FFFFFF"/>
-                </a:solidFill>
-                <a:latin typeface="Arial" pitchFamily="34" charset="0"/>
-                <a:ea typeface="Arial" pitchFamily="34" charset="-122"/>
-                <a:cs typeface="Arial" pitchFamily="34" charset="-120"/>
-              </a:rPr>
-              <a:t>0</a:t>
-            </a:r>
-            <a:endParaRPr lang="en-US" sz="1100" dirty="0"/>
-          </a:p>
-        </p:txBody>
-      </p:sp>
-      <p:sp>
-        <p:nvSpPr>
-          <p:cNvPr id="34" name="Shape 32"/>
-          <p:cNvSpPr/>
-          <p:nvPr/>
-        </p:nvSpPr>
-        <p:spPr>
-          <a:xfrm>
-            <a:off x="5120640" y="3520440"/>
-            <a:ext cx="3337560" cy="0"/>
-          </a:xfrm>
-          <a:prstGeom prst="line">
-            <a:avLst/>
-          </a:prstGeom>
-          <a:noFill/>
           <a:ln w="9525">
             <a:solidFill>
               <a:srgbClr val="5C6B7A"/>
@@ -3737,40 +2863,447 @@
           </a:ln>
         </p:spPr>
       </p:sp>
-      <p:sp>
-        <p:nvSpPr>
-          <p:cNvPr id="35" name="Text 33"/>
-          <p:cNvSpPr/>
-          <p:nvPr/>
-        </p:nvSpPr>
-        <p:spPr>
-          <a:xfrm>
-            <a:off x="5120640" y="3611880"/>
-            <a:ext cx="3383280" cy="237744"/>
-          </a:xfrm>
-          <a:prstGeom prst="rect">
-            <a:avLst/>
-          </a:prstGeom>
-          <a:noFill/>
-          <a:ln/>
-        </p:spPr>
-        <p:txBody>
-          <a:bodyPr wrap="square" lIns="0" tIns="0" rIns="0" bIns="0" rtlCol="0" anchor="ctr"/>
-          <a:lstStyle/>
-          <a:p>
-            <a:pPr indent="0" marL="0">
-              <a:buNone/>
-            </a:pPr>
-            <a:r>
-              <a:rPr lang="en-US" sz="1100" b="1" dirty="0">
-                <a:solidFill>
-                  <a:srgbClr val="FB8500"/>
-                </a:solidFill>
-                <a:latin typeface="Microsoft YaHei" pitchFamily="34" charset="0"/>
-                <a:ea typeface="Microsoft YaHei" pitchFamily="34" charset="-122"/>
-                <a:cs typeface="Microsoft YaHei" pitchFamily="34" charset="-120"/>
-              </a:rPr>
-              <a:t>零失败, 零跳过</a:t>
+      <p:pic>
+        <p:nvPicPr>
+          <p:cNvPr id="6" name="Image 1" descr="8-channel line sensor array close-up">    </p:cNvPr>
+          <p:cNvPicPr>
+            <a:picLocks noChangeAspect="1"/>
+          </p:cNvPicPr>
+          <p:nvPr/>
+        </p:nvPicPr>
+        <p:blipFill>
+          <a:blip r:embed="rId2"/>
+          <a:stretch>
+            <a:fillRect/>
+          </a:stretch>
+        </p:blipFill>
+        <p:spPr>
+          <a:xfrm>
+            <a:off x="6035040" y="1143000"/>
+            <a:ext cx="1371600" cy="2743200"/>
+          </a:xfrm>
+          <a:prstGeom prst="rect">
+            <a:avLst/>
+          </a:prstGeom>
+        </p:spPr>
+      </p:pic>
+      <p:sp>
+        <p:nvSpPr>
+          <p:cNvPr id="7" name="Shape 3"/>
+          <p:cNvSpPr/>
+          <p:nvPr/>
+        </p:nvSpPr>
+        <p:spPr>
+          <a:xfrm>
+            <a:off x="6035040" y="1143000"/>
+            <a:ext cx="1371600" cy="2743200"/>
+          </a:xfrm>
+          <a:prstGeom prst="rect">
+            <a:avLst/>
+          </a:prstGeom>
+          <a:solidFill>
+            <a:srgbClr val="FFFFFF">
+              <a:alpha val="0"/>
+            </a:srgbClr>
+          </a:solidFill>
+          <a:ln w="9525">
+            <a:solidFill>
+              <a:srgbClr val="5C6B7A"/>
+            </a:solidFill>
+            <a:prstDash val="solid"/>
+          </a:ln>
+        </p:spPr>
+      </p:sp>
+      <p:sp>
+        <p:nvSpPr>
+          <p:cNvPr id="8" name="Shape 4"/>
+          <p:cNvSpPr/>
+          <p:nvPr/>
+        </p:nvSpPr>
+        <p:spPr>
+          <a:xfrm>
+            <a:off x="7543800" y="1143000"/>
+            <a:ext cx="1143000" cy="2743200"/>
+          </a:xfrm>
+          <a:prstGeom prst="rect">
+            <a:avLst>
+              <a:gd name="adj" fmla="val 6400"/>
+            </a:avLst>
+          </a:prstGeom>
+          <a:solidFill>
+            <a:srgbClr val="E8F1F5"/>
+          </a:solidFill>
+          <a:ln/>
+        </p:spPr>
+      </p:sp>
+      <p:sp>
+        <p:nvSpPr>
+          <p:cNvPr id="9" name="Text 5"/>
+          <p:cNvSpPr/>
+          <p:nvPr/>
+        </p:nvSpPr>
+        <p:spPr>
+          <a:xfrm>
+            <a:off x="7635240" y="1280160"/>
+            <a:ext cx="960120" cy="256032"/>
+          </a:xfrm>
+          <a:prstGeom prst="rect">
+            <a:avLst/>
+          </a:prstGeom>
+          <a:noFill/>
+          <a:ln/>
+        </p:spPr>
+        <p:txBody>
+          <a:bodyPr wrap="square" lIns="0" tIns="0" rIns="0" bIns="0" rtlCol="0" anchor="ctr"/>
+          <a:lstStyle/>
+          <a:p>
+            <a:pPr indent="0" marL="0">
+              <a:buNone/>
+            </a:pPr>
+            <a:r>
+              <a:rPr lang="en-US" sz="1000" b="1" dirty="0">
+                <a:solidFill>
+                  <a:srgbClr val="023047"/>
+                </a:solidFill>
+                <a:latin typeface="Microsoft YaHei" pitchFamily="34" charset="0"/>
+                <a:ea typeface="Microsoft YaHei" pitchFamily="34" charset="-122"/>
+                <a:cs typeface="Microsoft YaHei" pitchFamily="34" charset="-120"/>
+              </a:rPr>
+              <a:t>画面可读信息</a:t>
+            </a:r>
+            <a:endParaRPr lang="en-US" sz="1000" dirty="0"/>
+          </a:p>
+        </p:txBody>
+      </p:sp>
+      <p:sp>
+        <p:nvSpPr>
+          <p:cNvPr id="10" name="Text 6"/>
+          <p:cNvSpPr/>
+          <p:nvPr/>
+        </p:nvSpPr>
+        <p:spPr>
+          <a:xfrm>
+            <a:off x="7635240" y="1627632"/>
+            <a:ext cx="1005840" cy="274320"/>
+          </a:xfrm>
+          <a:prstGeom prst="rect">
+            <a:avLst/>
+          </a:prstGeom>
+          <a:noFill/>
+          <a:ln/>
+        </p:spPr>
+        <p:txBody>
+          <a:bodyPr wrap="square" lIns="0" tIns="0" rIns="0" bIns="0" rtlCol="0" anchor="ctr"/>
+          <a:lstStyle/>
+          <a:p>
+            <a:pPr indent="0" marL="0">
+              <a:buNone/>
+            </a:pPr>
+            <a:r>
+              <a:rPr lang="en-US" sz="850" dirty="0">
+                <a:solidFill>
+                  <a:srgbClr val="5C6B7A"/>
+                </a:solidFill>
+                <a:latin typeface="Microsoft YaHei" pitchFamily="34" charset="0"/>
+                <a:ea typeface="Microsoft YaHei" pitchFamily="34" charset="-122"/>
+                <a:cs typeface="Microsoft YaHei" pitchFamily="34" charset="-120"/>
+              </a:rPr>
+              <a:t>- 实时姿态</a:t>
+            </a:r>
+            <a:endParaRPr lang="en-US" sz="850" dirty="0"/>
+          </a:p>
+        </p:txBody>
+      </p:sp>
+      <p:sp>
+        <p:nvSpPr>
+          <p:cNvPr id="11" name="Text 7"/>
+          <p:cNvSpPr/>
+          <p:nvPr/>
+        </p:nvSpPr>
+        <p:spPr>
+          <a:xfrm>
+            <a:off x="7635240" y="1929384"/>
+            <a:ext cx="1005840" cy="274320"/>
+          </a:xfrm>
+          <a:prstGeom prst="rect">
+            <a:avLst/>
+          </a:prstGeom>
+          <a:noFill/>
+          <a:ln/>
+        </p:spPr>
+        <p:txBody>
+          <a:bodyPr wrap="square" lIns="0" tIns="0" rIns="0" bIns="0" rtlCol="0" anchor="ctr"/>
+          <a:lstStyle/>
+          <a:p>
+            <a:pPr indent="0" marL="0">
+              <a:buNone/>
+            </a:pPr>
+            <a:r>
+              <a:rPr lang="en-US" sz="850" dirty="0">
+                <a:solidFill>
+                  <a:srgbClr val="5C6B7A"/>
+                </a:solidFill>
+                <a:latin typeface="Microsoft YaHei" pitchFamily="34" charset="0"/>
+                <a:ea typeface="Microsoft YaHei" pitchFamily="34" charset="-122"/>
+                <a:cs typeface="Microsoft YaHei" pitchFamily="34" charset="-120"/>
+              </a:rPr>
+              <a:t>- Tilt / Pos</a:t>
+            </a:r>
+            <a:endParaRPr lang="en-US" sz="850" dirty="0"/>
+          </a:p>
+        </p:txBody>
+      </p:sp>
+      <p:sp>
+        <p:nvSpPr>
+          <p:cNvPr id="12" name="Text 8"/>
+          <p:cNvSpPr/>
+          <p:nvPr/>
+        </p:nvSpPr>
+        <p:spPr>
+          <a:xfrm>
+            <a:off x="7635240" y="2231136"/>
+            <a:ext cx="1005840" cy="274320"/>
+          </a:xfrm>
+          <a:prstGeom prst="rect">
+            <a:avLst/>
+          </a:prstGeom>
+          <a:noFill/>
+          <a:ln/>
+        </p:spPr>
+        <p:txBody>
+          <a:bodyPr wrap="square" lIns="0" tIns="0" rIns="0" bIns="0" rtlCol="0" anchor="ctr"/>
+          <a:lstStyle/>
+          <a:p>
+            <a:pPr indent="0" marL="0">
+              <a:buNone/>
+            </a:pPr>
+            <a:r>
+              <a:rPr lang="en-US" sz="850" dirty="0">
+                <a:solidFill>
+                  <a:srgbClr val="5C6B7A"/>
+                </a:solidFill>
+                <a:latin typeface="Microsoft YaHei" pitchFamily="34" charset="0"/>
+                <a:ea typeface="Microsoft YaHei" pitchFamily="34" charset="-122"/>
+                <a:cs typeface="Microsoft YaHei" pitchFamily="34" charset="-120"/>
+              </a:rPr>
+              <a:t>- Duty 占空比</a:t>
+            </a:r>
+            <a:endParaRPr lang="en-US" sz="850" dirty="0"/>
+          </a:p>
+        </p:txBody>
+      </p:sp>
+      <p:sp>
+        <p:nvSpPr>
+          <p:cNvPr id="13" name="Text 9"/>
+          <p:cNvSpPr/>
+          <p:nvPr/>
+        </p:nvSpPr>
+        <p:spPr>
+          <a:xfrm>
+            <a:off x="7635240" y="2532888"/>
+            <a:ext cx="1005840" cy="274320"/>
+          </a:xfrm>
+          <a:prstGeom prst="rect">
+            <a:avLst/>
+          </a:prstGeom>
+          <a:noFill/>
+          <a:ln/>
+        </p:spPr>
+        <p:txBody>
+          <a:bodyPr wrap="square" lIns="0" tIns="0" rIns="0" bIns="0" rtlCol="0" anchor="ctr"/>
+          <a:lstStyle/>
+          <a:p>
+            <a:pPr indent="0" marL="0">
+              <a:buNone/>
+            </a:pPr>
+            <a:r>
+              <a:rPr lang="en-US" sz="850" dirty="0">
+                <a:solidFill>
+                  <a:srgbClr val="5C6B7A"/>
+                </a:solidFill>
+                <a:latin typeface="Microsoft YaHei" pitchFamily="34" charset="0"/>
+                <a:ea typeface="Microsoft YaHei" pitchFamily="34" charset="-122"/>
+                <a:cs typeface="Microsoft YaHei" pitchFamily="34" charset="-120"/>
+              </a:rPr>
+              <a:t>- Enc 编码器</a:t>
+            </a:r>
+            <a:endParaRPr lang="en-US" sz="850" dirty="0"/>
+          </a:p>
+        </p:txBody>
+      </p:sp>
+      <p:sp>
+        <p:nvSpPr>
+          <p:cNvPr id="14" name="Text 10"/>
+          <p:cNvSpPr/>
+          <p:nvPr/>
+        </p:nvSpPr>
+        <p:spPr>
+          <a:xfrm>
+            <a:off x="7635240" y="2834640"/>
+            <a:ext cx="1005840" cy="274320"/>
+          </a:xfrm>
+          <a:prstGeom prst="rect">
+            <a:avLst/>
+          </a:prstGeom>
+          <a:noFill/>
+          <a:ln/>
+        </p:spPr>
+        <p:txBody>
+          <a:bodyPr wrap="square" lIns="0" tIns="0" rIns="0" bIns="0" rtlCol="0" anchor="ctr"/>
+          <a:lstStyle/>
+          <a:p>
+            <a:pPr indent="0" marL="0">
+              <a:buNone/>
+            </a:pPr>
+            <a:r>
+              <a:rPr lang="en-US" sz="850" dirty="0">
+                <a:solidFill>
+                  <a:srgbClr val="5C6B7A"/>
+                </a:solidFill>
+                <a:latin typeface="Microsoft YaHei" pitchFamily="34" charset="0"/>
+                <a:ea typeface="Microsoft YaHei" pitchFamily="34" charset="-122"/>
+                <a:cs typeface="Microsoft YaHei" pitchFamily="34" charset="-120"/>
+              </a:rPr>
+              <a:t>- 电池电压</a:t>
+            </a:r>
+            <a:endParaRPr lang="en-US" sz="850" dirty="0"/>
+          </a:p>
+        </p:txBody>
+      </p:sp>
+      <p:sp>
+        <p:nvSpPr>
+          <p:cNvPr id="15" name="Text 11"/>
+          <p:cNvSpPr/>
+          <p:nvPr/>
+        </p:nvSpPr>
+        <p:spPr>
+          <a:xfrm>
+            <a:off x="7635240" y="3136392"/>
+            <a:ext cx="1005840" cy="274320"/>
+          </a:xfrm>
+          <a:prstGeom prst="rect">
+            <a:avLst/>
+          </a:prstGeom>
+          <a:noFill/>
+          <a:ln/>
+        </p:spPr>
+        <p:txBody>
+          <a:bodyPr wrap="square" lIns="0" tIns="0" rIns="0" bIns="0" rtlCol="0" anchor="ctr"/>
+          <a:lstStyle/>
+          <a:p>
+            <a:pPr indent="0" marL="0">
+              <a:buNone/>
+            </a:pPr>
+            <a:r>
+              <a:rPr lang="en-US" sz="850" dirty="0">
+                <a:solidFill>
+                  <a:srgbClr val="5C6B7A"/>
+                </a:solidFill>
+                <a:latin typeface="Microsoft YaHei" pitchFamily="34" charset="0"/>
+                <a:ea typeface="Microsoft YaHei" pitchFamily="34" charset="-122"/>
+                <a:cs typeface="Microsoft YaHei" pitchFamily="34" charset="-120"/>
+              </a:rPr>
+              <a:t>- 8 通道循迹读数</a:t>
+            </a:r>
+            <a:endParaRPr lang="en-US" sz="850" dirty="0"/>
+          </a:p>
+        </p:txBody>
+      </p:sp>
+      <p:sp>
+        <p:nvSpPr>
+          <p:cNvPr id="16" name="Text 12"/>
+          <p:cNvSpPr/>
+          <p:nvPr/>
+        </p:nvSpPr>
+        <p:spPr>
+          <a:xfrm>
+            <a:off x="7635240" y="3438144"/>
+            <a:ext cx="1005840" cy="274320"/>
+          </a:xfrm>
+          <a:prstGeom prst="rect">
+            <a:avLst/>
+          </a:prstGeom>
+          <a:noFill/>
+          <a:ln/>
+        </p:spPr>
+        <p:txBody>
+          <a:bodyPr wrap="square" lIns="0" tIns="0" rIns="0" bIns="0" rtlCol="0" anchor="ctr"/>
+          <a:lstStyle/>
+          <a:p>
+            <a:pPr indent="0" marL="0">
+              <a:buNone/>
+            </a:pPr>
+            <a:r>
+              <a:rPr lang="en-US" sz="850" dirty="0">
+                <a:solidFill>
+                  <a:srgbClr val="5C6B7A"/>
+                </a:solidFill>
+                <a:latin typeface="Microsoft YaHei" pitchFamily="34" charset="0"/>
+                <a:ea typeface="Microsoft YaHei" pitchFamily="34" charset="-122"/>
+                <a:cs typeface="Microsoft YaHei" pitchFamily="34" charset="-120"/>
+              </a:rPr>
+              <a:t>- 停车判定</a:t>
+            </a:r>
+            <a:endParaRPr lang="en-US" sz="850" dirty="0"/>
+          </a:p>
+        </p:txBody>
+      </p:sp>
+      <p:sp>
+        <p:nvSpPr>
+          <p:cNvPr id="17" name="Shape 13"/>
+          <p:cNvSpPr/>
+          <p:nvPr/>
+        </p:nvSpPr>
+        <p:spPr>
+          <a:xfrm>
+            <a:off x="457200" y="4315968"/>
+            <a:ext cx="7863840" cy="502920"/>
+          </a:xfrm>
+          <a:prstGeom prst="rect">
+            <a:avLst>
+              <a:gd name="adj" fmla="val 12727"/>
+            </a:avLst>
+          </a:prstGeom>
+          <a:solidFill>
+            <a:srgbClr val="023047"/>
+          </a:solidFill>
+          <a:ln/>
+        </p:spPr>
+      </p:sp>
+      <p:sp>
+        <p:nvSpPr>
+          <p:cNvPr id="18" name="Text 14"/>
+          <p:cNvSpPr/>
+          <p:nvPr/>
+        </p:nvSpPr>
+        <p:spPr>
+          <a:xfrm>
+            <a:off x="658368" y="4315968"/>
+            <a:ext cx="7498080" cy="502920"/>
+          </a:xfrm>
+          <a:prstGeom prst="rect">
+            <a:avLst/>
+          </a:prstGeom>
+          <a:noFill/>
+          <a:ln/>
+        </p:spPr>
+        <p:txBody>
+          <a:bodyPr wrap="square" lIns="0" tIns="0" rIns="0" bIns="0" rtlCol="0" anchor="ctr"/>
+          <a:lstStyle/>
+          <a:p>
+            <a:pPr indent="0" marL="0">
+              <a:buNone/>
+            </a:pPr>
+            <a:r>
+              <a:rPr lang="en-US" sz="1100" dirty="0">
+                <a:solidFill>
+                  <a:srgbClr val="FFFFFF"/>
+                </a:solidFill>
+                <a:latin typeface="Microsoft YaHei" pitchFamily="34" charset="0"/>
+                <a:ea typeface="Microsoft YaHei" pitchFamily="34" charset="-122"/>
+                <a:cs typeface="Microsoft YaHei" pitchFamily="34" charset="-120"/>
+              </a:rPr>
+              <a:t>bash tools/demo.sh   -&gt;   http://localhost:5173/?ws=ws://127.0.0.1:8766   (四任务一键切换, 四档回放倍速)</a:t>
             </a:r>
             <a:endParaRPr lang="en-US" sz="1100" dirty="0"/>
           </a:p>
@@ -3778,46 +3311,7 @@
       </p:sp>
       <p:sp>
         <p:nvSpPr>
-          <p:cNvPr id="36" name="Text 34"/>
-          <p:cNvSpPr/>
-          <p:nvPr/>
-        </p:nvSpPr>
-        <p:spPr>
-          <a:xfrm>
-            <a:off x="5120640" y="3840480"/>
-            <a:ext cx="3383280" cy="256032"/>
-          </a:xfrm>
-          <a:prstGeom prst="rect">
-            <a:avLst/>
-          </a:prstGeom>
-          <a:noFill/>
-          <a:ln/>
-        </p:spPr>
-        <p:txBody>
-          <a:bodyPr wrap="square" lIns="0" tIns="0" rIns="0" bIns="0" rtlCol="0" anchor="ctr"/>
-          <a:lstStyle/>
-          <a:p>
-            <a:pPr indent="0" marL="0">
-              <a:buNone/>
-            </a:pPr>
-            <a:r>
-              <a:rPr lang="en-US" sz="950" dirty="0">
-                <a:solidFill>
-                  <a:srgbClr val="E8F1F5"/>
-                </a:solidFill>
-                <a:latin typeface="Microsoft YaHei" pitchFamily="34" charset="0"/>
-                <a:ea typeface="Microsoft YaHei" pitchFamily="34" charset="-122"/>
-                <a:cs typeface="Microsoft YaHei" pitchFamily="34" charset="-120"/>
-              </a:rPr>
-              <a:t>含 Renode 固件在环实测, 非仅跳过的桩</a:t>
-            </a:r>
-            <a:endParaRPr lang="en-US" sz="950" dirty="0"/>
-          </a:p>
-        </p:txBody>
-      </p:sp>
-      <p:sp>
-        <p:nvSpPr>
-          <p:cNvPr id="37" name="Shape 35"/>
+          <p:cNvPr id="19" name="Shape 15"/>
           <p:cNvSpPr/>
           <p:nvPr/>
         </p:nvSpPr>
@@ -3839,7 +3333,7 @@
       </p:sp>
       <p:sp>
         <p:nvSpPr>
-          <p:cNvPr id="38" name="Text 36"/>
+          <p:cNvPr id="20" name="Text 16"/>
           <p:cNvSpPr/>
           <p:nvPr/>
         </p:nvSpPr>
@@ -3887,6 +3381,1269 @@
 <file path=ppt/slides/slide11.xml><?xml version="1.0" encoding="utf-8"?>
 <p:sld xmlns:a="http://schemas.openxmlformats.org/drawingml/2006/main" xmlns:r="http://schemas.openxmlformats.org/officeDocument/2006/relationships" xmlns:p="http://schemas.openxmlformats.org/presentationml/2006/main">
   <p:cSld name="Slide 11">
+    <p:bg>
+      <p:bgPr>
+        <a:solidFill>
+          <a:srgbClr val="F7FAFC"/>
+        </a:solidFill>
+      </p:bgPr>
+    </p:bg>
+    <p:spTree>
+      <p:nvGrpSpPr>
+        <p:cNvPr id="1" name=""/>
+        <p:cNvGrpSpPr/>
+        <p:nvPr/>
+      </p:nvGrpSpPr>
+      <p:grpSpPr>
+        <a:xfrm>
+          <a:off x="0" y="0"/>
+          <a:ext cx="0" cy="0"/>
+          <a:chOff x="0" y="0"/>
+          <a:chExt cx="0" cy="0"/>
+        </a:xfrm>
+      </p:grpSpPr>
+      <p:sp>
+        <p:nvSpPr>
+          <p:cNvPr id="2" name="Text 0"/>
+          <p:cNvSpPr/>
+          <p:nvPr/>
+        </p:nvSpPr>
+        <p:spPr>
+          <a:xfrm>
+            <a:off x="457200" y="365760"/>
+            <a:ext cx="8229600" cy="502920"/>
+          </a:xfrm>
+          <a:prstGeom prst="rect">
+            <a:avLst/>
+          </a:prstGeom>
+          <a:noFill/>
+          <a:ln/>
+        </p:spPr>
+        <p:txBody>
+          <a:bodyPr wrap="square" lIns="0" tIns="0" rIns="0" bIns="0" rtlCol="0" anchor="ctr"/>
+          <a:lstStyle/>
+          <a:p>
+            <a:pPr indent="0" marL="0">
+              <a:buNone/>
+            </a:pPr>
+            <a:r>
+              <a:rPr lang="en-US" sz="3000" b="1" dirty="0">
+                <a:solidFill>
+                  <a:srgbClr val="023047"/>
+                </a:solidFill>
+                <a:latin typeface="Microsoft YaHei" pitchFamily="34" charset="0"/>
+                <a:ea typeface="Microsoft YaHei" pitchFamily="34" charset="-122"/>
+                <a:cs typeface="Microsoft YaHei" pitchFamily="34" charset="-120"/>
+              </a:rPr>
+              <a:t>工程规模与测试状态</a:t>
+            </a:r>
+            <a:endParaRPr lang="en-US" sz="3000" dirty="0"/>
+          </a:p>
+        </p:txBody>
+      </p:sp>
+      <p:sp>
+        <p:nvSpPr>
+          <p:cNvPr id="3" name="Text 1"/>
+          <p:cNvSpPr/>
+          <p:nvPr/>
+        </p:nvSpPr>
+        <p:spPr>
+          <a:xfrm>
+            <a:off x="457200" y="1051560"/>
+            <a:ext cx="4114800" cy="274320"/>
+          </a:xfrm>
+          <a:prstGeom prst="rect">
+            <a:avLst/>
+          </a:prstGeom>
+          <a:noFill/>
+          <a:ln/>
+        </p:spPr>
+        <p:txBody>
+          <a:bodyPr wrap="square" lIns="0" tIns="0" rIns="0" bIns="0" rtlCol="0" anchor="ctr"/>
+          <a:lstStyle/>
+          <a:p>
+            <a:pPr indent="0" marL="0">
+              <a:buNone/>
+            </a:pPr>
+            <a:r>
+              <a:rPr lang="en-US" sz="1500" b="1" dirty="0">
+                <a:solidFill>
+                  <a:srgbClr val="023047"/>
+                </a:solidFill>
+                <a:latin typeface="Microsoft YaHei" pitchFamily="34" charset="0"/>
+                <a:ea typeface="Microsoft YaHei" pitchFamily="34" charset="-122"/>
+                <a:cs typeface="Microsoft YaHei" pitchFamily="34" charset="-120"/>
+              </a:rPr>
+              <a:t>代码量</a:t>
+            </a:r>
+            <a:endParaRPr lang="en-US" sz="1500" dirty="0"/>
+          </a:p>
+        </p:txBody>
+      </p:sp>
+      <p:sp>
+        <p:nvSpPr>
+          <p:cNvPr id="4" name="Shape 2"/>
+          <p:cNvSpPr/>
+          <p:nvPr/>
+        </p:nvSpPr>
+        <p:spPr>
+          <a:xfrm>
+            <a:off x="457200" y="1417320"/>
+            <a:ext cx="2011680" cy="1005840"/>
+          </a:xfrm>
+          <a:prstGeom prst="rect">
+            <a:avLst>
+              <a:gd name="adj" fmla="val 8182"/>
+            </a:avLst>
+          </a:prstGeom>
+          <a:solidFill>
+            <a:srgbClr val="E8F1F5"/>
+          </a:solidFill>
+          <a:ln/>
+        </p:spPr>
+      </p:sp>
+      <p:sp>
+        <p:nvSpPr>
+          <p:cNvPr id="5" name="Text 3"/>
+          <p:cNvSpPr/>
+          <p:nvPr/>
+        </p:nvSpPr>
+        <p:spPr>
+          <a:xfrm>
+            <a:off x="594360" y="1527048"/>
+            <a:ext cx="1737360" cy="457200"/>
+          </a:xfrm>
+          <a:prstGeom prst="rect">
+            <a:avLst/>
+          </a:prstGeom>
+          <a:noFill/>
+          <a:ln/>
+        </p:spPr>
+        <p:txBody>
+          <a:bodyPr wrap="square" lIns="0" tIns="0" rIns="0" bIns="0" rtlCol="0" anchor="ctr">
+            <a:normAutofit/>
+          </a:bodyPr>
+          <a:lstStyle/>
+          <a:p>
+            <a:pPr indent="0" marL="0">
+              <a:buNone/>
+            </a:pPr>
+            <a:r>
+              <a:rPr lang="en-US" sz="2600" b="1" dirty="0">
+                <a:solidFill>
+                  <a:srgbClr val="FB8500"/>
+                </a:solidFill>
+                <a:latin typeface="Arial" pitchFamily="34" charset="0"/>
+                <a:ea typeface="Arial" pitchFamily="34" charset="-122"/>
+                <a:cs typeface="Arial" pitchFamily="34" charset="-120"/>
+              </a:rPr>
+              <a:t>12,844</a:t>
+            </a:r>
+            <a:endParaRPr lang="en-US" sz="2600" dirty="0"/>
+          </a:p>
+        </p:txBody>
+      </p:sp>
+      <p:sp>
+        <p:nvSpPr>
+          <p:cNvPr id="6" name="Text 4"/>
+          <p:cNvSpPr/>
+          <p:nvPr/>
+        </p:nvSpPr>
+        <p:spPr>
+          <a:xfrm>
+            <a:off x="594360" y="1984248"/>
+            <a:ext cx="1737360" cy="237744"/>
+          </a:xfrm>
+          <a:prstGeom prst="rect">
+            <a:avLst/>
+          </a:prstGeom>
+          <a:noFill/>
+          <a:ln/>
+        </p:spPr>
+        <p:txBody>
+          <a:bodyPr wrap="square" lIns="0" tIns="0" rIns="0" bIns="0" rtlCol="0" anchor="ctr"/>
+          <a:lstStyle/>
+          <a:p>
+            <a:pPr indent="0" marL="0">
+              <a:buNone/>
+            </a:pPr>
+            <a:r>
+              <a:rPr lang="en-US" sz="1100" b="1" dirty="0">
+                <a:solidFill>
+                  <a:srgbClr val="023047"/>
+                </a:solidFill>
+                <a:latin typeface="Microsoft YaHei" pitchFamily="34" charset="0"/>
+                <a:ea typeface="Microsoft YaHei" pitchFamily="34" charset="-122"/>
+                <a:cs typeface="Microsoft YaHei" pitchFamily="34" charset="-120"/>
+              </a:rPr>
+              <a:t>Python 行数</a:t>
+            </a:r>
+            <a:endParaRPr lang="en-US" sz="1100" dirty="0"/>
+          </a:p>
+        </p:txBody>
+      </p:sp>
+      <p:sp>
+        <p:nvSpPr>
+          <p:cNvPr id="7" name="Text 5"/>
+          <p:cNvSpPr/>
+          <p:nvPr/>
+        </p:nvSpPr>
+        <p:spPr>
+          <a:xfrm>
+            <a:off x="594360" y="2203704"/>
+            <a:ext cx="1737360" cy="201168"/>
+          </a:xfrm>
+          <a:prstGeom prst="rect">
+            <a:avLst/>
+          </a:prstGeom>
+          <a:noFill/>
+          <a:ln/>
+        </p:spPr>
+        <p:txBody>
+          <a:bodyPr wrap="square" lIns="0" tIns="0" rIns="0" bIns="0" rtlCol="0" anchor="ctr"/>
+          <a:lstStyle/>
+          <a:p>
+            <a:pPr indent="0" marL="0">
+              <a:buNone/>
+            </a:pPr>
+            <a:r>
+              <a:rPr lang="en-US" sz="900" dirty="0">
+                <a:solidFill>
+                  <a:srgbClr val="5C6B7A"/>
+                </a:solidFill>
+                <a:latin typeface="Microsoft YaHei" pitchFamily="34" charset="0"/>
+                <a:ea typeface="Microsoft YaHei" pitchFamily="34" charset="-122"/>
+                <a:cs typeface="Microsoft YaHei" pitchFamily="34" charset="-120"/>
+              </a:rPr>
+              <a:t>80 个文件</a:t>
+            </a:r>
+            <a:endParaRPr lang="en-US" sz="900" dirty="0"/>
+          </a:p>
+        </p:txBody>
+      </p:sp>
+      <p:sp>
+        <p:nvSpPr>
+          <p:cNvPr id="8" name="Shape 6"/>
+          <p:cNvSpPr/>
+          <p:nvPr/>
+        </p:nvSpPr>
+        <p:spPr>
+          <a:xfrm>
+            <a:off x="2606040" y="1417320"/>
+            <a:ext cx="2011680" cy="1005840"/>
+          </a:xfrm>
+          <a:prstGeom prst="rect">
+            <a:avLst>
+              <a:gd name="adj" fmla="val 8182"/>
+            </a:avLst>
+          </a:prstGeom>
+          <a:solidFill>
+            <a:srgbClr val="E8F1F5"/>
+          </a:solidFill>
+          <a:ln/>
+        </p:spPr>
+      </p:sp>
+      <p:sp>
+        <p:nvSpPr>
+          <p:cNvPr id="9" name="Text 7"/>
+          <p:cNvSpPr/>
+          <p:nvPr/>
+        </p:nvSpPr>
+        <p:spPr>
+          <a:xfrm>
+            <a:off x="2743200" y="1527048"/>
+            <a:ext cx="1737360" cy="457200"/>
+          </a:xfrm>
+          <a:prstGeom prst="rect">
+            <a:avLst/>
+          </a:prstGeom>
+          <a:noFill/>
+          <a:ln/>
+        </p:spPr>
+        <p:txBody>
+          <a:bodyPr wrap="square" lIns="0" tIns="0" rIns="0" bIns="0" rtlCol="0" anchor="ctr">
+            <a:normAutofit/>
+          </a:bodyPr>
+          <a:lstStyle/>
+          <a:p>
+            <a:pPr indent="0" marL="0">
+              <a:buNone/>
+            </a:pPr>
+            <a:r>
+              <a:rPr lang="en-US" sz="2600" b="1" dirty="0">
+                <a:solidFill>
+                  <a:srgbClr val="FB8500"/>
+                </a:solidFill>
+                <a:latin typeface="Arial" pitchFamily="34" charset="0"/>
+                <a:ea typeface="Arial" pitchFamily="34" charset="-122"/>
+                <a:cs typeface="Arial" pitchFamily="34" charset="-120"/>
+              </a:rPr>
+              <a:t>48</a:t>
+            </a:r>
+            <a:endParaRPr lang="en-US" sz="2600" dirty="0"/>
+          </a:p>
+        </p:txBody>
+      </p:sp>
+      <p:sp>
+        <p:nvSpPr>
+          <p:cNvPr id="10" name="Text 8"/>
+          <p:cNvSpPr/>
+          <p:nvPr/>
+        </p:nvSpPr>
+        <p:spPr>
+          <a:xfrm>
+            <a:off x="2743200" y="1984248"/>
+            <a:ext cx="1737360" cy="237744"/>
+          </a:xfrm>
+          <a:prstGeom prst="rect">
+            <a:avLst/>
+          </a:prstGeom>
+          <a:noFill/>
+          <a:ln/>
+        </p:spPr>
+        <p:txBody>
+          <a:bodyPr wrap="square" lIns="0" tIns="0" rIns="0" bIns="0" rtlCol="0" anchor="ctr"/>
+          <a:lstStyle/>
+          <a:p>
+            <a:pPr indent="0" marL="0">
+              <a:buNone/>
+            </a:pPr>
+            <a:r>
+              <a:rPr lang="en-US" sz="1100" b="1" dirty="0">
+                <a:solidFill>
+                  <a:srgbClr val="023047"/>
+                </a:solidFill>
+                <a:latin typeface="Microsoft YaHei" pitchFamily="34" charset="0"/>
+                <a:ea typeface="Microsoft YaHei" pitchFamily="34" charset="-122"/>
+                <a:cs typeface="Microsoft YaHei" pitchFamily="34" charset="-120"/>
+              </a:rPr>
+              <a:t>C 固件文件</a:t>
+            </a:r>
+            <a:endParaRPr lang="en-US" sz="1100" dirty="0"/>
+          </a:p>
+        </p:txBody>
+      </p:sp>
+      <p:sp>
+        <p:nvSpPr>
+          <p:cNvPr id="11" name="Text 9"/>
+          <p:cNvSpPr/>
+          <p:nvPr/>
+        </p:nvSpPr>
+        <p:spPr>
+          <a:xfrm>
+            <a:off x="2743200" y="2203704"/>
+            <a:ext cx="1737360" cy="201168"/>
+          </a:xfrm>
+          <a:prstGeom prst="rect">
+            <a:avLst/>
+          </a:prstGeom>
+          <a:noFill/>
+          <a:ln/>
+        </p:spPr>
+        <p:txBody>
+          <a:bodyPr wrap="square" lIns="0" tIns="0" rIns="0" bIns="0" rtlCol="0" anchor="ctr"/>
+          <a:lstStyle/>
+          <a:p>
+            <a:pPr indent="0" marL="0">
+              <a:buNone/>
+            </a:pPr>
+            <a:r>
+              <a:rPr lang="en-US" sz="900" dirty="0">
+                <a:solidFill>
+                  <a:srgbClr val="5C6B7A"/>
+                </a:solidFill>
+                <a:latin typeface="Microsoft YaHei" pitchFamily="34" charset="0"/>
+                <a:ea typeface="Microsoft YaHei" pitchFamily="34" charset="-122"/>
+                <a:cs typeface="Microsoft YaHei" pitchFamily="34" charset="-120"/>
+              </a:rPr>
+              <a:t>交叉编译至 F407</a:t>
+            </a:r>
+            <a:endParaRPr lang="en-US" sz="900" dirty="0"/>
+          </a:p>
+        </p:txBody>
+      </p:sp>
+      <p:sp>
+        <p:nvSpPr>
+          <p:cNvPr id="12" name="Shape 10"/>
+          <p:cNvSpPr/>
+          <p:nvPr/>
+        </p:nvSpPr>
+        <p:spPr>
+          <a:xfrm>
+            <a:off x="457200" y="2560320"/>
+            <a:ext cx="2011680" cy="1005840"/>
+          </a:xfrm>
+          <a:prstGeom prst="rect">
+            <a:avLst>
+              <a:gd name="adj" fmla="val 8182"/>
+            </a:avLst>
+          </a:prstGeom>
+          <a:solidFill>
+            <a:srgbClr val="E8F1F5"/>
+          </a:solidFill>
+          <a:ln/>
+        </p:spPr>
+      </p:sp>
+      <p:sp>
+        <p:nvSpPr>
+          <p:cNvPr id="13" name="Text 11"/>
+          <p:cNvSpPr/>
+          <p:nvPr/>
+        </p:nvSpPr>
+        <p:spPr>
+          <a:xfrm>
+            <a:off x="594360" y="2670048"/>
+            <a:ext cx="1737360" cy="457200"/>
+          </a:xfrm>
+          <a:prstGeom prst="rect">
+            <a:avLst/>
+          </a:prstGeom>
+          <a:noFill/>
+          <a:ln/>
+        </p:spPr>
+        <p:txBody>
+          <a:bodyPr wrap="square" lIns="0" tIns="0" rIns="0" bIns="0" rtlCol="0" anchor="ctr">
+            <a:normAutofit/>
+          </a:bodyPr>
+          <a:lstStyle/>
+          <a:p>
+            <a:pPr indent="0" marL="0">
+              <a:buNone/>
+            </a:pPr>
+            <a:r>
+              <a:rPr lang="en-US" sz="2600" b="1" dirty="0">
+                <a:solidFill>
+                  <a:srgbClr val="FB8500"/>
+                </a:solidFill>
+                <a:latin typeface="Arial" pitchFamily="34" charset="0"/>
+                <a:ea typeface="Arial" pitchFamily="34" charset="-122"/>
+                <a:cs typeface="Arial" pitchFamily="34" charset="-120"/>
+              </a:rPr>
+              <a:t>9</a:t>
+            </a:r>
+            <a:endParaRPr lang="en-US" sz="2600" dirty="0"/>
+          </a:p>
+        </p:txBody>
+      </p:sp>
+      <p:sp>
+        <p:nvSpPr>
+          <p:cNvPr id="14" name="Text 12"/>
+          <p:cNvSpPr/>
+          <p:nvPr/>
+        </p:nvSpPr>
+        <p:spPr>
+          <a:xfrm>
+            <a:off x="594360" y="3127248"/>
+            <a:ext cx="1737360" cy="237744"/>
+          </a:xfrm>
+          <a:prstGeom prst="rect">
+            <a:avLst/>
+          </a:prstGeom>
+          <a:noFill/>
+          <a:ln/>
+        </p:spPr>
+        <p:txBody>
+          <a:bodyPr wrap="square" lIns="0" tIns="0" rIns="0" bIns="0" rtlCol="0" anchor="ctr"/>
+          <a:lstStyle/>
+          <a:p>
+            <a:pPr indent="0" marL="0">
+              <a:buNone/>
+            </a:pPr>
+            <a:r>
+              <a:rPr lang="en-US" sz="1100" b="1" dirty="0">
+                <a:solidFill>
+                  <a:srgbClr val="023047"/>
+                </a:solidFill>
+                <a:latin typeface="Microsoft YaHei" pitchFamily="34" charset="0"/>
+                <a:ea typeface="Microsoft YaHei" pitchFamily="34" charset="-122"/>
+                <a:cs typeface="Microsoft YaHei" pitchFamily="34" charset="-120"/>
+              </a:rPr>
+              <a:t>自研 C# 外设模型</a:t>
+            </a:r>
+            <a:endParaRPr lang="en-US" sz="1100" dirty="0"/>
+          </a:p>
+        </p:txBody>
+      </p:sp>
+      <p:sp>
+        <p:nvSpPr>
+          <p:cNvPr id="15" name="Text 13"/>
+          <p:cNvSpPr/>
+          <p:nvPr/>
+        </p:nvSpPr>
+        <p:spPr>
+          <a:xfrm>
+            <a:off x="594360" y="3346704"/>
+            <a:ext cx="1737360" cy="201168"/>
+          </a:xfrm>
+          <a:prstGeom prst="rect">
+            <a:avLst/>
+          </a:prstGeom>
+          <a:noFill/>
+          <a:ln/>
+        </p:spPr>
+        <p:txBody>
+          <a:bodyPr wrap="square" lIns="0" tIns="0" rIns="0" bIns="0" rtlCol="0" anchor="ctr"/>
+          <a:lstStyle/>
+          <a:p>
+            <a:pPr indent="0" marL="0">
+              <a:buNone/>
+            </a:pPr>
+            <a:r>
+              <a:rPr lang="en-US" sz="900" dirty="0">
+                <a:solidFill>
+                  <a:srgbClr val="5C6B7A"/>
+                </a:solidFill>
+                <a:latin typeface="Microsoft YaHei" pitchFamily="34" charset="0"/>
+                <a:ea typeface="Microsoft YaHei" pitchFamily="34" charset="-122"/>
+                <a:cs typeface="Microsoft YaHei" pitchFamily="34" charset="-120"/>
+              </a:rPr>
+              <a:t>Renode 侧</a:t>
+            </a:r>
+            <a:endParaRPr lang="en-US" sz="900" dirty="0"/>
+          </a:p>
+        </p:txBody>
+      </p:sp>
+      <p:sp>
+        <p:nvSpPr>
+          <p:cNvPr id="16" name="Shape 14"/>
+          <p:cNvSpPr/>
+          <p:nvPr/>
+        </p:nvSpPr>
+        <p:spPr>
+          <a:xfrm>
+            <a:off x="2606040" y="2560320"/>
+            <a:ext cx="2011680" cy="1005840"/>
+          </a:xfrm>
+          <a:prstGeom prst="rect">
+            <a:avLst>
+              <a:gd name="adj" fmla="val 8182"/>
+            </a:avLst>
+          </a:prstGeom>
+          <a:solidFill>
+            <a:srgbClr val="E8F1F5"/>
+          </a:solidFill>
+          <a:ln/>
+        </p:spPr>
+      </p:sp>
+      <p:sp>
+        <p:nvSpPr>
+          <p:cNvPr id="17" name="Text 15"/>
+          <p:cNvSpPr/>
+          <p:nvPr/>
+        </p:nvSpPr>
+        <p:spPr>
+          <a:xfrm>
+            <a:off x="2743200" y="2670048"/>
+            <a:ext cx="1737360" cy="457200"/>
+          </a:xfrm>
+          <a:prstGeom prst="rect">
+            <a:avLst/>
+          </a:prstGeom>
+          <a:noFill/>
+          <a:ln/>
+        </p:spPr>
+        <p:txBody>
+          <a:bodyPr wrap="square" lIns="0" tIns="0" rIns="0" bIns="0" rtlCol="0" anchor="ctr">
+            <a:normAutofit/>
+          </a:bodyPr>
+          <a:lstStyle/>
+          <a:p>
+            <a:pPr indent="0" marL="0">
+              <a:buNone/>
+            </a:pPr>
+            <a:r>
+              <a:rPr lang="en-US" sz="2600" b="1" dirty="0">
+                <a:solidFill>
+                  <a:srgbClr val="FB8500"/>
+                </a:solidFill>
+                <a:latin typeface="Arial" pitchFamily="34" charset="0"/>
+                <a:ea typeface="Arial" pitchFamily="34" charset="-122"/>
+                <a:cs typeface="Arial" pitchFamily="34" charset="-120"/>
+              </a:rPr>
+              <a:t>227</a:t>
+            </a:r>
+            <a:endParaRPr lang="en-US" sz="2600" dirty="0"/>
+          </a:p>
+        </p:txBody>
+      </p:sp>
+      <p:sp>
+        <p:nvSpPr>
+          <p:cNvPr id="18" name="Text 16"/>
+          <p:cNvSpPr/>
+          <p:nvPr/>
+        </p:nvSpPr>
+        <p:spPr>
+          <a:xfrm>
+            <a:off x="2743200" y="3127248"/>
+            <a:ext cx="1737360" cy="237744"/>
+          </a:xfrm>
+          <a:prstGeom prst="rect">
+            <a:avLst/>
+          </a:prstGeom>
+          <a:noFill/>
+          <a:ln/>
+        </p:spPr>
+        <p:txBody>
+          <a:bodyPr wrap="square" lIns="0" tIns="0" rIns="0" bIns="0" rtlCol="0" anchor="ctr"/>
+          <a:lstStyle/>
+          <a:p>
+            <a:pPr indent="0" marL="0">
+              <a:buNone/>
+            </a:pPr>
+            <a:r>
+              <a:rPr lang="en-US" sz="1100" b="1" dirty="0">
+                <a:solidFill>
+                  <a:srgbClr val="023047"/>
+                </a:solidFill>
+                <a:latin typeface="Microsoft YaHei" pitchFamily="34" charset="0"/>
+                <a:ea typeface="Microsoft YaHei" pitchFamily="34" charset="-122"/>
+                <a:cs typeface="Microsoft YaHei" pitchFamily="34" charset="-120"/>
+              </a:rPr>
+              <a:t>个测试用例</a:t>
+            </a:r>
+            <a:endParaRPr lang="en-US" sz="1100" dirty="0"/>
+          </a:p>
+        </p:txBody>
+      </p:sp>
+      <p:sp>
+        <p:nvSpPr>
+          <p:cNvPr id="19" name="Text 17"/>
+          <p:cNvSpPr/>
+          <p:nvPr/>
+        </p:nvSpPr>
+        <p:spPr>
+          <a:xfrm>
+            <a:off x="2743200" y="3346704"/>
+            <a:ext cx="1737360" cy="201168"/>
+          </a:xfrm>
+          <a:prstGeom prst="rect">
+            <a:avLst/>
+          </a:prstGeom>
+          <a:noFill/>
+          <a:ln/>
+        </p:spPr>
+        <p:txBody>
+          <a:bodyPr wrap="square" lIns="0" tIns="0" rIns="0" bIns="0" rtlCol="0" anchor="ctr"/>
+          <a:lstStyle/>
+          <a:p>
+            <a:pPr indent="0" marL="0">
+              <a:buNone/>
+            </a:pPr>
+            <a:r>
+              <a:rPr lang="en-US" sz="900" dirty="0">
+                <a:solidFill>
+                  <a:srgbClr val="5C6B7A"/>
+                </a:solidFill>
+                <a:latin typeface="Microsoft YaHei" pitchFamily="34" charset="0"/>
+                <a:ea typeface="Microsoft YaHei" pitchFamily="34" charset="-122"/>
+                <a:cs typeface="Microsoft YaHei" pitchFamily="34" charset="-120"/>
+              </a:rPr>
+              <a:t>23 个测试文件</a:t>
+            </a:r>
+            <a:endParaRPr lang="en-US" sz="900" dirty="0"/>
+          </a:p>
+        </p:txBody>
+      </p:sp>
+      <p:sp>
+        <p:nvSpPr>
+          <p:cNvPr id="20" name="Shape 18"/>
+          <p:cNvSpPr/>
+          <p:nvPr/>
+        </p:nvSpPr>
+        <p:spPr>
+          <a:xfrm>
+            <a:off x="4892040" y="1051560"/>
+            <a:ext cx="3794760" cy="3108960"/>
+          </a:xfrm>
+          <a:prstGeom prst="rect">
+            <a:avLst>
+              <a:gd name="adj" fmla="val 2941"/>
+            </a:avLst>
+          </a:prstGeom>
+          <a:solidFill>
+            <a:srgbClr val="023047"/>
+          </a:solidFill>
+          <a:ln/>
+        </p:spPr>
+      </p:sp>
+      <p:sp>
+        <p:nvSpPr>
+          <p:cNvPr id="21" name="Text 19"/>
+          <p:cNvSpPr/>
+          <p:nvPr/>
+        </p:nvSpPr>
+        <p:spPr>
+          <a:xfrm>
+            <a:off x="5120640" y="1234440"/>
+            <a:ext cx="3383280" cy="274320"/>
+          </a:xfrm>
+          <a:prstGeom prst="rect">
+            <a:avLst/>
+          </a:prstGeom>
+          <a:noFill/>
+          <a:ln/>
+        </p:spPr>
+        <p:txBody>
+          <a:bodyPr wrap="square" lIns="0" tIns="0" rIns="0" bIns="0" rtlCol="0" anchor="ctr"/>
+          <a:lstStyle/>
+          <a:p>
+            <a:pPr indent="0" marL="0">
+              <a:buNone/>
+            </a:pPr>
+            <a:r>
+              <a:rPr lang="en-US" sz="1500" b="1" dirty="0">
+                <a:solidFill>
+                  <a:srgbClr val="FFFFFF"/>
+                </a:solidFill>
+                <a:latin typeface="Microsoft YaHei" pitchFamily="34" charset="0"/>
+                <a:ea typeface="Microsoft YaHei" pitchFamily="34" charset="-122"/>
+                <a:cs typeface="Microsoft YaHei" pitchFamily="34" charset="-120"/>
+              </a:rPr>
+              <a:t>测试现状</a:t>
+            </a:r>
+            <a:endParaRPr lang="en-US" sz="1500" dirty="0"/>
+          </a:p>
+        </p:txBody>
+      </p:sp>
+      <p:sp>
+        <p:nvSpPr>
+          <p:cNvPr id="22" name="Text 20"/>
+          <p:cNvSpPr/>
+          <p:nvPr/>
+        </p:nvSpPr>
+        <p:spPr>
+          <a:xfrm>
+            <a:off x="5120640" y="1691640"/>
+            <a:ext cx="3383280" cy="219456"/>
+          </a:xfrm>
+          <a:prstGeom prst="rect">
+            <a:avLst/>
+          </a:prstGeom>
+          <a:noFill/>
+          <a:ln/>
+        </p:spPr>
+        <p:txBody>
+          <a:bodyPr wrap="square" lIns="0" tIns="0" rIns="0" bIns="0" rtlCol="0" anchor="ctr"/>
+          <a:lstStyle/>
+          <a:p>
+            <a:pPr indent="0" marL="0">
+              <a:buNone/>
+            </a:pPr>
+            <a:r>
+              <a:rPr lang="en-US" sz="1000" dirty="0">
+                <a:solidFill>
+                  <a:srgbClr val="E8F1F5"/>
+                </a:solidFill>
+                <a:latin typeface="Microsoft YaHei" pitchFamily="34" charset="0"/>
+                <a:ea typeface="Microsoft YaHei" pitchFamily="34" charset="-122"/>
+                <a:cs typeface="Microsoft YaHei" pitchFamily="34" charset="-120"/>
+              </a:rPr>
+              <a:t>通过 passed</a:t>
+            </a:r>
+            <a:endParaRPr lang="en-US" sz="1000" dirty="0"/>
+          </a:p>
+        </p:txBody>
+      </p:sp>
+      <p:sp>
+        <p:nvSpPr>
+          <p:cNvPr id="23" name="Shape 21"/>
+          <p:cNvSpPr/>
+          <p:nvPr/>
+        </p:nvSpPr>
+        <p:spPr>
+          <a:xfrm>
+            <a:off x="5120640" y="1929384"/>
+            <a:ext cx="3291840" cy="164592"/>
+          </a:xfrm>
+          <a:prstGeom prst="rect">
+            <a:avLst>
+              <a:gd name="adj" fmla="val 16667"/>
+            </a:avLst>
+          </a:prstGeom>
+          <a:solidFill>
+            <a:srgbClr val="F7FAFC"/>
+          </a:solidFill>
+          <a:ln/>
+        </p:spPr>
+      </p:sp>
+      <p:sp>
+        <p:nvSpPr>
+          <p:cNvPr id="24" name="Shape 22"/>
+          <p:cNvSpPr/>
+          <p:nvPr/>
+        </p:nvSpPr>
+        <p:spPr>
+          <a:xfrm>
+            <a:off x="5120640" y="1929384"/>
+            <a:ext cx="2926080" cy="164592"/>
+          </a:xfrm>
+          <a:prstGeom prst="rect">
+            <a:avLst>
+              <a:gd name="adj" fmla="val 16667"/>
+            </a:avLst>
+          </a:prstGeom>
+          <a:solidFill>
+            <a:srgbClr val="FB8500"/>
+          </a:solidFill>
+          <a:ln/>
+        </p:spPr>
+      </p:sp>
+      <p:sp>
+        <p:nvSpPr>
+          <p:cNvPr id="25" name="Text 23"/>
+          <p:cNvSpPr/>
+          <p:nvPr/>
+        </p:nvSpPr>
+        <p:spPr>
+          <a:xfrm>
+            <a:off x="7955280" y="1691640"/>
+            <a:ext cx="457200" cy="219456"/>
+          </a:xfrm>
+          <a:prstGeom prst="rect">
+            <a:avLst/>
+          </a:prstGeom>
+          <a:noFill/>
+          <a:ln/>
+        </p:spPr>
+        <p:txBody>
+          <a:bodyPr wrap="square" lIns="0" tIns="0" rIns="0" bIns="0" rtlCol="0" anchor="ctr"/>
+          <a:lstStyle/>
+          <a:p>
+            <a:pPr algn="r" indent="0" marL="0">
+              <a:buNone/>
+            </a:pPr>
+            <a:r>
+              <a:rPr lang="en-US" sz="1100" b="1" dirty="0">
+                <a:solidFill>
+                  <a:srgbClr val="FFFFFF"/>
+                </a:solidFill>
+                <a:latin typeface="Arial" pitchFamily="34" charset="0"/>
+                <a:ea typeface="Arial" pitchFamily="34" charset="-122"/>
+                <a:cs typeface="Arial" pitchFamily="34" charset="-120"/>
+              </a:rPr>
+              <a:t>162</a:t>
+            </a:r>
+            <a:endParaRPr lang="en-US" sz="1100" dirty="0"/>
+          </a:p>
+        </p:txBody>
+      </p:sp>
+      <p:sp>
+        <p:nvSpPr>
+          <p:cNvPr id="26" name="Text 24"/>
+          <p:cNvSpPr/>
+          <p:nvPr/>
+        </p:nvSpPr>
+        <p:spPr>
+          <a:xfrm>
+            <a:off x="5120640" y="2258568"/>
+            <a:ext cx="3383280" cy="219456"/>
+          </a:xfrm>
+          <a:prstGeom prst="rect">
+            <a:avLst/>
+          </a:prstGeom>
+          <a:noFill/>
+          <a:ln/>
+        </p:spPr>
+        <p:txBody>
+          <a:bodyPr wrap="square" lIns="0" tIns="0" rIns="0" bIns="0" rtlCol="0" anchor="ctr"/>
+          <a:lstStyle/>
+          <a:p>
+            <a:pPr indent="0" marL="0">
+              <a:buNone/>
+            </a:pPr>
+            <a:r>
+              <a:rPr lang="en-US" sz="1000" dirty="0">
+                <a:solidFill>
+                  <a:srgbClr val="E8F1F5"/>
+                </a:solidFill>
+                <a:latin typeface="Microsoft YaHei" pitchFamily="34" charset="0"/>
+                <a:ea typeface="Microsoft YaHei" pitchFamily="34" charset="-122"/>
+                <a:cs typeface="Microsoft YaHei" pitchFamily="34" charset="-120"/>
+              </a:rPr>
+              <a:t>跳过 skipped</a:t>
+            </a:r>
+            <a:endParaRPr lang="en-US" sz="1000" dirty="0"/>
+          </a:p>
+        </p:txBody>
+      </p:sp>
+      <p:sp>
+        <p:nvSpPr>
+          <p:cNvPr id="27" name="Shape 25"/>
+          <p:cNvSpPr/>
+          <p:nvPr/>
+        </p:nvSpPr>
+        <p:spPr>
+          <a:xfrm>
+            <a:off x="5120640" y="2496312"/>
+            <a:ext cx="3291840" cy="164592"/>
+          </a:xfrm>
+          <a:prstGeom prst="rect">
+            <a:avLst>
+              <a:gd name="adj" fmla="val 16667"/>
+            </a:avLst>
+          </a:prstGeom>
+          <a:solidFill>
+            <a:srgbClr val="F7FAFC"/>
+          </a:solidFill>
+          <a:ln/>
+        </p:spPr>
+      </p:sp>
+      <p:sp>
+        <p:nvSpPr>
+          <p:cNvPr id="28" name="Shape 26"/>
+          <p:cNvSpPr/>
+          <p:nvPr/>
+        </p:nvSpPr>
+        <p:spPr>
+          <a:xfrm>
+            <a:off x="5120640" y="2496312"/>
+            <a:ext cx="1170432" cy="164592"/>
+          </a:xfrm>
+          <a:prstGeom prst="rect">
+            <a:avLst>
+              <a:gd name="adj" fmla="val 16667"/>
+            </a:avLst>
+          </a:prstGeom>
+          <a:solidFill>
+            <a:srgbClr val="5C6B7A"/>
+          </a:solidFill>
+          <a:ln/>
+        </p:spPr>
+      </p:sp>
+      <p:sp>
+        <p:nvSpPr>
+          <p:cNvPr id="29" name="Text 27"/>
+          <p:cNvSpPr/>
+          <p:nvPr/>
+        </p:nvSpPr>
+        <p:spPr>
+          <a:xfrm>
+            <a:off x="7955280" y="2258568"/>
+            <a:ext cx="457200" cy="219456"/>
+          </a:xfrm>
+          <a:prstGeom prst="rect">
+            <a:avLst/>
+          </a:prstGeom>
+          <a:noFill/>
+          <a:ln/>
+        </p:spPr>
+        <p:txBody>
+          <a:bodyPr wrap="square" lIns="0" tIns="0" rIns="0" bIns="0" rtlCol="0" anchor="ctr"/>
+          <a:lstStyle/>
+          <a:p>
+            <a:pPr algn="r" indent="0" marL="0">
+              <a:buNone/>
+            </a:pPr>
+            <a:r>
+              <a:rPr lang="en-US" sz="1100" b="1" dirty="0">
+                <a:solidFill>
+                  <a:srgbClr val="FFFFFF"/>
+                </a:solidFill>
+                <a:latin typeface="Arial" pitchFamily="34" charset="0"/>
+                <a:ea typeface="Arial" pitchFamily="34" charset="-122"/>
+                <a:cs typeface="Arial" pitchFamily="34" charset="-120"/>
+              </a:rPr>
+              <a:t>65</a:t>
+            </a:r>
+            <a:endParaRPr lang="en-US" sz="1100" dirty="0"/>
+          </a:p>
+        </p:txBody>
+      </p:sp>
+      <p:sp>
+        <p:nvSpPr>
+          <p:cNvPr id="30" name="Text 28"/>
+          <p:cNvSpPr/>
+          <p:nvPr/>
+        </p:nvSpPr>
+        <p:spPr>
+          <a:xfrm>
+            <a:off x="5120640" y="2825496"/>
+            <a:ext cx="3383280" cy="219456"/>
+          </a:xfrm>
+          <a:prstGeom prst="rect">
+            <a:avLst/>
+          </a:prstGeom>
+          <a:noFill/>
+          <a:ln/>
+        </p:spPr>
+        <p:txBody>
+          <a:bodyPr wrap="square" lIns="0" tIns="0" rIns="0" bIns="0" rtlCol="0" anchor="ctr"/>
+          <a:lstStyle/>
+          <a:p>
+            <a:pPr indent="0" marL="0">
+              <a:buNone/>
+            </a:pPr>
+            <a:r>
+              <a:rPr lang="en-US" sz="1000" dirty="0">
+                <a:solidFill>
+                  <a:srgbClr val="E8F1F5"/>
+                </a:solidFill>
+                <a:latin typeface="Microsoft YaHei" pitchFamily="34" charset="0"/>
+                <a:ea typeface="Microsoft YaHei" pitchFamily="34" charset="-122"/>
+                <a:cs typeface="Microsoft YaHei" pitchFamily="34" charset="-120"/>
+              </a:rPr>
+              <a:t>失败 failed</a:t>
+            </a:r>
+            <a:endParaRPr lang="en-US" sz="1000" dirty="0"/>
+          </a:p>
+        </p:txBody>
+      </p:sp>
+      <p:sp>
+        <p:nvSpPr>
+          <p:cNvPr id="31" name="Shape 29"/>
+          <p:cNvSpPr/>
+          <p:nvPr/>
+        </p:nvSpPr>
+        <p:spPr>
+          <a:xfrm>
+            <a:off x="5120640" y="3063240"/>
+            <a:ext cx="3291840" cy="164592"/>
+          </a:xfrm>
+          <a:prstGeom prst="rect">
+            <a:avLst>
+              <a:gd name="adj" fmla="val 16667"/>
+            </a:avLst>
+          </a:prstGeom>
+          <a:solidFill>
+            <a:srgbClr val="F7FAFC"/>
+          </a:solidFill>
+          <a:ln/>
+        </p:spPr>
+      </p:sp>
+      <p:sp>
+        <p:nvSpPr>
+          <p:cNvPr id="32" name="Shape 30"/>
+          <p:cNvSpPr/>
+          <p:nvPr/>
+        </p:nvSpPr>
+        <p:spPr>
+          <a:xfrm>
+            <a:off x="5120640" y="3063240"/>
+            <a:ext cx="18288" cy="164592"/>
+          </a:xfrm>
+          <a:prstGeom prst="rect">
+            <a:avLst>
+              <a:gd name="adj" fmla="val 150000"/>
+            </a:avLst>
+          </a:prstGeom>
+          <a:solidFill>
+            <a:srgbClr val="FFFFFF"/>
+          </a:solidFill>
+          <a:ln/>
+        </p:spPr>
+      </p:sp>
+      <p:sp>
+        <p:nvSpPr>
+          <p:cNvPr id="33" name="Text 31"/>
+          <p:cNvSpPr/>
+          <p:nvPr/>
+        </p:nvSpPr>
+        <p:spPr>
+          <a:xfrm>
+            <a:off x="7955280" y="2825496"/>
+            <a:ext cx="457200" cy="219456"/>
+          </a:xfrm>
+          <a:prstGeom prst="rect">
+            <a:avLst/>
+          </a:prstGeom>
+          <a:noFill/>
+          <a:ln/>
+        </p:spPr>
+        <p:txBody>
+          <a:bodyPr wrap="square" lIns="0" tIns="0" rIns="0" bIns="0" rtlCol="0" anchor="ctr"/>
+          <a:lstStyle/>
+          <a:p>
+            <a:pPr algn="r" indent="0" marL="0">
+              <a:buNone/>
+            </a:pPr>
+            <a:r>
+              <a:rPr lang="en-US" sz="1100" b="1" dirty="0">
+                <a:solidFill>
+                  <a:srgbClr val="FFFFFF"/>
+                </a:solidFill>
+                <a:latin typeface="Arial" pitchFamily="34" charset="0"/>
+                <a:ea typeface="Arial" pitchFamily="34" charset="-122"/>
+                <a:cs typeface="Arial" pitchFamily="34" charset="-120"/>
+              </a:rPr>
+              <a:t>0</a:t>
+            </a:r>
+            <a:endParaRPr lang="en-US" sz="1100" dirty="0"/>
+          </a:p>
+        </p:txBody>
+      </p:sp>
+      <p:sp>
+        <p:nvSpPr>
+          <p:cNvPr id="34" name="Shape 32"/>
+          <p:cNvSpPr/>
+          <p:nvPr/>
+        </p:nvSpPr>
+        <p:spPr>
+          <a:xfrm>
+            <a:off x="5120640" y="3520440"/>
+            <a:ext cx="3337560" cy="0"/>
+          </a:xfrm>
+          <a:prstGeom prst="line">
+            <a:avLst/>
+          </a:prstGeom>
+          <a:noFill/>
+          <a:ln w="9525">
+            <a:solidFill>
+              <a:srgbClr val="5C6B7A"/>
+            </a:solidFill>
+            <a:prstDash val="solid"/>
+          </a:ln>
+        </p:spPr>
+      </p:sp>
+      <p:sp>
+        <p:nvSpPr>
+          <p:cNvPr id="35" name="Text 33"/>
+          <p:cNvSpPr/>
+          <p:nvPr/>
+        </p:nvSpPr>
+        <p:spPr>
+          <a:xfrm>
+            <a:off x="5120640" y="3611880"/>
+            <a:ext cx="3383280" cy="237744"/>
+          </a:xfrm>
+          <a:prstGeom prst="rect">
+            <a:avLst/>
+          </a:prstGeom>
+          <a:noFill/>
+          <a:ln/>
+        </p:spPr>
+        <p:txBody>
+          <a:bodyPr wrap="square" lIns="0" tIns="0" rIns="0" bIns="0" rtlCol="0" anchor="ctr"/>
+          <a:lstStyle/>
+          <a:p>
+            <a:pPr indent="0" marL="0">
+              <a:buNone/>
+            </a:pPr>
+            <a:r>
+              <a:rPr lang="en-US" sz="1200" b="1" dirty="0">
+                <a:solidFill>
+                  <a:srgbClr val="FB8500"/>
+                </a:solidFill>
+                <a:latin typeface="Microsoft YaHei" pitchFamily="34" charset="0"/>
+                <a:ea typeface="Microsoft YaHei" pitchFamily="34" charset="-122"/>
+                <a:cs typeface="Microsoft YaHei" pitchFamily="34" charset="-120"/>
+              </a:rPr>
+              <a:t>零失败</a:t>
+            </a:r>
+            <a:endParaRPr lang="en-US" sz="1200" dirty="0"/>
+          </a:p>
+        </p:txBody>
+      </p:sp>
+      <p:sp>
+        <p:nvSpPr>
+          <p:cNvPr id="36" name="Text 34"/>
+          <p:cNvSpPr/>
+          <p:nvPr/>
+        </p:nvSpPr>
+        <p:spPr>
+          <a:xfrm>
+            <a:off x="5120640" y="3858768"/>
+            <a:ext cx="3383280" cy="256032"/>
+          </a:xfrm>
+          <a:prstGeom prst="rect">
+            <a:avLst/>
+          </a:prstGeom>
+          <a:noFill/>
+          <a:ln/>
+        </p:spPr>
+        <p:txBody>
+          <a:bodyPr wrap="square" lIns="0" tIns="0" rIns="0" bIns="0" rtlCol="0" anchor="ctr"/>
+          <a:lstStyle/>
+          <a:p>
+            <a:pPr indent="0" marL="0">
+              <a:buNone/>
+            </a:pPr>
+            <a:r>
+              <a:rPr lang="en-US" sz="850" dirty="0">
+                <a:solidFill>
+                  <a:srgbClr val="E8F1F5"/>
+                </a:solidFill>
+                <a:latin typeface="Microsoft YaHei" pitchFamily="34" charset="0"/>
+                <a:ea typeface="Microsoft YaHei" pitchFamily="34" charset="-122"/>
+                <a:cs typeface="Microsoft YaHei" pitchFamily="34" charset="-120"/>
+              </a:rPr>
+              <a:t>含 Renode 固件在环实测; 跳过项为可选依赖(GrabCAD 登录下载等)</a:t>
+            </a:r>
+            <a:endParaRPr lang="en-US" sz="850" dirty="0"/>
+          </a:p>
+        </p:txBody>
+      </p:sp>
+      <p:sp>
+        <p:nvSpPr>
+          <p:cNvPr id="37" name="Shape 35"/>
+          <p:cNvSpPr/>
+          <p:nvPr/>
+        </p:nvSpPr>
+        <p:spPr>
+          <a:xfrm>
+            <a:off x="8503920" y="4663440"/>
+            <a:ext cx="384048" cy="274320"/>
+          </a:xfrm>
+          <a:prstGeom prst="rect">
+            <a:avLst>
+              <a:gd name="adj" fmla="val 16667"/>
+            </a:avLst>
+          </a:prstGeom>
+          <a:solidFill>
+            <a:srgbClr val="E8F1F5"/>
+          </a:solidFill>
+          <a:ln/>
+        </p:spPr>
+      </p:sp>
+      <p:sp>
+        <p:nvSpPr>
+          <p:cNvPr id="38" name="Text 36"/>
+          <p:cNvSpPr/>
+          <p:nvPr/>
+        </p:nvSpPr>
+        <p:spPr>
+          <a:xfrm>
+            <a:off x="8503920" y="4663440"/>
+            <a:ext cx="384048" cy="274320"/>
+          </a:xfrm>
+          <a:prstGeom prst="rect">
+            <a:avLst/>
+          </a:prstGeom>
+          <a:noFill/>
+          <a:ln/>
+        </p:spPr>
+        <p:txBody>
+          <a:bodyPr wrap="square" lIns="0" tIns="0" rIns="0" bIns="0" rtlCol="0" anchor="ctr"/>
+          <a:lstStyle/>
+          <a:p>
+            <a:pPr algn="ctr" indent="0" marL="0">
+              <a:buNone/>
+            </a:pPr>
+            <a:r>
+              <a:rPr lang="en-US" sz="1000" dirty="0">
+                <a:solidFill>
+                  <a:srgbClr val="5C6B7A"/>
+                </a:solidFill>
+                <a:latin typeface="Arial" pitchFamily="34" charset="0"/>
+                <a:ea typeface="Arial" pitchFamily="34" charset="-122"/>
+                <a:cs typeface="Arial" pitchFamily="34" charset="-120"/>
+              </a:rPr>
+              <a:t>11</a:t>
+            </a:r>
+            <a:endParaRPr lang="en-US" sz="1000" dirty="0"/>
+          </a:p>
+        </p:txBody>
+      </p:sp>
+    </p:spTree>
+  </p:cSld>
+  <p:clrMapOvr>
+    <a:masterClrMapping/>
+  </p:clrMapOvr>
+</p:sld>
+</file>
+
+<file path=ppt/slides/slide12.xml><?xml version="1.0" encoding="utf-8"?>
+<p:sld xmlns:a="http://schemas.openxmlformats.org/drawingml/2006/main" xmlns:r="http://schemas.openxmlformats.org/officeDocument/2006/relationships" xmlns:p="http://schemas.openxmlformats.org/presentationml/2006/main">
+  <p:cSld name="Slide 12">
     <p:bg>
       <p:bgPr>
         <a:solidFill>
@@ -4802,7 +5559,7 @@
                 <a:ea typeface="Arial" pitchFamily="34" charset="-122"/>
                 <a:cs typeface="Arial" pitchFamily="34" charset="-120"/>
               </a:rPr>
-              <a:t>11</a:t>
+              <a:t>12</a:t>
             </a:r>
             <a:endParaRPr lang="en-US" sz="1000" dirty="0"/>
           </a:p>
@@ -12462,6 +13219,1005 @@
         </p:nvSpPr>
         <p:spPr>
           <a:xfrm>
+            <a:off x="457200" y="320040"/>
+            <a:ext cx="8229600" cy="457200"/>
+          </a:xfrm>
+          <a:prstGeom prst="rect">
+            <a:avLst/>
+          </a:prstGeom>
+          <a:noFill/>
+          <a:ln/>
+        </p:spPr>
+        <p:txBody>
+          <a:bodyPr wrap="square" lIns="0" tIns="0" rIns="0" bIns="0" rtlCol="0" anchor="ctr">
+            <a:normAutofit/>
+          </a:bodyPr>
+          <a:lstStyle/>
+          <a:p>
+            <a:pPr indent="0" marL="0">
+              <a:buNone/>
+            </a:pPr>
+            <a:r>
+              <a:rPr lang="en-US" sz="2800" b="1" dirty="0">
+                <a:solidFill>
+                  <a:srgbClr val="023047"/>
+                </a:solidFill>
+                <a:latin typeface="Microsoft YaHei" pitchFamily="34" charset="0"/>
+                <a:ea typeface="Microsoft YaHei" pitchFamily="34" charset="-122"/>
+                <a:cs typeface="Microsoft YaHei" pitchFamily="34" charset="-120"/>
+              </a:rPr>
+              <a:t>赛题要求: 小车行驶场地与四项任务</a:t>
+            </a:r>
+            <a:endParaRPr lang="en-US" sz="2800" dirty="0"/>
+          </a:p>
+        </p:txBody>
+      </p:sp>
+      <p:sp>
+        <p:nvSpPr>
+          <p:cNvPr id="3" name="Text 1"/>
+          <p:cNvSpPr/>
+          <p:nvPr/>
+        </p:nvSpPr>
+        <p:spPr>
+          <a:xfrm>
+            <a:off x="457200" y="795528"/>
+            <a:ext cx="8229600" cy="274320"/>
+          </a:xfrm>
+          <a:prstGeom prst="rect">
+            <a:avLst/>
+          </a:prstGeom>
+          <a:noFill/>
+          <a:ln/>
+        </p:spPr>
+        <p:txBody>
+          <a:bodyPr wrap="square" lIns="0" tIns="0" rIns="0" bIns="0" rtlCol="0" anchor="ctr"/>
+          <a:lstStyle/>
+          <a:p>
+            <a:pPr indent="0" marL="0">
+              <a:buNone/>
+            </a:pPr>
+            <a:r>
+              <a:rPr lang="en-US" sz="1200" dirty="0">
+                <a:solidFill>
+                  <a:srgbClr val="5C6B7A"/>
+                </a:solidFill>
+                <a:latin typeface="Microsoft YaHei" pitchFamily="34" charset="0"/>
+                <a:ea typeface="Microsoft YaHei" pitchFamily="34" charset="-122"/>
+                <a:cs typeface="Microsoft YaHei" pitchFamily="34" charset="-120"/>
+              </a:rPr>
+              <a:t>孪生不是自娱自乐的靶场 -- 它逐条复现考题, 并按同一套判分标准打分</a:t>
+            </a:r>
+            <a:endParaRPr lang="en-US" sz="1200" dirty="0"/>
+          </a:p>
+        </p:txBody>
+      </p:sp>
+      <p:pic>
+        <p:nvPicPr>
+          <p:cNvPr id="4" name="Image 0" descr="2024 H sheet smart-car exam: field layout and four tasks">    </p:cNvPr>
+          <p:cNvPicPr>
+            <a:picLocks noChangeAspect="1"/>
+          </p:cNvPicPr>
+          <p:nvPr/>
+        </p:nvPicPr>
+        <p:blipFill>
+          <a:blip r:embed="rId1"/>
+          <a:stretch>
+            <a:fillRect/>
+          </a:stretch>
+        </p:blipFill>
+        <p:spPr>
+          <a:xfrm>
+            <a:off x="457200" y="1170432"/>
+            <a:ext cx="3310128" cy="3017520"/>
+          </a:xfrm>
+          <a:prstGeom prst="rect">
+            <a:avLst/>
+          </a:prstGeom>
+        </p:spPr>
+      </p:pic>
+      <p:sp>
+        <p:nvSpPr>
+          <p:cNvPr id="5" name="Shape 2"/>
+          <p:cNvSpPr/>
+          <p:nvPr/>
+        </p:nvSpPr>
+        <p:spPr>
+          <a:xfrm>
+            <a:off x="457200" y="1170432"/>
+            <a:ext cx="3310128" cy="3017520"/>
+          </a:xfrm>
+          <a:prstGeom prst="rect">
+            <a:avLst/>
+          </a:prstGeom>
+          <a:solidFill>
+            <a:srgbClr val="FFFFFF">
+              <a:alpha val="0"/>
+            </a:srgbClr>
+          </a:solidFill>
+          <a:ln w="9525">
+            <a:solidFill>
+              <a:srgbClr val="5C6B7A"/>
+            </a:solidFill>
+            <a:prstDash val="solid"/>
+          </a:ln>
+        </p:spPr>
+      </p:sp>
+      <p:sp>
+        <p:nvSpPr>
+          <p:cNvPr id="6" name="Text 3"/>
+          <p:cNvSpPr/>
+          <p:nvPr/>
+        </p:nvSpPr>
+        <p:spPr>
+          <a:xfrm>
+            <a:off x="457200" y="4224528"/>
+            <a:ext cx="3310128" cy="219456"/>
+          </a:xfrm>
+          <a:prstGeom prst="rect">
+            <a:avLst/>
+          </a:prstGeom>
+          <a:noFill/>
+          <a:ln/>
+        </p:spPr>
+        <p:txBody>
+          <a:bodyPr wrap="square" lIns="0" tIns="0" rIns="0" bIns="0" rtlCol="0" anchor="ctr"/>
+          <a:lstStyle/>
+          <a:p>
+            <a:pPr algn="ctr" indent="0" marL="0">
+              <a:buNone/>
+            </a:pPr>
+            <a:r>
+              <a:rPr lang="en-US" sz="900" dirty="0">
+                <a:solidFill>
+                  <a:srgbClr val="5C6B7A"/>
+                </a:solidFill>
+                <a:latin typeface="Microsoft YaHei" pitchFamily="34" charset="0"/>
+                <a:ea typeface="Microsoft YaHei" pitchFamily="34" charset="-122"/>
+                <a:cs typeface="Microsoft YaHei" pitchFamily="34" charset="-120"/>
+              </a:rPr>
+              <a:t>赛题原图</a:t>
+            </a:r>
+            <a:endParaRPr lang="en-US" sz="900" dirty="0"/>
+          </a:p>
+        </p:txBody>
+      </p:sp>
+      <p:sp>
+        <p:nvSpPr>
+          <p:cNvPr id="7" name="Text 4"/>
+          <p:cNvSpPr/>
+          <p:nvPr/>
+        </p:nvSpPr>
+        <p:spPr>
+          <a:xfrm>
+            <a:off x="4023360" y="1170432"/>
+            <a:ext cx="4663440" cy="256032"/>
+          </a:xfrm>
+          <a:prstGeom prst="rect">
+            <a:avLst/>
+          </a:prstGeom>
+          <a:noFill/>
+          <a:ln/>
+        </p:spPr>
+        <p:txBody>
+          <a:bodyPr wrap="square" lIns="0" tIns="0" rIns="0" bIns="0" rtlCol="0" anchor="ctr"/>
+          <a:lstStyle/>
+          <a:p>
+            <a:pPr indent="0" marL="0">
+              <a:buNone/>
+            </a:pPr>
+            <a:r>
+              <a:rPr lang="en-US" sz="1400" b="1" dirty="0">
+                <a:solidFill>
+                  <a:srgbClr val="023047"/>
+                </a:solidFill>
+                <a:latin typeface="Microsoft YaHei" pitchFamily="34" charset="0"/>
+                <a:ea typeface="Microsoft YaHei" pitchFamily="34" charset="-122"/>
+                <a:cs typeface="Microsoft YaHei" pitchFamily="34" charset="-120"/>
+              </a:rPr>
+              <a:t>四项任务 (与仿真一一对应)</a:t>
+            </a:r>
+            <a:endParaRPr lang="en-US" sz="1400" dirty="0"/>
+          </a:p>
+        </p:txBody>
+      </p:sp>
+      <p:sp>
+        <p:nvSpPr>
+          <p:cNvPr id="8" name="Shape 5"/>
+          <p:cNvSpPr/>
+          <p:nvPr/>
+        </p:nvSpPr>
+        <p:spPr>
+          <a:xfrm>
+            <a:off x="4023360" y="1517904"/>
+            <a:ext cx="4663440" cy="621792"/>
+          </a:xfrm>
+          <a:prstGeom prst="rect">
+            <a:avLst>
+              <a:gd name="adj" fmla="val 10294"/>
+            </a:avLst>
+          </a:prstGeom>
+          <a:solidFill>
+            <a:srgbClr val="E8F1F5"/>
+          </a:solidFill>
+          <a:ln/>
+        </p:spPr>
+      </p:sp>
+      <p:sp>
+        <p:nvSpPr>
+          <p:cNvPr id="9" name="Shape 6"/>
+          <p:cNvSpPr/>
+          <p:nvPr/>
+        </p:nvSpPr>
+        <p:spPr>
+          <a:xfrm>
+            <a:off x="4023360" y="1517904"/>
+            <a:ext cx="64008" cy="621792"/>
+          </a:xfrm>
+          <a:prstGeom prst="rect">
+            <a:avLst/>
+          </a:prstGeom>
+          <a:solidFill>
+            <a:srgbClr val="FB8500"/>
+          </a:solidFill>
+          <a:ln/>
+        </p:spPr>
+      </p:sp>
+      <p:sp>
+        <p:nvSpPr>
+          <p:cNvPr id="10" name="Text 7"/>
+          <p:cNvSpPr/>
+          <p:nvPr/>
+        </p:nvSpPr>
+        <p:spPr>
+          <a:xfrm>
+            <a:off x="4187952" y="1591056"/>
+            <a:ext cx="868680" cy="237744"/>
+          </a:xfrm>
+          <a:prstGeom prst="rect">
+            <a:avLst/>
+          </a:prstGeom>
+          <a:noFill/>
+          <a:ln/>
+        </p:spPr>
+        <p:txBody>
+          <a:bodyPr wrap="square" lIns="0" tIns="0" rIns="0" bIns="0" rtlCol="0" anchor="ctr"/>
+          <a:lstStyle/>
+          <a:p>
+            <a:pPr indent="0" marL="0">
+              <a:buNone/>
+            </a:pPr>
+            <a:r>
+              <a:rPr lang="en-US" sz="1200" b="1" dirty="0">
+                <a:solidFill>
+                  <a:srgbClr val="FB8500"/>
+                </a:solidFill>
+                <a:latin typeface="Microsoft YaHei" pitchFamily="34" charset="0"/>
+                <a:ea typeface="Microsoft YaHei" pitchFamily="34" charset="-122"/>
+                <a:cs typeface="Microsoft YaHei" pitchFamily="34" charset="-120"/>
+              </a:rPr>
+              <a:t>任务 1</a:t>
+            </a:r>
+            <a:endParaRPr lang="en-US" sz="1200" dirty="0"/>
+          </a:p>
+        </p:txBody>
+      </p:sp>
+      <p:sp>
+        <p:nvSpPr>
+          <p:cNvPr id="11" name="Text 8"/>
+          <p:cNvSpPr/>
+          <p:nvPr/>
+        </p:nvSpPr>
+        <p:spPr>
+          <a:xfrm>
+            <a:off x="5074920" y="1591056"/>
+            <a:ext cx="3520440" cy="237744"/>
+          </a:xfrm>
+          <a:prstGeom prst="rect">
+            <a:avLst/>
+          </a:prstGeom>
+          <a:noFill/>
+          <a:ln/>
+        </p:spPr>
+        <p:txBody>
+          <a:bodyPr wrap="square" lIns="0" tIns="0" rIns="0" bIns="0" rtlCol="0" anchor="ctr"/>
+          <a:lstStyle/>
+          <a:p>
+            <a:pPr indent="0" marL="0">
+              <a:buNone/>
+            </a:pPr>
+            <a:r>
+              <a:rPr lang="en-US" sz="1100" dirty="0">
+                <a:solidFill>
+                  <a:srgbClr val="023047"/>
+                </a:solidFill>
+                <a:latin typeface="Microsoft YaHei" pitchFamily="34" charset="0"/>
+                <a:ea typeface="Microsoft YaHei" pitchFamily="34" charset="-122"/>
+                <a:cs typeface="Microsoft YaHei" pitchFamily="34" charset="-120"/>
+              </a:rPr>
+              <a:t>A -&gt; B 直线行驶并停车, 声光提示</a:t>
+            </a:r>
+            <a:endParaRPr lang="en-US" sz="1100" dirty="0"/>
+          </a:p>
+        </p:txBody>
+      </p:sp>
+      <p:sp>
+        <p:nvSpPr>
+          <p:cNvPr id="12" name="Text 9"/>
+          <p:cNvSpPr/>
+          <p:nvPr/>
+        </p:nvSpPr>
+        <p:spPr>
+          <a:xfrm>
+            <a:off x="5074920" y="1847088"/>
+            <a:ext cx="3520440" cy="219456"/>
+          </a:xfrm>
+          <a:prstGeom prst="rect">
+            <a:avLst/>
+          </a:prstGeom>
+          <a:noFill/>
+          <a:ln/>
+        </p:spPr>
+        <p:txBody>
+          <a:bodyPr wrap="square" lIns="0" tIns="0" rIns="0" bIns="0" rtlCol="0" anchor="ctr"/>
+          <a:lstStyle/>
+          <a:p>
+            <a:pPr indent="0" marL="0">
+              <a:buNone/>
+            </a:pPr>
+            <a:r>
+              <a:rPr lang="en-US" sz="1000" b="1" dirty="0">
+                <a:solidFill>
+                  <a:srgbClr val="5C6B7A"/>
+                </a:solidFill>
+                <a:latin typeface="Microsoft YaHei" pitchFamily="34" charset="0"/>
+                <a:ea typeface="Microsoft YaHei" pitchFamily="34" charset="-122"/>
+                <a:cs typeface="Microsoft YaHei" pitchFamily="34" charset="-120"/>
+              </a:rPr>
+              <a:t>限 15 秒</a:t>
+            </a:r>
+            <a:endParaRPr lang="en-US" sz="1000" dirty="0"/>
+          </a:p>
+        </p:txBody>
+      </p:sp>
+      <p:sp>
+        <p:nvSpPr>
+          <p:cNvPr id="13" name="Shape 10"/>
+          <p:cNvSpPr/>
+          <p:nvPr/>
+        </p:nvSpPr>
+        <p:spPr>
+          <a:xfrm>
+            <a:off x="4023360" y="2231136"/>
+            <a:ext cx="4663440" cy="621792"/>
+          </a:xfrm>
+          <a:prstGeom prst="rect">
+            <a:avLst>
+              <a:gd name="adj" fmla="val 10294"/>
+            </a:avLst>
+          </a:prstGeom>
+          <a:solidFill>
+            <a:srgbClr val="E8F1F5"/>
+          </a:solidFill>
+          <a:ln/>
+        </p:spPr>
+      </p:sp>
+      <p:sp>
+        <p:nvSpPr>
+          <p:cNvPr id="14" name="Shape 11"/>
+          <p:cNvSpPr/>
+          <p:nvPr/>
+        </p:nvSpPr>
+        <p:spPr>
+          <a:xfrm>
+            <a:off x="4023360" y="2231136"/>
+            <a:ext cx="64008" cy="621792"/>
+          </a:xfrm>
+          <a:prstGeom prst="rect">
+            <a:avLst/>
+          </a:prstGeom>
+          <a:solidFill>
+            <a:srgbClr val="FB8500"/>
+          </a:solidFill>
+          <a:ln/>
+        </p:spPr>
+      </p:sp>
+      <p:sp>
+        <p:nvSpPr>
+          <p:cNvPr id="15" name="Text 12"/>
+          <p:cNvSpPr/>
+          <p:nvPr/>
+        </p:nvSpPr>
+        <p:spPr>
+          <a:xfrm>
+            <a:off x="4187952" y="2304288"/>
+            <a:ext cx="868680" cy="237744"/>
+          </a:xfrm>
+          <a:prstGeom prst="rect">
+            <a:avLst/>
+          </a:prstGeom>
+          <a:noFill/>
+          <a:ln/>
+        </p:spPr>
+        <p:txBody>
+          <a:bodyPr wrap="square" lIns="0" tIns="0" rIns="0" bIns="0" rtlCol="0" anchor="ctr"/>
+          <a:lstStyle/>
+          <a:p>
+            <a:pPr indent="0" marL="0">
+              <a:buNone/>
+            </a:pPr>
+            <a:r>
+              <a:rPr lang="en-US" sz="1200" b="1" dirty="0">
+                <a:solidFill>
+                  <a:srgbClr val="FB8500"/>
+                </a:solidFill>
+                <a:latin typeface="Microsoft YaHei" pitchFamily="34" charset="0"/>
+                <a:ea typeface="Microsoft YaHei" pitchFamily="34" charset="-122"/>
+                <a:cs typeface="Microsoft YaHei" pitchFamily="34" charset="-120"/>
+              </a:rPr>
+              <a:t>任务 2</a:t>
+            </a:r>
+            <a:endParaRPr lang="en-US" sz="1200" dirty="0"/>
+          </a:p>
+        </p:txBody>
+      </p:sp>
+      <p:sp>
+        <p:nvSpPr>
+          <p:cNvPr id="16" name="Text 13"/>
+          <p:cNvSpPr/>
+          <p:nvPr/>
+        </p:nvSpPr>
+        <p:spPr>
+          <a:xfrm>
+            <a:off x="5074920" y="2304288"/>
+            <a:ext cx="3520440" cy="237744"/>
+          </a:xfrm>
+          <a:prstGeom prst="rect">
+            <a:avLst/>
+          </a:prstGeom>
+          <a:noFill/>
+          <a:ln/>
+        </p:spPr>
+        <p:txBody>
+          <a:bodyPr wrap="square" lIns="0" tIns="0" rIns="0" bIns="0" rtlCol="0" anchor="ctr"/>
+          <a:lstStyle/>
+          <a:p>
+            <a:pPr indent="0" marL="0">
+              <a:buNone/>
+            </a:pPr>
+            <a:r>
+              <a:rPr lang="en-US" sz="1100" dirty="0">
+                <a:solidFill>
+                  <a:srgbClr val="023047"/>
+                </a:solidFill>
+                <a:latin typeface="Microsoft YaHei" pitchFamily="34" charset="0"/>
+                <a:ea typeface="Microsoft YaHei" pitchFamily="34" charset="-122"/>
+                <a:cs typeface="Microsoft YaHei" pitchFamily="34" charset="-120"/>
+              </a:rPr>
+              <a:t>A -&gt; B -&gt; C -&gt; D -&gt; A, 每经一点提示一次</a:t>
+            </a:r>
+            <a:endParaRPr lang="en-US" sz="1100" dirty="0"/>
+          </a:p>
+        </p:txBody>
+      </p:sp>
+      <p:sp>
+        <p:nvSpPr>
+          <p:cNvPr id="17" name="Text 14"/>
+          <p:cNvSpPr/>
+          <p:nvPr/>
+        </p:nvSpPr>
+        <p:spPr>
+          <a:xfrm>
+            <a:off x="5074920" y="2560320"/>
+            <a:ext cx="3520440" cy="219456"/>
+          </a:xfrm>
+          <a:prstGeom prst="rect">
+            <a:avLst/>
+          </a:prstGeom>
+          <a:noFill/>
+          <a:ln/>
+        </p:spPr>
+        <p:txBody>
+          <a:bodyPr wrap="square" lIns="0" tIns="0" rIns="0" bIns="0" rtlCol="0" anchor="ctr"/>
+          <a:lstStyle/>
+          <a:p>
+            <a:pPr indent="0" marL="0">
+              <a:buNone/>
+            </a:pPr>
+            <a:r>
+              <a:rPr lang="en-US" sz="1000" b="1" dirty="0">
+                <a:solidFill>
+                  <a:srgbClr val="5C6B7A"/>
+                </a:solidFill>
+                <a:latin typeface="Microsoft YaHei" pitchFamily="34" charset="0"/>
+                <a:ea typeface="Microsoft YaHei" pitchFamily="34" charset="-122"/>
+                <a:cs typeface="Microsoft YaHei" pitchFamily="34" charset="-120"/>
+              </a:rPr>
+              <a:t>限 30 秒</a:t>
+            </a:r>
+            <a:endParaRPr lang="en-US" sz="1000" dirty="0"/>
+          </a:p>
+        </p:txBody>
+      </p:sp>
+      <p:sp>
+        <p:nvSpPr>
+          <p:cNvPr id="18" name="Shape 15"/>
+          <p:cNvSpPr/>
+          <p:nvPr/>
+        </p:nvSpPr>
+        <p:spPr>
+          <a:xfrm>
+            <a:off x="4023360" y="2944368"/>
+            <a:ext cx="4663440" cy="621792"/>
+          </a:xfrm>
+          <a:prstGeom prst="rect">
+            <a:avLst>
+              <a:gd name="adj" fmla="val 10294"/>
+            </a:avLst>
+          </a:prstGeom>
+          <a:solidFill>
+            <a:srgbClr val="E8F1F5"/>
+          </a:solidFill>
+          <a:ln/>
+        </p:spPr>
+      </p:sp>
+      <p:sp>
+        <p:nvSpPr>
+          <p:cNvPr id="19" name="Shape 16"/>
+          <p:cNvSpPr/>
+          <p:nvPr/>
+        </p:nvSpPr>
+        <p:spPr>
+          <a:xfrm>
+            <a:off x="4023360" y="2944368"/>
+            <a:ext cx="64008" cy="621792"/>
+          </a:xfrm>
+          <a:prstGeom prst="rect">
+            <a:avLst/>
+          </a:prstGeom>
+          <a:solidFill>
+            <a:srgbClr val="FB8500"/>
+          </a:solidFill>
+          <a:ln/>
+        </p:spPr>
+      </p:sp>
+      <p:sp>
+        <p:nvSpPr>
+          <p:cNvPr id="20" name="Text 17"/>
+          <p:cNvSpPr/>
+          <p:nvPr/>
+        </p:nvSpPr>
+        <p:spPr>
+          <a:xfrm>
+            <a:off x="4187952" y="3017520"/>
+            <a:ext cx="868680" cy="237744"/>
+          </a:xfrm>
+          <a:prstGeom prst="rect">
+            <a:avLst/>
+          </a:prstGeom>
+          <a:noFill/>
+          <a:ln/>
+        </p:spPr>
+        <p:txBody>
+          <a:bodyPr wrap="square" lIns="0" tIns="0" rIns="0" bIns="0" rtlCol="0" anchor="ctr"/>
+          <a:lstStyle/>
+          <a:p>
+            <a:pPr indent="0" marL="0">
+              <a:buNone/>
+            </a:pPr>
+            <a:r>
+              <a:rPr lang="en-US" sz="1200" b="1" dirty="0">
+                <a:solidFill>
+                  <a:srgbClr val="FB8500"/>
+                </a:solidFill>
+                <a:latin typeface="Microsoft YaHei" pitchFamily="34" charset="0"/>
+                <a:ea typeface="Microsoft YaHei" pitchFamily="34" charset="-122"/>
+                <a:cs typeface="Microsoft YaHei" pitchFamily="34" charset="-120"/>
+              </a:rPr>
+              <a:t>任务 3</a:t>
+            </a:r>
+            <a:endParaRPr lang="en-US" sz="1200" dirty="0"/>
+          </a:p>
+        </p:txBody>
+      </p:sp>
+      <p:sp>
+        <p:nvSpPr>
+          <p:cNvPr id="21" name="Text 18"/>
+          <p:cNvSpPr/>
+          <p:nvPr/>
+        </p:nvSpPr>
+        <p:spPr>
+          <a:xfrm>
+            <a:off x="5074920" y="3017520"/>
+            <a:ext cx="3520440" cy="237744"/>
+          </a:xfrm>
+          <a:prstGeom prst="rect">
+            <a:avLst/>
+          </a:prstGeom>
+          <a:noFill/>
+          <a:ln/>
+        </p:spPr>
+        <p:txBody>
+          <a:bodyPr wrap="square" lIns="0" tIns="0" rIns="0" bIns="0" rtlCol="0" anchor="ctr"/>
+          <a:lstStyle/>
+          <a:p>
+            <a:pPr indent="0" marL="0">
+              <a:buNone/>
+            </a:pPr>
+            <a:r>
+              <a:rPr lang="en-US" sz="1100" dirty="0">
+                <a:solidFill>
+                  <a:srgbClr val="023047"/>
+                </a:solidFill>
+                <a:latin typeface="Microsoft YaHei" pitchFamily="34" charset="0"/>
+                <a:ea typeface="Microsoft YaHei" pitchFamily="34" charset="-122"/>
+                <a:cs typeface="Microsoft YaHei" pitchFamily="34" charset="-120"/>
+              </a:rPr>
+              <a:t>A -&gt; C -&gt; B -&gt; D -&gt; A, 每经一点提示一次</a:t>
+            </a:r>
+            <a:endParaRPr lang="en-US" sz="1100" dirty="0"/>
+          </a:p>
+        </p:txBody>
+      </p:sp>
+      <p:sp>
+        <p:nvSpPr>
+          <p:cNvPr id="22" name="Text 19"/>
+          <p:cNvSpPr/>
+          <p:nvPr/>
+        </p:nvSpPr>
+        <p:spPr>
+          <a:xfrm>
+            <a:off x="5074920" y="3273552"/>
+            <a:ext cx="3520440" cy="219456"/>
+          </a:xfrm>
+          <a:prstGeom prst="rect">
+            <a:avLst/>
+          </a:prstGeom>
+          <a:noFill/>
+          <a:ln/>
+        </p:spPr>
+        <p:txBody>
+          <a:bodyPr wrap="square" lIns="0" tIns="0" rIns="0" bIns="0" rtlCol="0" anchor="ctr"/>
+          <a:lstStyle/>
+          <a:p>
+            <a:pPr indent="0" marL="0">
+              <a:buNone/>
+            </a:pPr>
+            <a:r>
+              <a:rPr lang="en-US" sz="1000" b="1" dirty="0">
+                <a:solidFill>
+                  <a:srgbClr val="5C6B7A"/>
+                </a:solidFill>
+                <a:latin typeface="Microsoft YaHei" pitchFamily="34" charset="0"/>
+                <a:ea typeface="Microsoft YaHei" pitchFamily="34" charset="-122"/>
+                <a:cs typeface="Microsoft YaHei" pitchFamily="34" charset="-120"/>
+              </a:rPr>
+              <a:t>限 40 秒</a:t>
+            </a:r>
+            <a:endParaRPr lang="en-US" sz="1000" dirty="0"/>
+          </a:p>
+        </p:txBody>
+      </p:sp>
+      <p:sp>
+        <p:nvSpPr>
+          <p:cNvPr id="23" name="Shape 20"/>
+          <p:cNvSpPr/>
+          <p:nvPr/>
+        </p:nvSpPr>
+        <p:spPr>
+          <a:xfrm>
+            <a:off x="4023360" y="3657600"/>
+            <a:ext cx="4663440" cy="621792"/>
+          </a:xfrm>
+          <a:prstGeom prst="rect">
+            <a:avLst>
+              <a:gd name="adj" fmla="val 10294"/>
+            </a:avLst>
+          </a:prstGeom>
+          <a:solidFill>
+            <a:srgbClr val="E8F1F5"/>
+          </a:solidFill>
+          <a:ln/>
+        </p:spPr>
+      </p:sp>
+      <p:sp>
+        <p:nvSpPr>
+          <p:cNvPr id="24" name="Shape 21"/>
+          <p:cNvSpPr/>
+          <p:nvPr/>
+        </p:nvSpPr>
+        <p:spPr>
+          <a:xfrm>
+            <a:off x="4023360" y="3657600"/>
+            <a:ext cx="64008" cy="621792"/>
+          </a:xfrm>
+          <a:prstGeom prst="rect">
+            <a:avLst/>
+          </a:prstGeom>
+          <a:solidFill>
+            <a:srgbClr val="FB8500"/>
+          </a:solidFill>
+          <a:ln/>
+        </p:spPr>
+      </p:sp>
+      <p:sp>
+        <p:nvSpPr>
+          <p:cNvPr id="25" name="Text 22"/>
+          <p:cNvSpPr/>
+          <p:nvPr/>
+        </p:nvSpPr>
+        <p:spPr>
+          <a:xfrm>
+            <a:off x="4187952" y="3730752"/>
+            <a:ext cx="868680" cy="237744"/>
+          </a:xfrm>
+          <a:prstGeom prst="rect">
+            <a:avLst/>
+          </a:prstGeom>
+          <a:noFill/>
+          <a:ln/>
+        </p:spPr>
+        <p:txBody>
+          <a:bodyPr wrap="square" lIns="0" tIns="0" rIns="0" bIns="0" rtlCol="0" anchor="ctr"/>
+          <a:lstStyle/>
+          <a:p>
+            <a:pPr indent="0" marL="0">
+              <a:buNone/>
+            </a:pPr>
+            <a:r>
+              <a:rPr lang="en-US" sz="1200" b="1" dirty="0">
+                <a:solidFill>
+                  <a:srgbClr val="FB8500"/>
+                </a:solidFill>
+                <a:latin typeface="Microsoft YaHei" pitchFamily="34" charset="0"/>
+                <a:ea typeface="Microsoft YaHei" pitchFamily="34" charset="-122"/>
+                <a:cs typeface="Microsoft YaHei" pitchFamily="34" charset="-120"/>
+              </a:rPr>
+              <a:t>任务 4</a:t>
+            </a:r>
+            <a:endParaRPr lang="en-US" sz="1200" dirty="0"/>
+          </a:p>
+        </p:txBody>
+      </p:sp>
+      <p:sp>
+        <p:nvSpPr>
+          <p:cNvPr id="26" name="Text 23"/>
+          <p:cNvSpPr/>
+          <p:nvPr/>
+        </p:nvSpPr>
+        <p:spPr>
+          <a:xfrm>
+            <a:off x="5074920" y="3730752"/>
+            <a:ext cx="3520440" cy="237744"/>
+          </a:xfrm>
+          <a:prstGeom prst="rect">
+            <a:avLst/>
+          </a:prstGeom>
+          <a:noFill/>
+          <a:ln/>
+        </p:spPr>
+        <p:txBody>
+          <a:bodyPr wrap="square" lIns="0" tIns="0" rIns="0" bIns="0" rtlCol="0" anchor="ctr"/>
+          <a:lstStyle/>
+          <a:p>
+            <a:pPr indent="0" marL="0">
+              <a:buNone/>
+            </a:pPr>
+            <a:r>
+              <a:rPr lang="en-US" sz="1100" dirty="0">
+                <a:solidFill>
+                  <a:srgbClr val="023047"/>
+                </a:solidFill>
+                <a:latin typeface="Microsoft YaHei" pitchFamily="34" charset="0"/>
+                <a:ea typeface="Microsoft YaHei" pitchFamily="34" charset="-122"/>
+                <a:cs typeface="Microsoft YaHei" pitchFamily="34" charset="-120"/>
+              </a:rPr>
+              <a:t>按任务 3 路线连跑 4 圈, 用时越少越好</a:t>
+            </a:r>
+            <a:endParaRPr lang="en-US" sz="1100" dirty="0"/>
+          </a:p>
+        </p:txBody>
+      </p:sp>
+      <p:sp>
+        <p:nvSpPr>
+          <p:cNvPr id="27" name="Text 24"/>
+          <p:cNvSpPr/>
+          <p:nvPr/>
+        </p:nvSpPr>
+        <p:spPr>
+          <a:xfrm>
+            <a:off x="5074920" y="3986784"/>
+            <a:ext cx="3520440" cy="219456"/>
+          </a:xfrm>
+          <a:prstGeom prst="rect">
+            <a:avLst/>
+          </a:prstGeom>
+          <a:noFill/>
+          <a:ln/>
+        </p:spPr>
+        <p:txBody>
+          <a:bodyPr wrap="square" lIns="0" tIns="0" rIns="0" bIns="0" rtlCol="0" anchor="ctr"/>
+          <a:lstStyle/>
+          <a:p>
+            <a:pPr indent="0" marL="0">
+              <a:buNone/>
+            </a:pPr>
+            <a:r>
+              <a:rPr lang="en-US" sz="1000" b="1" dirty="0">
+                <a:solidFill>
+                  <a:srgbClr val="5C6B7A"/>
+                </a:solidFill>
+                <a:latin typeface="Microsoft YaHei" pitchFamily="34" charset="0"/>
+                <a:ea typeface="Microsoft YaHei" pitchFamily="34" charset="-122"/>
+                <a:cs typeface="Microsoft YaHei" pitchFamily="34" charset="-120"/>
+              </a:rPr>
+              <a:t>不限时</a:t>
+            </a:r>
+            <a:endParaRPr lang="en-US" sz="1000" dirty="0"/>
+          </a:p>
+        </p:txBody>
+      </p:sp>
+      <p:sp>
+        <p:nvSpPr>
+          <p:cNvPr id="28" name="Shape 25"/>
+          <p:cNvSpPr/>
+          <p:nvPr/>
+        </p:nvSpPr>
+        <p:spPr>
+          <a:xfrm>
+            <a:off x="4023360" y="4370832"/>
+            <a:ext cx="4297680" cy="548640"/>
+          </a:xfrm>
+          <a:prstGeom prst="rect">
+            <a:avLst>
+              <a:gd name="adj" fmla="val 11667"/>
+            </a:avLst>
+          </a:prstGeom>
+          <a:solidFill>
+            <a:srgbClr val="023047"/>
+          </a:solidFill>
+          <a:ln/>
+        </p:spPr>
+      </p:sp>
+      <p:sp>
+        <p:nvSpPr>
+          <p:cNvPr id="29" name="Text 26"/>
+          <p:cNvSpPr/>
+          <p:nvPr/>
+        </p:nvSpPr>
+        <p:spPr>
+          <a:xfrm>
+            <a:off x="4187952" y="4370832"/>
+            <a:ext cx="4069080" cy="548640"/>
+          </a:xfrm>
+          <a:prstGeom prst="rect">
+            <a:avLst/>
+          </a:prstGeom>
+          <a:noFill/>
+          <a:ln/>
+        </p:spPr>
+        <p:txBody>
+          <a:bodyPr wrap="square" lIns="0" tIns="0" rIns="0" bIns="0" rtlCol="0" anchor="ctr"/>
+          <a:lstStyle/>
+          <a:p>
+            <a:pPr indent="0" marL="0">
+              <a:buNone/>
+            </a:pPr>
+            <a:r>
+              <a:rPr lang="en-US" sz="1000" dirty="0">
+                <a:solidFill>
+                  <a:srgbClr val="FFFFFF"/>
+                </a:solidFill>
+                <a:latin typeface="Microsoft YaHei" pitchFamily="34" charset="0"/>
+                <a:ea typeface="Microsoft YaHei" pitchFamily="34" charset="-122"/>
+                <a:cs typeface="Microsoft YaHei" pitchFamily="34" charset="-120"/>
+              </a:rPr>
+              <a:t>场地 220 x 120 cm, 半径 40 cm 半弧; 尺寸直接来自题图</a:t>
+            </a:r>
+            <a:endParaRPr lang="en-US" sz="1000" dirty="0"/>
+          </a:p>
+        </p:txBody>
+      </p:sp>
+      <p:sp>
+        <p:nvSpPr>
+          <p:cNvPr id="30" name="Shape 27"/>
+          <p:cNvSpPr/>
+          <p:nvPr/>
+        </p:nvSpPr>
+        <p:spPr>
+          <a:xfrm>
+            <a:off x="8503920" y="4663440"/>
+            <a:ext cx="384048" cy="274320"/>
+          </a:xfrm>
+          <a:prstGeom prst="rect">
+            <a:avLst>
+              <a:gd name="adj" fmla="val 16667"/>
+            </a:avLst>
+          </a:prstGeom>
+          <a:solidFill>
+            <a:srgbClr val="E8F1F5"/>
+          </a:solidFill>
+          <a:ln/>
+        </p:spPr>
+      </p:sp>
+      <p:sp>
+        <p:nvSpPr>
+          <p:cNvPr id="31" name="Text 28"/>
+          <p:cNvSpPr/>
+          <p:nvPr/>
+        </p:nvSpPr>
+        <p:spPr>
+          <a:xfrm>
+            <a:off x="8503920" y="4663440"/>
+            <a:ext cx="384048" cy="274320"/>
+          </a:xfrm>
+          <a:prstGeom prst="rect">
+            <a:avLst/>
+          </a:prstGeom>
+          <a:noFill/>
+          <a:ln/>
+        </p:spPr>
+        <p:txBody>
+          <a:bodyPr wrap="square" lIns="0" tIns="0" rIns="0" bIns="0" rtlCol="0" anchor="ctr"/>
+          <a:lstStyle/>
+          <a:p>
+            <a:pPr algn="ctr" indent="0" marL="0">
+              <a:buNone/>
+            </a:pPr>
+            <a:r>
+              <a:rPr lang="en-US" sz="1000" dirty="0">
+                <a:solidFill>
+                  <a:srgbClr val="5C6B7A"/>
+                </a:solidFill>
+                <a:latin typeface="Arial" pitchFamily="34" charset="0"/>
+                <a:ea typeface="Arial" pitchFamily="34" charset="-122"/>
+                <a:cs typeface="Arial" pitchFamily="34" charset="-120"/>
+              </a:rPr>
+              <a:t>08</a:t>
+            </a:r>
+            <a:endParaRPr lang="en-US" sz="1000" dirty="0"/>
+          </a:p>
+        </p:txBody>
+      </p:sp>
+    </p:spTree>
+  </p:cSld>
+  <p:clrMapOvr>
+    <a:masterClrMapping/>
+  </p:clrMapOvr>
+</p:sld>
+</file>
+
+<file path=ppt/slides/slide9.xml><?xml version="1.0" encoding="utf-8"?>
+<p:sld xmlns:a="http://schemas.openxmlformats.org/drawingml/2006/main" xmlns:r="http://schemas.openxmlformats.org/officeDocument/2006/relationships" xmlns:p="http://schemas.openxmlformats.org/presentationml/2006/main">
+  <p:cSld name="Slide 9">
+    <p:bg>
+      <p:bgPr>
+        <a:solidFill>
+          <a:srgbClr val="F7FAFC"/>
+        </a:solidFill>
+      </p:bgPr>
+    </p:bg>
+    <p:spTree>
+      <p:nvGrpSpPr>
+        <p:cNvPr id="1" name=""/>
+        <p:cNvGrpSpPr/>
+        <p:nvPr/>
+      </p:nvGrpSpPr>
+      <p:grpSpPr>
+        <a:xfrm>
+          <a:off x="0" y="0"/>
+          <a:ext cx="0" cy="0"/>
+          <a:chOff x="0" y="0"/>
+          <a:chExt cx="0" cy="0"/>
+        </a:xfrm>
+      </p:grpSpPr>
+      <p:sp>
+        <p:nvSpPr>
+          <p:cNvPr id="2" name="Text 0"/>
+          <p:cNvSpPr/>
+          <p:nvPr/>
+        </p:nvSpPr>
+        <p:spPr>
+          <a:xfrm>
             <a:off x="457200" y="365760"/>
             <a:ext cx="8229600" cy="502920"/>
           </a:xfrm>
@@ -12591,7 +14347,7 @@
       </p:sp>
       <p:graphicFrame>
         <p:nvGraphicFramePr>
-          <p:cNvPr id="9" name="Table 0"/>
+          <p:cNvPr id="10" name="Table 0"/>
           <p:cNvGraphicFramePr>
             <a:graphicFrameLocks noGrp="1"/>
           </p:cNvGraphicFramePr>
@@ -14526,674 +16282,6 @@
                 <a:ea typeface="Arial" pitchFamily="34" charset="-122"/>
                 <a:cs typeface="Arial" pitchFamily="34" charset="-120"/>
               </a:rPr>
-              <a:t>08</a:t>
-            </a:r>
-            <a:endParaRPr lang="en-US" sz="1000" dirty="0"/>
-          </a:p>
-        </p:txBody>
-      </p:sp>
-    </p:spTree>
-  </p:cSld>
-  <p:clrMapOvr>
-    <a:masterClrMapping/>
-  </p:clrMapOvr>
-</p:sld>
-</file>
-
-<file path=ppt/slides/slide9.xml><?xml version="1.0" encoding="utf-8"?>
-<p:sld xmlns:a="http://schemas.openxmlformats.org/drawingml/2006/main" xmlns:r="http://schemas.openxmlformats.org/officeDocument/2006/relationships" xmlns:p="http://schemas.openxmlformats.org/presentationml/2006/main">
-  <p:cSld name="Slide 9">
-    <p:bg>
-      <p:bgPr>
-        <a:solidFill>
-          <a:srgbClr val="F7FAFC"/>
-        </a:solidFill>
-      </p:bgPr>
-    </p:bg>
-    <p:spTree>
-      <p:nvGrpSpPr>
-        <p:cNvPr id="1" name=""/>
-        <p:cNvGrpSpPr/>
-        <p:nvPr/>
-      </p:nvGrpSpPr>
-      <p:grpSpPr>
-        <a:xfrm>
-          <a:off x="0" y="0"/>
-          <a:ext cx="0" cy="0"/>
-          <a:chOff x="0" y="0"/>
-          <a:chExt cx="0" cy="0"/>
-        </a:xfrm>
-      </p:grpSpPr>
-      <p:sp>
-        <p:nvSpPr>
-          <p:cNvPr id="2" name="Text 0"/>
-          <p:cNvSpPr/>
-          <p:nvPr/>
-        </p:nvSpPr>
-        <p:spPr>
-          <a:xfrm>
-            <a:off x="457200" y="365760"/>
-            <a:ext cx="5486400" cy="457200"/>
-          </a:xfrm>
-          <a:prstGeom prst="rect">
-            <a:avLst/>
-          </a:prstGeom>
-          <a:noFill/>
-          <a:ln/>
-        </p:spPr>
-        <p:txBody>
-          <a:bodyPr wrap="square" lIns="0" tIns="0" rIns="0" bIns="0" rtlCol="0" anchor="ctr"/>
-          <a:lstStyle/>
-          <a:p>
-            <a:pPr indent="0" marL="0">
-              <a:buNone/>
-            </a:pPr>
-            <a:r>
-              <a:rPr lang="en-US" sz="2800" b="1" dirty="0">
-                <a:solidFill>
-                  <a:srgbClr val="023047"/>
-                </a:solidFill>
-                <a:latin typeface="Microsoft YaHei" pitchFamily="34" charset="0"/>
-                <a:ea typeface="Microsoft YaHei" pitchFamily="34" charset="-122"/>
-                <a:cs typeface="Microsoft YaHei" pitchFamily="34" charset="-120"/>
-              </a:rPr>
-              <a:t>3D 浏览器查看器</a:t>
-            </a:r>
-            <a:endParaRPr lang="en-US" sz="2800" dirty="0"/>
-          </a:p>
-        </p:txBody>
-      </p:sp>
-      <p:sp>
-        <p:nvSpPr>
-          <p:cNvPr id="3" name="Text 1"/>
-          <p:cNvSpPr/>
-          <p:nvPr/>
-        </p:nvSpPr>
-        <p:spPr>
-          <a:xfrm>
-            <a:off x="457200" y="822960"/>
-            <a:ext cx="5486400" cy="274320"/>
-          </a:xfrm>
-          <a:prstGeom prst="rect">
-            <a:avLst/>
-          </a:prstGeom>
-          <a:noFill/>
-          <a:ln/>
-        </p:spPr>
-        <p:txBody>
-          <a:bodyPr wrap="square" lIns="0" tIns="0" rIns="0" bIns="0" rtlCol="0" anchor="ctr"/>
-          <a:lstStyle/>
-          <a:p>
-            <a:pPr indent="0" marL="0">
-              <a:buNone/>
-            </a:pPr>
-            <a:r>
-              <a:rPr lang="en-US" sz="1200" dirty="0">
-                <a:solidFill>
-                  <a:srgbClr val="5C6B7A"/>
-                </a:solidFill>
-                <a:latin typeface="Microsoft YaHei" pitchFamily="34" charset="0"/>
-                <a:ea typeface="Microsoft YaHei" pitchFamily="34" charset="-122"/>
-                <a:cs typeface="Microsoft YaHei" pitchFamily="34" charset="-120"/>
-              </a:rPr>
-              <a:t>three.js 实时渲染, 30Hz 状态帧, 一条命令拉起</a:t>
-            </a:r>
-            <a:endParaRPr lang="en-US" sz="1200" dirty="0"/>
-          </a:p>
-        </p:txBody>
-      </p:sp>
-      <p:pic>
-        <p:nvPicPr>
-          <p:cNvPr id="4" name="Image 0" descr="3D twin viewer: task 1 graded">    </p:cNvPr>
-          <p:cNvPicPr>
-            <a:picLocks noChangeAspect="1"/>
-          </p:cNvPicPr>
-          <p:nvPr/>
-        </p:nvPicPr>
-        <p:blipFill>
-          <a:blip r:embed="rId1"/>
-          <a:stretch>
-            <a:fillRect/>
-          </a:stretch>
-        </p:blipFill>
-        <p:spPr>
-          <a:xfrm>
-            <a:off x="457200" y="1143000"/>
-            <a:ext cx="5440680" cy="3063240"/>
-          </a:xfrm>
-          <a:prstGeom prst="rect">
-            <a:avLst/>
-          </a:prstGeom>
-        </p:spPr>
-      </p:pic>
-      <p:sp>
-        <p:nvSpPr>
-          <p:cNvPr id="5" name="Shape 2"/>
-          <p:cNvSpPr/>
-          <p:nvPr/>
-        </p:nvSpPr>
-        <p:spPr>
-          <a:xfrm>
-            <a:off x="457200" y="1143000"/>
-            <a:ext cx="5440680" cy="3063240"/>
-          </a:xfrm>
-          <a:prstGeom prst="rect">
-            <a:avLst/>
-          </a:prstGeom>
-          <a:solidFill>
-            <a:srgbClr val="FFFFFF">
-              <a:alpha val="0"/>
-            </a:srgbClr>
-          </a:solidFill>
-          <a:ln w="9525">
-            <a:solidFill>
-              <a:srgbClr val="5C6B7A"/>
-            </a:solidFill>
-            <a:prstDash val="solid"/>
-          </a:ln>
-        </p:spPr>
-      </p:sp>
-      <p:pic>
-        <p:nvPicPr>
-          <p:cNvPr id="6" name="Image 1" descr="8-channel line sensor array close-up">    </p:cNvPr>
-          <p:cNvPicPr>
-            <a:picLocks noChangeAspect="1"/>
-          </p:cNvPicPr>
-          <p:nvPr/>
-        </p:nvPicPr>
-        <p:blipFill>
-          <a:blip r:embed="rId2"/>
-          <a:stretch>
-            <a:fillRect/>
-          </a:stretch>
-        </p:blipFill>
-        <p:spPr>
-          <a:xfrm>
-            <a:off x="6035040" y="1143000"/>
-            <a:ext cx="1371600" cy="2743200"/>
-          </a:xfrm>
-          <a:prstGeom prst="rect">
-            <a:avLst/>
-          </a:prstGeom>
-        </p:spPr>
-      </p:pic>
-      <p:sp>
-        <p:nvSpPr>
-          <p:cNvPr id="7" name="Shape 3"/>
-          <p:cNvSpPr/>
-          <p:nvPr/>
-        </p:nvSpPr>
-        <p:spPr>
-          <a:xfrm>
-            <a:off x="6035040" y="1143000"/>
-            <a:ext cx="1371600" cy="2743200"/>
-          </a:xfrm>
-          <a:prstGeom prst="rect">
-            <a:avLst/>
-          </a:prstGeom>
-          <a:solidFill>
-            <a:srgbClr val="FFFFFF">
-              <a:alpha val="0"/>
-            </a:srgbClr>
-          </a:solidFill>
-          <a:ln w="9525">
-            <a:solidFill>
-              <a:srgbClr val="5C6B7A"/>
-            </a:solidFill>
-            <a:prstDash val="solid"/>
-          </a:ln>
-        </p:spPr>
-      </p:sp>
-      <p:sp>
-        <p:nvSpPr>
-          <p:cNvPr id="8" name="Shape 4"/>
-          <p:cNvSpPr/>
-          <p:nvPr/>
-        </p:nvSpPr>
-        <p:spPr>
-          <a:xfrm>
-            <a:off x="7543800" y="1143000"/>
-            <a:ext cx="1143000" cy="2743200"/>
-          </a:xfrm>
-          <a:prstGeom prst="rect">
-            <a:avLst>
-              <a:gd name="adj" fmla="val 6400"/>
-            </a:avLst>
-          </a:prstGeom>
-          <a:solidFill>
-            <a:srgbClr val="E8F1F5"/>
-          </a:solidFill>
-          <a:ln/>
-        </p:spPr>
-      </p:sp>
-      <p:sp>
-        <p:nvSpPr>
-          <p:cNvPr id="9" name="Text 5"/>
-          <p:cNvSpPr/>
-          <p:nvPr/>
-        </p:nvSpPr>
-        <p:spPr>
-          <a:xfrm>
-            <a:off x="7635240" y="1280160"/>
-            <a:ext cx="960120" cy="256032"/>
-          </a:xfrm>
-          <a:prstGeom prst="rect">
-            <a:avLst/>
-          </a:prstGeom>
-          <a:noFill/>
-          <a:ln/>
-        </p:spPr>
-        <p:txBody>
-          <a:bodyPr wrap="square" lIns="0" tIns="0" rIns="0" bIns="0" rtlCol="0" anchor="ctr"/>
-          <a:lstStyle/>
-          <a:p>
-            <a:pPr indent="0" marL="0">
-              <a:buNone/>
-            </a:pPr>
-            <a:r>
-              <a:rPr lang="en-US" sz="1000" b="1" dirty="0">
-                <a:solidFill>
-                  <a:srgbClr val="023047"/>
-                </a:solidFill>
-                <a:latin typeface="Microsoft YaHei" pitchFamily="34" charset="0"/>
-                <a:ea typeface="Microsoft YaHei" pitchFamily="34" charset="-122"/>
-                <a:cs typeface="Microsoft YaHei" pitchFamily="34" charset="-120"/>
-              </a:rPr>
-              <a:t>画面可读信息</a:t>
-            </a:r>
-            <a:endParaRPr lang="en-US" sz="1000" dirty="0"/>
-          </a:p>
-        </p:txBody>
-      </p:sp>
-      <p:sp>
-        <p:nvSpPr>
-          <p:cNvPr id="10" name="Text 6"/>
-          <p:cNvSpPr/>
-          <p:nvPr/>
-        </p:nvSpPr>
-        <p:spPr>
-          <a:xfrm>
-            <a:off x="7635240" y="1627632"/>
-            <a:ext cx="1005840" cy="274320"/>
-          </a:xfrm>
-          <a:prstGeom prst="rect">
-            <a:avLst/>
-          </a:prstGeom>
-          <a:noFill/>
-          <a:ln/>
-        </p:spPr>
-        <p:txBody>
-          <a:bodyPr wrap="square" lIns="0" tIns="0" rIns="0" bIns="0" rtlCol="0" anchor="ctr"/>
-          <a:lstStyle/>
-          <a:p>
-            <a:pPr indent="0" marL="0">
-              <a:buNone/>
-            </a:pPr>
-            <a:r>
-              <a:rPr lang="en-US" sz="850" dirty="0">
-                <a:solidFill>
-                  <a:srgbClr val="5C6B7A"/>
-                </a:solidFill>
-                <a:latin typeface="Microsoft YaHei" pitchFamily="34" charset="0"/>
-                <a:ea typeface="Microsoft YaHei" pitchFamily="34" charset="-122"/>
-                <a:cs typeface="Microsoft YaHei" pitchFamily="34" charset="-120"/>
-              </a:rPr>
-              <a:t>- 实时姿态</a:t>
-            </a:r>
-            <a:endParaRPr lang="en-US" sz="850" dirty="0"/>
-          </a:p>
-        </p:txBody>
-      </p:sp>
-      <p:sp>
-        <p:nvSpPr>
-          <p:cNvPr id="11" name="Text 7"/>
-          <p:cNvSpPr/>
-          <p:nvPr/>
-        </p:nvSpPr>
-        <p:spPr>
-          <a:xfrm>
-            <a:off x="7635240" y="1929384"/>
-            <a:ext cx="1005840" cy="274320"/>
-          </a:xfrm>
-          <a:prstGeom prst="rect">
-            <a:avLst/>
-          </a:prstGeom>
-          <a:noFill/>
-          <a:ln/>
-        </p:spPr>
-        <p:txBody>
-          <a:bodyPr wrap="square" lIns="0" tIns="0" rIns="0" bIns="0" rtlCol="0" anchor="ctr"/>
-          <a:lstStyle/>
-          <a:p>
-            <a:pPr indent="0" marL="0">
-              <a:buNone/>
-            </a:pPr>
-            <a:r>
-              <a:rPr lang="en-US" sz="850" dirty="0">
-                <a:solidFill>
-                  <a:srgbClr val="5C6B7A"/>
-                </a:solidFill>
-                <a:latin typeface="Microsoft YaHei" pitchFamily="34" charset="0"/>
-                <a:ea typeface="Microsoft YaHei" pitchFamily="34" charset="-122"/>
-                <a:cs typeface="Microsoft YaHei" pitchFamily="34" charset="-120"/>
-              </a:rPr>
-              <a:t>- Tilt / Pos</a:t>
-            </a:r>
-            <a:endParaRPr lang="en-US" sz="850" dirty="0"/>
-          </a:p>
-        </p:txBody>
-      </p:sp>
-      <p:sp>
-        <p:nvSpPr>
-          <p:cNvPr id="12" name="Text 8"/>
-          <p:cNvSpPr/>
-          <p:nvPr/>
-        </p:nvSpPr>
-        <p:spPr>
-          <a:xfrm>
-            <a:off x="7635240" y="2231136"/>
-            <a:ext cx="1005840" cy="274320"/>
-          </a:xfrm>
-          <a:prstGeom prst="rect">
-            <a:avLst/>
-          </a:prstGeom>
-          <a:noFill/>
-          <a:ln/>
-        </p:spPr>
-        <p:txBody>
-          <a:bodyPr wrap="square" lIns="0" tIns="0" rIns="0" bIns="0" rtlCol="0" anchor="ctr"/>
-          <a:lstStyle/>
-          <a:p>
-            <a:pPr indent="0" marL="0">
-              <a:buNone/>
-            </a:pPr>
-            <a:r>
-              <a:rPr lang="en-US" sz="850" dirty="0">
-                <a:solidFill>
-                  <a:srgbClr val="5C6B7A"/>
-                </a:solidFill>
-                <a:latin typeface="Microsoft YaHei" pitchFamily="34" charset="0"/>
-                <a:ea typeface="Microsoft YaHei" pitchFamily="34" charset="-122"/>
-                <a:cs typeface="Microsoft YaHei" pitchFamily="34" charset="-120"/>
-              </a:rPr>
-              <a:t>- Duty 占空比</a:t>
-            </a:r>
-            <a:endParaRPr lang="en-US" sz="850" dirty="0"/>
-          </a:p>
-        </p:txBody>
-      </p:sp>
-      <p:sp>
-        <p:nvSpPr>
-          <p:cNvPr id="13" name="Text 9"/>
-          <p:cNvSpPr/>
-          <p:nvPr/>
-        </p:nvSpPr>
-        <p:spPr>
-          <a:xfrm>
-            <a:off x="7635240" y="2532888"/>
-            <a:ext cx="1005840" cy="274320"/>
-          </a:xfrm>
-          <a:prstGeom prst="rect">
-            <a:avLst/>
-          </a:prstGeom>
-          <a:noFill/>
-          <a:ln/>
-        </p:spPr>
-        <p:txBody>
-          <a:bodyPr wrap="square" lIns="0" tIns="0" rIns="0" bIns="0" rtlCol="0" anchor="ctr"/>
-          <a:lstStyle/>
-          <a:p>
-            <a:pPr indent="0" marL="0">
-              <a:buNone/>
-            </a:pPr>
-            <a:r>
-              <a:rPr lang="en-US" sz="850" dirty="0">
-                <a:solidFill>
-                  <a:srgbClr val="5C6B7A"/>
-                </a:solidFill>
-                <a:latin typeface="Microsoft YaHei" pitchFamily="34" charset="0"/>
-                <a:ea typeface="Microsoft YaHei" pitchFamily="34" charset="-122"/>
-                <a:cs typeface="Microsoft YaHei" pitchFamily="34" charset="-120"/>
-              </a:rPr>
-              <a:t>- Enc 编码器</a:t>
-            </a:r>
-            <a:endParaRPr lang="en-US" sz="850" dirty="0"/>
-          </a:p>
-        </p:txBody>
-      </p:sp>
-      <p:sp>
-        <p:nvSpPr>
-          <p:cNvPr id="14" name="Text 10"/>
-          <p:cNvSpPr/>
-          <p:nvPr/>
-        </p:nvSpPr>
-        <p:spPr>
-          <a:xfrm>
-            <a:off x="7635240" y="2834640"/>
-            <a:ext cx="1005840" cy="274320"/>
-          </a:xfrm>
-          <a:prstGeom prst="rect">
-            <a:avLst/>
-          </a:prstGeom>
-          <a:noFill/>
-          <a:ln/>
-        </p:spPr>
-        <p:txBody>
-          <a:bodyPr wrap="square" lIns="0" tIns="0" rIns="0" bIns="0" rtlCol="0" anchor="ctr"/>
-          <a:lstStyle/>
-          <a:p>
-            <a:pPr indent="0" marL="0">
-              <a:buNone/>
-            </a:pPr>
-            <a:r>
-              <a:rPr lang="en-US" sz="850" dirty="0">
-                <a:solidFill>
-                  <a:srgbClr val="5C6B7A"/>
-                </a:solidFill>
-                <a:latin typeface="Microsoft YaHei" pitchFamily="34" charset="0"/>
-                <a:ea typeface="Microsoft YaHei" pitchFamily="34" charset="-122"/>
-                <a:cs typeface="Microsoft YaHei" pitchFamily="34" charset="-120"/>
-              </a:rPr>
-              <a:t>- 电池电压</a:t>
-            </a:r>
-            <a:endParaRPr lang="en-US" sz="850" dirty="0"/>
-          </a:p>
-        </p:txBody>
-      </p:sp>
-      <p:sp>
-        <p:nvSpPr>
-          <p:cNvPr id="15" name="Text 11"/>
-          <p:cNvSpPr/>
-          <p:nvPr/>
-        </p:nvSpPr>
-        <p:spPr>
-          <a:xfrm>
-            <a:off x="7635240" y="3136392"/>
-            <a:ext cx="1005840" cy="274320"/>
-          </a:xfrm>
-          <a:prstGeom prst="rect">
-            <a:avLst/>
-          </a:prstGeom>
-          <a:noFill/>
-          <a:ln/>
-        </p:spPr>
-        <p:txBody>
-          <a:bodyPr wrap="square" lIns="0" tIns="0" rIns="0" bIns="0" rtlCol="0" anchor="ctr"/>
-          <a:lstStyle/>
-          <a:p>
-            <a:pPr indent="0" marL="0">
-              <a:buNone/>
-            </a:pPr>
-            <a:r>
-              <a:rPr lang="en-US" sz="850" dirty="0">
-                <a:solidFill>
-                  <a:srgbClr val="5C6B7A"/>
-                </a:solidFill>
-                <a:latin typeface="Microsoft YaHei" pitchFamily="34" charset="0"/>
-                <a:ea typeface="Microsoft YaHei" pitchFamily="34" charset="-122"/>
-                <a:cs typeface="Microsoft YaHei" pitchFamily="34" charset="-120"/>
-              </a:rPr>
-              <a:t>- 8 通道循迹读数</a:t>
-            </a:r>
-            <a:endParaRPr lang="en-US" sz="850" dirty="0"/>
-          </a:p>
-        </p:txBody>
-      </p:sp>
-      <p:sp>
-        <p:nvSpPr>
-          <p:cNvPr id="16" name="Text 12"/>
-          <p:cNvSpPr/>
-          <p:nvPr/>
-        </p:nvSpPr>
-        <p:spPr>
-          <a:xfrm>
-            <a:off x="7635240" y="3438144"/>
-            <a:ext cx="1005840" cy="274320"/>
-          </a:xfrm>
-          <a:prstGeom prst="rect">
-            <a:avLst/>
-          </a:prstGeom>
-          <a:noFill/>
-          <a:ln/>
-        </p:spPr>
-        <p:txBody>
-          <a:bodyPr wrap="square" lIns="0" tIns="0" rIns="0" bIns="0" rtlCol="0" anchor="ctr"/>
-          <a:lstStyle/>
-          <a:p>
-            <a:pPr indent="0" marL="0">
-              <a:buNone/>
-            </a:pPr>
-            <a:r>
-              <a:rPr lang="en-US" sz="850" dirty="0">
-                <a:solidFill>
-                  <a:srgbClr val="5C6B7A"/>
-                </a:solidFill>
-                <a:latin typeface="Microsoft YaHei" pitchFamily="34" charset="0"/>
-                <a:ea typeface="Microsoft YaHei" pitchFamily="34" charset="-122"/>
-                <a:cs typeface="Microsoft YaHei" pitchFamily="34" charset="-120"/>
-              </a:rPr>
-              <a:t>- 停车判定</a:t>
-            </a:r>
-            <a:endParaRPr lang="en-US" sz="850" dirty="0"/>
-          </a:p>
-        </p:txBody>
-      </p:sp>
-      <p:sp>
-        <p:nvSpPr>
-          <p:cNvPr id="17" name="Shape 13"/>
-          <p:cNvSpPr/>
-          <p:nvPr/>
-        </p:nvSpPr>
-        <p:spPr>
-          <a:xfrm>
-            <a:off x="457200" y="4315968"/>
-            <a:ext cx="7863840" cy="502920"/>
-          </a:xfrm>
-          <a:prstGeom prst="rect">
-            <a:avLst>
-              <a:gd name="adj" fmla="val 12727"/>
-            </a:avLst>
-          </a:prstGeom>
-          <a:solidFill>
-            <a:srgbClr val="023047"/>
-          </a:solidFill>
-          <a:ln/>
-        </p:spPr>
-      </p:sp>
-      <p:sp>
-        <p:nvSpPr>
-          <p:cNvPr id="18" name="Text 14"/>
-          <p:cNvSpPr/>
-          <p:nvPr/>
-        </p:nvSpPr>
-        <p:spPr>
-          <a:xfrm>
-            <a:off x="658368" y="4315968"/>
-            <a:ext cx="7498080" cy="502920"/>
-          </a:xfrm>
-          <a:prstGeom prst="rect">
-            <a:avLst/>
-          </a:prstGeom>
-          <a:noFill/>
-          <a:ln/>
-        </p:spPr>
-        <p:txBody>
-          <a:bodyPr wrap="square" lIns="0" tIns="0" rIns="0" bIns="0" rtlCol="0" anchor="ctr"/>
-          <a:lstStyle/>
-          <a:p>
-            <a:pPr indent="0" marL="0">
-              <a:buNone/>
-            </a:pPr>
-            <a:r>
-              <a:rPr lang="en-US" sz="1100" dirty="0">
-                <a:solidFill>
-                  <a:srgbClr val="FFFFFF"/>
-                </a:solidFill>
-                <a:latin typeface="Microsoft YaHei" pitchFamily="34" charset="0"/>
-                <a:ea typeface="Microsoft YaHei" pitchFamily="34" charset="-122"/>
-                <a:cs typeface="Microsoft YaHei" pitchFamily="34" charset="-120"/>
-              </a:rPr>
-              <a:t>bash tools/demo.sh   -&gt;   http://localhost:5173/?ws=ws://127.0.0.1:8766   (四任务一键切换, 四档回放倍速)</a:t>
-            </a:r>
-            <a:endParaRPr lang="en-US" sz="1100" dirty="0"/>
-          </a:p>
-        </p:txBody>
-      </p:sp>
-      <p:sp>
-        <p:nvSpPr>
-          <p:cNvPr id="19" name="Shape 15"/>
-          <p:cNvSpPr/>
-          <p:nvPr/>
-        </p:nvSpPr>
-        <p:spPr>
-          <a:xfrm>
-            <a:off x="8503920" y="4663440"/>
-            <a:ext cx="384048" cy="274320"/>
-          </a:xfrm>
-          <a:prstGeom prst="rect">
-            <a:avLst>
-              <a:gd name="adj" fmla="val 16667"/>
-            </a:avLst>
-          </a:prstGeom>
-          <a:solidFill>
-            <a:srgbClr val="E8F1F5"/>
-          </a:solidFill>
-          <a:ln/>
-        </p:spPr>
-      </p:sp>
-      <p:sp>
-        <p:nvSpPr>
-          <p:cNvPr id="20" name="Text 16"/>
-          <p:cNvSpPr/>
-          <p:nvPr/>
-        </p:nvSpPr>
-        <p:spPr>
-          <a:xfrm>
-            <a:off x="8503920" y="4663440"/>
-            <a:ext cx="384048" cy="274320"/>
-          </a:xfrm>
-          <a:prstGeom prst="rect">
-            <a:avLst/>
-          </a:prstGeom>
-          <a:noFill/>
-          <a:ln/>
-        </p:spPr>
-        <p:txBody>
-          <a:bodyPr wrap="square" lIns="0" tIns="0" rIns="0" bIns="0" rtlCol="0" anchor="ctr"/>
-          <a:lstStyle/>
-          <a:p>
-            <a:pPr algn="ctr" indent="0" marL="0">
-              <a:buNone/>
-            </a:pPr>
-            <a:r>
-              <a:rPr lang="en-US" sz="1000" dirty="0">
-                <a:solidFill>
-                  <a:srgbClr val="5C6B7A"/>
-                </a:solidFill>
-                <a:latin typeface="Arial" pitchFamily="34" charset="0"/>
-                <a:ea typeface="Arial" pitchFamily="34" charset="-122"/>
-                <a:cs typeface="Arial" pitchFamily="34" charset="-120"/>
-              </a:rPr>
               <a:t>09</a:t>
             </a:r>
             <a:endParaRPr lang="en-US" sz="1000" dirty="0"/>

</xml_diff>

<commit_message>
defense: use the measured numbers - 218 passed / 9 skipped / 0 failed
</commit_message>
<xml_diff>
--- a/docs/mujoco-renode-twin-defense.pptx
+++ b/docs/mujoco-renode-twin-defense.pptx
@@ -3960,7 +3960,7 @@
                 <a:ea typeface="Arial" pitchFamily="34" charset="-122"/>
                 <a:cs typeface="Arial" pitchFamily="34" charset="-120"/>
               </a:rPr>
-              <a:t>236</a:t>
+              <a:t>227</a:t>
             </a:r>
             <a:endParaRPr lang="en-US" sz="2600" dirty="0"/>
           </a:p>
@@ -4221,7 +4221,7 @@
                 <a:ea typeface="Arial" pitchFamily="34" charset="-122"/>
                 <a:cs typeface="Arial" pitchFamily="34" charset="-120"/>
               </a:rPr>
-              <a:t>227</a:t>
+              <a:t>218</a:t>
             </a:r>
             <a:endParaRPr lang="en-US" sz="1100" dirty="0"/>
           </a:p>
@@ -4527,7 +4527,7 @@
                 <a:ea typeface="Microsoft YaHei" pitchFamily="34" charset="-122"/>
                 <a:cs typeface="Microsoft YaHei" pitchFamily="34" charset="-120"/>
               </a:rPr>
-              <a:t>零失败 · 227 项通过</a:t>
+              <a:t>零失败 · 218 项通过</a:t>
             </a:r>
             <a:endParaRPr lang="en-US" sz="1200" dirty="0"/>
           </a:p>
@@ -4566,7 +4566,7 @@
                 <a:ea typeface="Microsoft YaHei" pitchFamily="34" charset="-122"/>
                 <a:cs typeface="Microsoft YaHei" pitchFamily="34" charset="-120"/>
               </a:rPr>
-              <a:t>pytest 收集 236 例(含 subtests 展开); 9 项跳过为可选外部依赖(GrabCAD 登录下载等)</a:t>
+              <a:t>pytest 收集 227 例(另含 45 个 subtests); 9 项跳过为可选外部依赖(GrabCAD 登录下载等)</a:t>
             </a:r>
             <a:endParaRPr lang="en-US" sz="850" dirty="0"/>
           </a:p>

</xml_diff>

<commit_message>
defense: measured numbers after the per-gate vendor fix - 221 passed / 6 skipped / 0 failed
</commit_message>
<xml_diff>
--- a/docs/mujoco-renode-twin-defense.pptx
+++ b/docs/mujoco-renode-twin-defense.pptx
@@ -4175,7 +4175,7 @@
         <p:spPr>
           <a:xfrm>
             <a:off x="5120640" y="1929384"/>
-            <a:ext cx="3163824" cy="164592"/>
+            <a:ext cx="3200400" cy="164592"/>
           </a:xfrm>
           <a:prstGeom prst="rect">
             <a:avLst>
@@ -4221,7 +4221,7 @@
                 <a:ea typeface="Arial" pitchFamily="34" charset="-122"/>
                 <a:cs typeface="Arial" pitchFamily="34" charset="-120"/>
               </a:rPr>
-              <a:t>218</a:t>
+              <a:t>221</a:t>
             </a:r>
             <a:endParaRPr lang="en-US" sz="1100" dirty="0"/>
           </a:p>
@@ -4297,11 +4297,11 @@
         <p:spPr>
           <a:xfrm>
             <a:off x="5120640" y="2496312"/>
-            <a:ext cx="128016" cy="164592"/>
+            <a:ext cx="86868" cy="164592"/>
           </a:xfrm>
           <a:prstGeom prst="rect">
             <a:avLst>
-              <a:gd name="adj" fmla="val 21429"/>
+              <a:gd name="adj" fmla="val 31579"/>
             </a:avLst>
           </a:prstGeom>
           <a:solidFill>
@@ -4343,7 +4343,7 @@
                 <a:ea typeface="Arial" pitchFamily="34" charset="-122"/>
                 <a:cs typeface="Arial" pitchFamily="34" charset="-120"/>
               </a:rPr>
-              <a:t>9</a:t>
+              <a:t>6</a:t>
             </a:r>
             <a:endParaRPr lang="en-US" sz="1100" dirty="0"/>
           </a:p>
@@ -4527,7 +4527,7 @@
                 <a:ea typeface="Microsoft YaHei" pitchFamily="34" charset="-122"/>
                 <a:cs typeface="Microsoft YaHei" pitchFamily="34" charset="-120"/>
               </a:rPr>
-              <a:t>零失败 · 218 项通过</a:t>
+              <a:t>零失败 · 221 项通过</a:t>
             </a:r>
             <a:endParaRPr lang="en-US" sz="1200" dirty="0"/>
           </a:p>
@@ -4566,7 +4566,7 @@
                 <a:ea typeface="Microsoft YaHei" pitchFamily="34" charset="-122"/>
                 <a:cs typeface="Microsoft YaHei" pitchFamily="34" charset="-120"/>
               </a:rPr>
-              <a:t>pytest 收集 227 例(另含 45 个 subtests); 9 项跳过为可选外部依赖(GrabCAD 登录下载等)</a:t>
+              <a:t>pytest 收集 227 例(另含 45 个 subtests); 6 项跳过为可选外部依赖(GrabCAD 电机模型, 需登录下载)</a:t>
             </a:r>
             <a:endParaRPr lang="en-US" sz="850" dirty="0"/>
           </a:p>

</xml_diff>

<commit_message>
docs: point the clone instructions and the deck at this repository
The upstream rim5432/mujoco-renode-twin is read-only for this account and
still lacks everything added since 5582e17c. LICENSE keeps the original
copyright line -- only the addresses moved.
</commit_message>
<xml_diff>
--- a/docs/mujoco-renode-twin-defense.pptx
+++ b/docs/mujoco-renode-twin-defense.pptx
@@ -2696,7 +2696,7 @@
                 <a:ea typeface="Arial" pitchFamily="34" charset="-122"/>
                 <a:cs typeface="Arial" pitchFamily="34" charset="-120"/>
               </a:rPr>
-              <a:t>github.com/rim5432/mujoco-renode-twin   |   MIT License</a:t>
+              <a:t>github.com/superfansizhe-beep/mujoco-renode-twin   |   MIT License</a:t>
             </a:r>
             <a:endParaRPr lang="en-US" sz="1100" dirty="0"/>
           </a:p>
@@ -5498,7 +5498,7 @@
                 <a:ea typeface="Arial" pitchFamily="34" charset="-122"/>
                 <a:cs typeface="Arial" pitchFamily="34" charset="-120"/>
               </a:rPr>
-              <a:t>github.com/rim5432/mujoco-renode-twin</a:t>
+              <a:t>github.com/superfansizhe-beep/mujoco-renode-twin</a:t>
             </a:r>
             <a:endParaRPr lang="en-US" sz="1100" dirty="0"/>
           </a:p>

</xml_diff>